<commit_message>
Restore original Projet 11 presentation with speaker notes added, split Omar/Iliass presenters
</commit_message>
<xml_diff>
--- a/output/Presentation_Cache_Redis.pptx
+++ b/output/Presentation_Cache_Redis.pptx
@@ -521,7 +521,7 @@
           <a:p>
             <a:r>
               <a:rPr lang="en-US" dirty="0"/>
-              <a:t>Bonjour, je suis Omar Sarsar et je suis accompagné d'Iliass Hariz. Nous allons présenter notre projet d'intégration d'un cache distribué Redis dans une application marketplace SaaS. Ce projet a été réalisé dans le cadre de notre formation à HEEC Marrakech. Nous allons d'abord décrire le contexte et la problématique, puis présenter l'architecture du cache distribué, l'implémentation technique avec le code source, les tests et validations effectués, et enfin les résultats obtenus avec les mesures de performance.</a:t>
+              <a:t>Bonjour, je suis Omar Sarsar. Avec Iliass Hariz, nous présentons notre projet d'intégration d'un cache distribué Redis dans une marketplace SaaS. Nous allons couvrir le contexte, l'architecture Cache-Aside, l'implémentation technique, les tests et les résultats. Cette solution vise à résoudre les problèmes de performance de notre application web.</a:t>
             </a:r>
             <a:endParaRPr lang="en-US" dirty="0"/>
           </a:p>
@@ -609,7 +609,7 @@
           <a:p>
             <a:r>
               <a:rPr lang="en-US" dirty="0"/>
-              <a:t>L'invalidation est essentielle pour la cohérence. Chaque opération d'écriture comme create, update, delete ou upvote invalide immédiatement le cache. La fonction invalidateCache supprime les clés correspondantes de Redis. Le TTL sert de mécanisme d'expiration automatique. Les clés utilisent le préfixe saas: pour éviter les collisions.</a:t>
+              <a:t>L'invalidation garantit la cohérence des données. Chaque opération d'écriture comme create, update, delete ou upvote déclenche immédiatement invalidateCache pour supprimer les clés concernées de Redis. Le TTL complète ce mécanisme par une expiration automatique. Le préfixe saas: sur les clés évite toute collision avec d'autres applications.</a:t>
             </a:r>
             <a:endParaRPr lang="en-US" dirty="0"/>
           </a:p>
@@ -697,7 +697,7 @@
           <a:p>
             <a:r>
               <a:rPr lang="en-US" dirty="0"/>
-              <a:t>Transition : Iliass Hariz prend la suite. Nous avons mis en place des tests unitaires avec Jest couvrant cacheSet, cacheGet et invalidateCache. Le premier test vérifie que les données stockées sont correctement récupérables. Le second test vérifie que l'invalidation supprime la clé. Les tests s'exécutent avec une instance Redis locale dans Docker.</a:t>
+              <a:t>Transition : Iliass Hariz prend la suite. Merci Omar. Je vais maintenant présenter les tests unitaires que nous avons mis en place pour valider notre implémentation de cache. Ces tests couvrent les fonctions cacheSet, cacheGet et invalidateCache avec Jest et une instance Redis locale. Vérifions ensemble que notre solution est robuste et fiable.</a:t>
             </a:r>
             <a:endParaRPr lang="en-US" dirty="0"/>
           </a:p>
@@ -785,7 +785,7 @@
           <a:p>
             <a:r>
               <a:rPr lang="en-US" dirty="0"/>
-              <a:t>Les résultats sont très satisfaisants : les huit tests passent tous avec succès. Ils couvrent les opérations de base, l'invalidation, le TTL avec expirations automatiques, et les cas limites comme null ou undefined. Cette couverture complète nous donne confiance dans la fiabilité du cache.</a:t>
+              <a:t>Les résultats des tests sont excellents. Les huit tests passent avec succès, couvrant les opérations de base, l'invalidation, le TTL avec expirations automatiques, et les cas limites comme null ou undefined. Cette couverture complète nous assure que le cache fonctionne correctement dans toutes les situations. Les tests s'intègrent dans notre pipeline CI pour validation continue.</a:t>
             </a:r>
             <a:endParaRPr lang="en-US" dirty="0"/>
           </a:p>
@@ -873,7 +873,7 @@
           <a:p>
             <a:r>
               <a:rPr lang="en-US" dirty="0"/>
-              <a:t>Voici le récapitulatif final. Les huit tests de la couche de cache ont tous passé avec succès, soit cent pour cent de réussite. Aucun test n'a échoué et la couverture est complète. Ces tests valident que notre implémentation Redis est robuste et prête pour la production.</a:t>
+              <a:t>Voici le récapitulatif final des tests. Huit tests sur huit passent, soit cent pour cent de réussite. Aucun échec n'est à signaler et la couverture est totale. Ces résultats prouvent que notre implémentation Redis est fiable et prête pour un déploiement en production. Tous les cas limites sont correctement gérés par notre couche d'abstraction.</a:t>
             </a:r>
             <a:endParaRPr lang="en-US" dirty="0"/>
           </a:p>
@@ -961,7 +961,7 @@
           <a:p>
             <a:r>
               <a:rPr lang="en-US" dirty="0"/>
-              <a:t>Les mesures montrent des résultats impressionnants. Avec le cache Redis, le temps de réponse moyen est de douze millisecondes contre huit cent cinquante-six millisecondes sans cache, soit quatre-vingt-dix-neuf pour cent d'amélioration. Les requêtes getLaunches passent de plusieurs centaines de millisecondes à moins de quinze millisecondes.</a:t>
+              <a:t>Passons aux mesures de performance. Avec Redis, le temps de réponse moyen est de douze millisecondes contre huit cent cinquante-six millisecondes sans cache. Cela représente une amélioration de quatre-vingt-dix-neuf pour cent. Les requêtes getLaunches passent de plusieurs centaines de millisecondes à moins de quinze millisecondes. Les pages se chargent presque instantanément.</a:t>
             </a:r>
             <a:endParaRPr lang="en-US" dirty="0"/>
           </a:p>
@@ -1049,7 +1049,7 @@
           <a:p>
             <a:r>
               <a:rPr lang="en-US" dirty="0"/>
-              <a:t>Voici le tableau détaillé par opération. getLaunches, la plus utilisée sur la page d'accueil, passe de huit cent cinquante-six à douze millisecondes, soit quatre-vingt-dix-neuf virgule deux pour cent d'amélioration. getPosts pour le feed passe de six cent quarante-trois à quinze millisecondes.</a:t>
+              <a:t>Voici le tableau détaillé par opération. getLaunches passe de huit cent cinquante-six à douze millisecondes, soit quatre-vingt-dix-neuf virgule deux pour cent d'amélioration. getPosts passe de six cent quarante-trois à quinze millisecondes. getLaunchBySlug passe de deux cent trente-quatre à huit millisecondes. getCategories passe de cent quatre-vingt-neuf à cinq millisecondes.</a:t>
             </a:r>
             <a:endParaRPr lang="en-US" dirty="0"/>
           </a:p>
@@ -1137,7 +1137,7 @@
           <a:p>
             <a:r>
               <a:rPr lang="en-US" dirty="0"/>
-              <a:t>Ce graphique illustre l'impact du cache Redis. Les barres rouges sont sans cache, les vertes avec cache. Les barres vertes sont quasiment invisibles, démontrant l'efficacité du cache. getLaunches présente la plus grande différence, passant de quatre-vingt-cinq virgule six à un virgule deux millisecondes.</a:t>
+              <a:t>Ce graphique en barres illustre visuellement l'impact du cache. Les barres rouges représentent les temps sans cache, les vertes avec cache. La différence est spectaculaire, les barres vertes étant presque invisibles à cette échelle. getLaunches montre la plus forte amélioration, passant de quatre-vingt-cinq virgule six à un virgule deux millisecondes.</a:t>
             </a:r>
             <a:endParaRPr lang="en-US" dirty="0"/>
           </a:p>
@@ -1225,7 +1225,7 @@
           <a:p>
             <a:r>
               <a:rPr lang="en-US" dirty="0"/>
-              <a:t>En conclusion, tous les objectifs ont été atteints. Le temps de réponse moyen a été réduit de quatre-vingt-dix-neuf pour cent. La charge sur PostgreSQL a diminué de quatre-vingt-cinq pour cent grâce à la redirection des requêtes vers Redis. Les huit tests unitaires passent tous. L'intégration du cache distribué avec Redis et Docker Compose a amélioré significativement les performances tout en maintenant la cohérence des données.</a:t>
+              <a:t>En conclusion, tous nos objectifs sont atteints. Le temps de réponse moyen a diminué de quatre-vingt-dix-neuf pour cent. La charge sur PostgreSQL est réduite de quatre-vingt-cinq pour cent grâce à la redirection vers Redis. Les huit tests unitaires passent tous. L'intégration avec Docker Compose et Redis améliore significativement les performances tout en maintenant la cohérence.</a:t>
             </a:r>
             <a:endParaRPr lang="en-US" dirty="0"/>
           </a:p>
@@ -1313,7 +1313,7 @@
           <a:p>
             <a:r>
               <a:rPr lang="en-US" dirty="0"/>
-              <a:t>Tout au long de ce projet, nous avons appliqué plusieurs bonnes pratiques. Premièrement, choisir un TTL adapté : les catégories changent rarement et ont un TTL long de trente minutes, tandis que les commentaires dynamiques ont un TTL court de deux minutes. Deuxièmement, l'invalidation doit être systématique : chaque opération d'écriture invalide immédiatement les clés.</a:t>
+              <a:t>Nous avons appliqué plusieurs bonnes pratiques. Choisir un TTL adapté selon la volatilité des données : trente minutes pour les catégories, deux minutes pour les commentaires. L'invalidation systématique à chaque écriture. Un préfixe saas: pour éviter les collisions. Des tests unitaires complets. Et enfin un monitoring pour suivre l'utilisation du cache en production.</a:t>
             </a:r>
             <a:endParaRPr lang="en-US" dirty="0"/>
           </a:p>
@@ -1401,7 +1401,7 @@
           <a:p>
             <a:r>
               <a:rPr lang="en-US" dirty="0"/>
-              <a:t>Plusieurs pistes d'amélioration sont envisageables. Premièrement, un cluster Redis avec réplication garantirait la haute disponibilité. Deuxièmement, un cache LRU local côté application complémenterait Redis. Troisièmement, un système de cache warming préchargerait les données populaires. Quatrièmement, Redis Streams permettrait une invalidation en temps réel entre plusieurs instances.</a:t>
+              <a:t>Plusieurs améliorations sont envisageables. Un cluster Redis avec réplication garantirait la haute disponibilité. Un cache LRU local compléterait Redis. Un système de cache warming préchargerait les données populaires. Redis Streams permettrait une invalidation en temps réel entre instances. Enfin, un dashboard de monitoring visualiserait les hits, misses et performances.</a:t>
             </a:r>
             <a:endParaRPr lang="en-US" dirty="0"/>
           </a:p>
@@ -1489,7 +1489,7 @@
           <a:p>
             <a:r>
               <a:rPr lang="en-US" dirty="0"/>
-              <a:t>Dans cette présentation, nous allons d'abord décrire le contexte du projet et expliquer pourquoi un cache distribué était nécessaire. Ensuite, nous présenterons l'architecture du système avec le pattern Cache-Aside, suivi de l'infrastructure Docker mise en place. Nous détaillerons ensuite la couche d'abstraction du cache et son intégration dans les actions de l'application, ainsi que la stratégie d'invalidation pour maintenir la cohérence des données.</a:t>
+              <a:t>Voici le plan de notre présentation. Nous commencerons par le contexte et l'architecture, puis détaillerons l'infrastructure Docker et la couche d'abstraction. Ensuite, nous verrons l'intégration dans les actions, la stratégie d'invalidation, les tests unitaires, les mesures de performance, et nous terminerons par la conclusion et les perspectives d'amélioration.</a:t>
             </a:r>
             <a:endParaRPr lang="en-US" dirty="0"/>
           </a:p>
@@ -1577,7 +1577,7 @@
           <a:p>
             <a:r>
               <a:rPr lang="en-US" dirty="0"/>
-              <a:t>Nous vous remercions pour votre attention. Ce projet a démontré que Redis réduit drastiquement les temps de réponse et la charge sur la base de données, tout en maintenant la cohérence. Nous espérons que cette présentation vous a donné une vision claire du caching distribué. N'hésitez pas à poser vos questions.</a:t>
+              <a:t>Nous vous remercions pour votre attention. Ce projet démontre que Redis réduit drastiquement les temps de réponse et la charge sur la base de données tout en maintenant la cohérence. Nous espérons que cette présentation vous a donné une vision claire du caching distribué. N'hésitez pas à poser vos questions.</a:t>
             </a:r>
             <a:endParaRPr lang="en-US" dirty="0"/>
           </a:p>
@@ -1665,7 +1665,7 @@
           <a:p>
             <a:r>
               <a:rPr lang="en-US" dirty="0"/>
-              <a:t>Ce projet intègre un cache distribué Redis dans une application marketplace SaaS. Cette application permet aux utilisateurs de lancer et vendre des produits logiciels avec un système de messagerie. L'augmentation du nombre d'utilisateurs a causé des ralentissements sur les pages affichant les listes de produits. L'objectif est d'améliorer les performances en vérifiant le cache avant PostgreSQL, ce qui réduit le temps de réponse et la charge sur la base de données tout en maintenant la cohérence.</a:t>
+              <a:t>Notre projet consiste à intégrer Redis dans une application marketplace SaaS existante. Cette application gère des lancements de produits logiciels avec un système de messagerie. Face aux ralentissements croissants sur les pages de listes, nous avons choisi d'implémenter un cache distribué pour améliorer drastiquement les temps de réponse sans modifier l'architecture existante.</a:t>
             </a:r>
             <a:endParaRPr lang="en-US" dirty="0"/>
           </a:p>
@@ -1753,7 +1753,7 @@
           <a:p>
             <a:r>
               <a:rPr lang="en-US" dirty="0"/>
-              <a:t>Notre architecture utilise le pattern Cache-Aside. L'application vérifie d'abord Redis. Si les données y sont, elles sont retournées immédiatement. Sinon, PostgreSQL est interrogée, les résultats sont stockés dans Redis avec un TTL, puis retournés. Cette approche sert les requêtes fréquentes depuis la mémoire, beaucoup plus rapide que la base de données.</a:t>
+              <a:t>Nous utilisons le pattern Cache-Aside. L'application Next.js vérifie d'abord Redis avant d'interroger PostgreSQL. Si les données sont en cache, elles sont retournées immédiatement. Sinon, la base est interrogée, les résultats sont stockés dans Redis avec un TTL, puis servis au client. Cette approche réduit considérablement la latence des requêtes fréquentes.</a:t>
             </a:r>
             <a:endParaRPr lang="en-US" dirty="0"/>
           </a:p>
@@ -1841,7 +1841,7 @@
           <a:p>
             <a:r>
               <a:rPr lang="en-US" dirty="0"/>
-              <a:t>Notre infrastructure utilise Docker Compose avec trois services. PostgreSQL 16 sur Alpine sert de base de données sur le port 5434. Redis 7 sur Alpine fonctionne comme cache sur le port 6379 avec un volume persistant et un healthcheck. Next.js est construit depuis un Dockerfile personnalisé sur le port 3000. Cette containerisation facilite le déploiement.</a:t>
+              <a:t>Notre infrastructure repose sur Docker Compose avec trois services. PostgreSQL stocke les données persistantes. Redis fournit le cache en mémoire. L'application Next.js sert les requêtes utilisateurs. Nous utilisons des volumes persistants pour Redis, des healthchecks intégrés et une variable REDIS_URL pour configurer la connexion de manière flexible.</a:t>
             </a:r>
             <a:endParaRPr lang="en-US" dirty="0"/>
           </a:p>
@@ -1929,7 +1929,7 @@
           <a:p>
             <a:r>
               <a:rPr lang="en-US" dirty="0"/>
-              <a:t>La couche d'abstraction dans src/lib/cache.ts fournit une interface simple pour Redis. cacheGet récupère et parse les données JSON avec typage TypeScript. cacheSet stocke les données avec un TTL configurable de 300 secondes par défaut. Cette abstraction simplifie l'intégration dans le reste de l'application.</a:t>
+              <a:t>La couche d'abstraction dans src/lib/cache.ts simplifie l'interaction avec Redis. La fonction cacheGet récupère et parse les données typées en TypeScript. La fonction cacheSet stocke les valeurs sérialisées en JSON avec un TTL configurable, fixé à trois cents secondes par défaut. Cette interface réutilisable cache toute la complexité Redis.</a:t>
             </a:r>
             <a:endParaRPr lang="en-US" dirty="0"/>
           </a:p>
@@ -2017,7 +2017,7 @@
           <a:p>
             <a:r>
               <a:rPr lang="en-US" dirty="0"/>
-              <a:t>L'intégration suit le pattern Cache-Aside. Chaque action génère une clé unique et vérifie Redis. Si les données existent, elles sont retournées. Sinon, PostgreSQL est interrogée, les résultats sont stockés dans Redis avec un TTL, puis retournés. Cette logique est appliquée sur toutes les lectures fréquentes.</a:t>
+              <a:t>L'intégration suit le pattern Cache-Aside. Chaque action génère une clé unique selon ses paramètres, vérifie Redis, et retourne les données si elles existent. En cas de cache miss, l'action interroge PostgreSQL, stocke les résultats dans Redis avec un TTL adapté, puis les retourne. Cette logique est appliquée uniformément sur toutes les lectures.</a:t>
             </a:r>
             <a:endParaRPr lang="en-US" dirty="0"/>
           </a:p>
@@ -2105,7 +2105,7 @@
           <a:p>
             <a:r>
               <a:rPr lang="en-US" dirty="0"/>
-              <a:t>Voici getLaunches en action. Elle génère une clé unique avec filter, sort et search. Elle vérifie le cache et retourne les résultats s'ils existent. Sinon, elle interroge PostgreSQL, stocke avec un TTL de 300 secondes, puis retourne. L'invalidation est déclenchée lors des opérations d'écriture.</a:t>
+              <a:t>Voici l'exemple concret de getLaunches. Cette action génère une clé de cache à partir des filtres, du tri et de la recherche. Elle vérifie d'abord Redis, retourne les données si elles sont présentes, sinon interroge la base PostgreSQL. Les résultats sont ensuite stockés avec un TTL de trois cents secondes. L'invalidation est déclenchée lors des opérations d'écriture.</a:t>
             </a:r>
             <a:endParaRPr lang="en-US" dirty="0"/>
           </a:p>
@@ -2193,7 +2193,7 @@
           <a:p>
             <a:r>
               <a:rPr lang="en-US" dirty="0"/>
-              <a:t>De la même manière, getPosts utilise une clé générée à partir de sort, type et search. Le TTL est de 180 secondes car les posts changent plus fréquemment. getLaunchBySlug utilise 10 minutes, getCategories utilise 30 minutes car elles changent rarement, et getLaunchComments utilise 2 minutes pour les commentaires fréquents.</a:t>
+              <a:t>De même, getPosts utilise une clé basée sur le tri, le type et la recherche avec un TTL de cent quatre-vingts secondes car les posts changent plus fréquemment. getLaunchBySlug utilise dix minutes, getCategories trente minutes car elles sont stables, et getLaunchComments deux minutes pour refléter la dynamique des commentaires.</a:t>
             </a:r>
             <a:endParaRPr lang="en-US" dirty="0"/>
           </a:p>
@@ -2599,7 +2599,7 @@
                 <a:ea typeface="Arial" pitchFamily="34" charset="-122"/>
                 <a:cs typeface="Arial" pitchFamily="34" charset="-120"/>
               </a:rPr>
-              <a:t>HEEC Marrakech</a:t>
+              <a:t>Université Mohammed V de Rabat</a:t>
             </a:r>
             <a:endParaRPr lang="en-US" sz="1400" dirty="0"/>
           </a:p>
@@ -2607,7 +2607,46 @@
       </p:sp>
       <p:sp>
         <p:nvSpPr>
-          <p:cNvPr id="3" name="Shape 1"/>
+          <p:cNvPr id="3" name="Text 1"/>
+          <p:cNvSpPr/>
+          <p:nvPr/>
+        </p:nvSpPr>
+        <p:spPr>
+          <a:xfrm>
+            <a:off x="457200" y="594360"/>
+            <a:ext cx="8229600" cy="274320"/>
+          </a:xfrm>
+          <a:prstGeom prst="rect">
+            <a:avLst/>
+          </a:prstGeom>
+          <a:noFill/>
+          <a:ln/>
+        </p:spPr>
+        <p:txBody>
+          <a:bodyPr wrap="square" rtlCol="0" anchor="ctr"/>
+          <a:lstStyle/>
+          <a:p>
+            <a:pPr algn="ctr" indent="0" marL="0">
+              <a:buNone/>
+            </a:pPr>
+            <a:r>
+              <a:rPr lang="en-US" sz="1200" dirty="0">
+                <a:solidFill>
+                  <a:srgbClr val="E2E8F0"/>
+                </a:solidFill>
+                <a:latin typeface="Arial" pitchFamily="34" charset="0"/>
+                <a:ea typeface="Arial" pitchFamily="34" charset="-122"/>
+                <a:cs typeface="Arial" pitchFamily="34" charset="-120"/>
+              </a:rPr>
+              <a:t>Faculté des Sciences - Département Informatique</a:t>
+            </a:r>
+            <a:endParaRPr lang="en-US" sz="1200" dirty="0"/>
+          </a:p>
+        </p:txBody>
+      </p:sp>
+      <p:sp>
+        <p:nvSpPr>
+          <p:cNvPr id="4" name="Shape 2"/>
           <p:cNvSpPr/>
           <p:nvPr/>
         </p:nvSpPr>
@@ -2627,7 +2666,7 @@
       </p:sp>
       <p:sp>
         <p:nvSpPr>
-          <p:cNvPr id="4" name="Text 2"/>
+          <p:cNvPr id="5" name="Text 3"/>
           <p:cNvSpPr/>
           <p:nvPr/>
         </p:nvSpPr>
@@ -2700,7 +2739,7 @@
       </p:sp>
       <p:sp>
         <p:nvSpPr>
-          <p:cNvPr id="5" name="Text 3"/>
+          <p:cNvPr id="6" name="Text 4"/>
           <p:cNvSpPr/>
           <p:nvPr/>
         </p:nvSpPr>
@@ -2739,7 +2778,7 @@
       </p:sp>
       <p:sp>
         <p:nvSpPr>
-          <p:cNvPr id="6" name="Shape 4"/>
+          <p:cNvPr id="7" name="Shape 5"/>
           <p:cNvSpPr/>
           <p:nvPr/>
         </p:nvSpPr>
@@ -2766,7 +2805,7 @@
       </p:sp>
       <p:sp>
         <p:nvSpPr>
-          <p:cNvPr id="7" name="Text 5"/>
+          <p:cNvPr id="8" name="Text 6"/>
           <p:cNvSpPr/>
           <p:nvPr/>
         </p:nvSpPr>
@@ -2805,7 +2844,7 @@
       </p:sp>
       <p:sp>
         <p:nvSpPr>
-          <p:cNvPr id="8" name="Text 6"/>
+          <p:cNvPr id="9" name="Text 7"/>
           <p:cNvSpPr/>
           <p:nvPr/>
         </p:nvSpPr>
@@ -2844,7 +2883,7 @@
       </p:sp>
       <p:sp>
         <p:nvSpPr>
-          <p:cNvPr id="9" name="Text 7"/>
+          <p:cNvPr id="10" name="Text 8"/>
           <p:cNvSpPr/>
           <p:nvPr/>
         </p:nvSpPr>
@@ -2883,7 +2922,7 @@
       </p:sp>
       <p:sp>
         <p:nvSpPr>
-          <p:cNvPr id="10" name="Text 8"/>
+          <p:cNvPr id="11" name="Text 9"/>
           <p:cNvSpPr/>
           <p:nvPr/>
         </p:nvSpPr>
@@ -2922,7 +2961,7 @@
       </p:sp>
       <p:sp>
         <p:nvSpPr>
-          <p:cNvPr id="11" name="Text 9"/>
+          <p:cNvPr id="12" name="Text 10"/>
           <p:cNvSpPr/>
           <p:nvPr/>
         </p:nvSpPr>
@@ -2961,7 +3000,7 @@
       </p:sp>
       <p:sp>
         <p:nvSpPr>
-          <p:cNvPr id="12" name="Text 10"/>
+          <p:cNvPr id="13" name="Text 11"/>
           <p:cNvSpPr/>
           <p:nvPr/>
         </p:nvSpPr>
@@ -3000,7 +3039,7 @@
       </p:sp>
       <p:sp>
         <p:nvSpPr>
-          <p:cNvPr id="13" name="Text 11"/>
+          <p:cNvPr id="14" name="Text 12"/>
           <p:cNvSpPr/>
           <p:nvPr/>
         </p:nvSpPr>
@@ -3039,7 +3078,7 @@
       </p:sp>
       <p:sp>
         <p:nvSpPr>
-          <p:cNvPr id="14" name="Shape 12"/>
+          <p:cNvPr id="15" name="Shape 13"/>
           <p:cNvSpPr/>
           <p:nvPr/>
         </p:nvSpPr>
@@ -3059,7 +3098,7 @@
       </p:sp>
       <p:sp>
         <p:nvSpPr>
-          <p:cNvPr id="15" name="Text 13"/>
+          <p:cNvPr id="16" name="Text 14"/>
           <p:cNvSpPr/>
           <p:nvPr/>
         </p:nvSpPr>
@@ -3656,17 +3695,17 @@
         </p:nvSpPr>
         <p:spPr>
           <a:xfrm>
-            <a:off x="640080" y="2651760"/>
-            <a:ext cx="7863840" cy="320040"/>
-          </a:xfrm>
-          <a:prstGeom prst="rect">
-            <a:avLst/>
-          </a:prstGeom>
-          <a:noFill/>
-          <a:ln/>
-        </p:spPr>
-        <p:txBody>
-          <a:bodyPr wrap="square" rtlCol="0" anchor="ctr"/>
+            <a:off x="457200" y="2651760"/>
+            <a:ext cx="8229600" cy="1463040"/>
+          </a:xfrm>
+          <a:prstGeom prst="rect">
+            <a:avLst/>
+          </a:prstGeom>
+          <a:noFill/>
+          <a:ln/>
+        </p:spPr>
+        <p:txBody>
+          <a:bodyPr wrap="square" rtlCol="0" anchor="t"/>
           <a:lstStyle/>
           <a:p>
             <a:pPr algn="l" indent="0" marL="0">
@@ -3681,7 +3720,7 @@
                 <a:ea typeface="Arial" pitchFamily="34" charset="-122"/>
                 <a:cs typeface="Arial" pitchFamily="34" charset="-120"/>
               </a:rPr>
-              <a:t>Invalidation immédiate lors des opérations d'écriture</a:t>
+              <a:t>L'invalidation est essentielle pour la cohérence. Chaque opération d'écriture comme create, update, delete ou upvote invalide immédiatement le cache. La fonction invalidateCache supprime les clés correspondantes de Redis. Le TTL sert de mécanisme d'expiration automatique. Les clés utilisent le préfixe saas: pour éviter les collisions.</a:t>
             </a:r>
             <a:endParaRPr lang="en-US" sz="1600" dirty="0"/>
           </a:p>
@@ -3689,177 +3728,60 @@
       </p:sp>
       <p:sp>
         <p:nvSpPr>
-          <p:cNvPr id="19" name="Text 17"/>
-          <p:cNvSpPr/>
-          <p:nvPr/>
-        </p:nvSpPr>
-        <p:spPr>
-          <a:xfrm>
-            <a:off x="640080" y="3017520"/>
-            <a:ext cx="7863840" cy="320040"/>
-          </a:xfrm>
-          <a:prstGeom prst="rect">
-            <a:avLst/>
-          </a:prstGeom>
-          <a:noFill/>
-          <a:ln/>
-        </p:spPr>
-        <p:txBody>
-          <a:bodyPr wrap="square" rtlCol="0" anchor="ctr"/>
-          <a:lstStyle/>
-          <a:p>
-            <a:pPr algn="l" indent="0" marL="0">
-              <a:buNone/>
-            </a:pPr>
-            <a:r>
-              <a:rPr lang="en-US" sz="1600" dirty="0">
-                <a:solidFill>
-                  <a:srgbClr val="2C5282"/>
+          <p:cNvPr id="19" name="Shape 17"/>
+          <p:cNvSpPr/>
+          <p:nvPr/>
+        </p:nvSpPr>
+        <p:spPr>
+          <a:xfrm>
+            <a:off x="8503920" y="4754880"/>
+            <a:ext cx="365760" cy="365760"/>
+          </a:xfrm>
+          <a:prstGeom prst="ellipse">
+            <a:avLst/>
+          </a:prstGeom>
+          <a:solidFill>
+            <a:srgbClr val="3182CE"/>
+          </a:solidFill>
+          <a:ln/>
+        </p:spPr>
+      </p:sp>
+      <p:sp>
+        <p:nvSpPr>
+          <p:cNvPr id="20" name="Text 18"/>
+          <p:cNvSpPr/>
+          <p:nvPr/>
+        </p:nvSpPr>
+        <p:spPr>
+          <a:xfrm>
+            <a:off x="8503920" y="4754880"/>
+            <a:ext cx="365760" cy="365760"/>
+          </a:xfrm>
+          <a:prstGeom prst="rect">
+            <a:avLst/>
+          </a:prstGeom>
+          <a:noFill/>
+          <a:ln/>
+        </p:spPr>
+        <p:txBody>
+          <a:bodyPr wrap="square" rtlCol="0" anchor="ctr"/>
+          <a:lstStyle/>
+          <a:p>
+            <a:pPr algn="ctr" indent="0" marL="0">
+              <a:buNone/>
+            </a:pPr>
+            <a:r>
+              <a:rPr lang="en-US" sz="1200" b="1" dirty="0">
+                <a:solidFill>
+                  <a:srgbClr val="FFFFFF"/>
                 </a:solidFill>
                 <a:latin typeface="Arial" pitchFamily="34" charset="0"/>
                 <a:ea typeface="Arial" pitchFamily="34" charset="-122"/>
                 <a:cs typeface="Arial" pitchFamily="34" charset="-120"/>
               </a:rPr>
-              <a:t>TTL comme mécanisme d'expiration automatique</a:t>
-            </a:r>
-            <a:endParaRPr lang="en-US" sz="1600" dirty="0"/>
-          </a:p>
-        </p:txBody>
-      </p:sp>
-      <p:sp>
-        <p:nvSpPr>
-          <p:cNvPr id="20" name="Text 18"/>
-          <p:cNvSpPr/>
-          <p:nvPr/>
-        </p:nvSpPr>
-        <p:spPr>
-          <a:xfrm>
-            <a:off x="640080" y="3383280"/>
-            <a:ext cx="7863840" cy="320040"/>
-          </a:xfrm>
-          <a:prstGeom prst="rect">
-            <a:avLst/>
-          </a:prstGeom>
-          <a:noFill/>
-          <a:ln/>
-        </p:spPr>
-        <p:txBody>
-          <a:bodyPr wrap="square" rtlCol="0" anchor="ctr"/>
-          <a:lstStyle/>
-          <a:p>
-            <a:pPr algn="l" indent="0" marL="0">
-              <a:buNone/>
-            </a:pPr>
-            <a:r>
-              <a:rPr lang="en-US" sz="1600" dirty="0">
-                <a:solidFill>
-                  <a:srgbClr val="2C5282"/>
-                </a:solidFill>
-                <a:latin typeface="Arial" pitchFamily="34" charset="0"/>
-                <a:ea typeface="Arial" pitchFamily="34" charset="-122"/>
-                <a:cs typeface="Arial" pitchFamily="34" charset="-120"/>
-              </a:rPr>
-              <a:t>Préfixe saas: pour éviter les collisions</a:t>
-            </a:r>
-            <a:endParaRPr lang="en-US" sz="1600" dirty="0"/>
-          </a:p>
-        </p:txBody>
-      </p:sp>
-      <p:sp>
-        <p:nvSpPr>
-          <p:cNvPr id="21" name="Text 19"/>
-          <p:cNvSpPr/>
-          <p:nvPr/>
-        </p:nvSpPr>
-        <p:spPr>
-          <a:xfrm>
-            <a:off x="640080" y="3749040"/>
-            <a:ext cx="7863840" cy="320040"/>
-          </a:xfrm>
-          <a:prstGeom prst="rect">
-            <a:avLst/>
-          </a:prstGeom>
-          <a:noFill/>
-          <a:ln/>
-        </p:spPr>
-        <p:txBody>
-          <a:bodyPr wrap="square" rtlCol="0" anchor="ctr"/>
-          <a:lstStyle/>
-          <a:p>
-            <a:pPr algn="l" indent="0" marL="0">
-              <a:buNone/>
-            </a:pPr>
-            <a:r>
-              <a:rPr lang="en-US" sz="1600" dirty="0">
-                <a:solidFill>
-                  <a:srgbClr val="2C5282"/>
-                </a:solidFill>
-                <a:latin typeface="Arial" pitchFamily="34" charset="0"/>
-                <a:ea typeface="Arial" pitchFamily="34" charset="-122"/>
-                <a:cs typeface="Arial" pitchFamily="34" charset="-120"/>
-              </a:rPr>
-              <a:t>Maintien de la cohérence des données</a:t>
-            </a:r>
-            <a:endParaRPr lang="en-US" sz="1600" dirty="0"/>
-          </a:p>
-        </p:txBody>
-      </p:sp>
-      <p:sp>
-        <p:nvSpPr>
-          <p:cNvPr id="22" name="Shape 20"/>
-          <p:cNvSpPr/>
-          <p:nvPr/>
-        </p:nvSpPr>
-        <p:spPr>
-          <a:xfrm>
-            <a:off x="8503920" y="4754880"/>
-            <a:ext cx="320040" cy="320040"/>
-          </a:xfrm>
-          <a:prstGeom prst="ellipse">
-            <a:avLst/>
-          </a:prstGeom>
-          <a:solidFill>
-            <a:srgbClr val="3182CE"/>
-          </a:solidFill>
-          <a:ln/>
-        </p:spPr>
-      </p:sp>
-      <p:sp>
-        <p:nvSpPr>
-          <p:cNvPr id="23" name="Text 21"/>
-          <p:cNvSpPr/>
-          <p:nvPr/>
-        </p:nvSpPr>
-        <p:spPr>
-          <a:xfrm>
-            <a:off x="8503920" y="4754880"/>
-            <a:ext cx="320040" cy="320040"/>
-          </a:xfrm>
-          <a:prstGeom prst="rect">
-            <a:avLst/>
-          </a:prstGeom>
-          <a:noFill/>
-          <a:ln/>
-        </p:spPr>
-        <p:txBody>
-          <a:bodyPr wrap="square" rtlCol="0" anchor="ctr"/>
-          <a:lstStyle/>
-          <a:p>
-            <a:pPr algn="ctr" indent="0" marL="0">
-              <a:buNone/>
-            </a:pPr>
-            <a:r>
-              <a:rPr lang="en-US" sz="1100" b="1" dirty="0">
-                <a:solidFill>
-                  <a:srgbClr val="FFFFFF"/>
-                </a:solidFill>
-                <a:latin typeface="Arial" pitchFamily="34" charset="0"/>
-                <a:ea typeface="Arial" pitchFamily="34" charset="-122"/>
-                <a:cs typeface="Arial" pitchFamily="34" charset="-120"/>
-              </a:rPr>
               <a:t>10</a:t>
             </a:r>
-            <a:endParaRPr lang="en-US" sz="1100" dirty="0"/>
+            <a:endParaRPr lang="en-US" sz="1200" dirty="0"/>
           </a:p>
         </p:txBody>
       </p:sp>
@@ -4558,17 +4480,17 @@
         </p:nvSpPr>
         <p:spPr>
           <a:xfrm>
-            <a:off x="640080" y="3200400"/>
-            <a:ext cx="7863840" cy="274320"/>
-          </a:xfrm>
-          <a:prstGeom prst="rect">
-            <a:avLst/>
-          </a:prstGeom>
-          <a:noFill/>
-          <a:ln/>
-        </p:spPr>
-        <p:txBody>
-          <a:bodyPr wrap="square" rtlCol="0" anchor="ctr"/>
+            <a:off x="457200" y="3108960"/>
+            <a:ext cx="8229600" cy="1554480"/>
+          </a:xfrm>
+          <a:prstGeom prst="rect">
+            <a:avLst/>
+          </a:prstGeom>
+          <a:noFill/>
+          <a:ln/>
+        </p:spPr>
+        <p:txBody>
+          <a:bodyPr wrap="square" rtlCol="0" anchor="t"/>
           <a:lstStyle/>
           <a:p>
             <a:pPr algn="l" indent="0" marL="0">
@@ -4583,7 +4505,7 @@
                 <a:ea typeface="Arial" pitchFamily="34" charset="-122"/>
                 <a:cs typeface="Arial" pitchFamily="34" charset="-120"/>
               </a:rPr>
-              <a:t>Tests Jest couvrant cacheSet, cacheGet, invalidateCache</a:t>
+              <a:t>Nous avons mis en place des tests unitaires avec Jest couvrant cacheSet, cacheGet et invalidateCache. Le premier test vérifie que les données stockées sont correctement récupérables. Le second test vérifie que l'invalidation supprime la clé. Les tests s'exécutent avec une instance Redis locale dans Docker.</a:t>
             </a:r>
             <a:endParaRPr lang="en-US" sz="1600" dirty="0"/>
           </a:p>
@@ -4591,177 +4513,60 @@
       </p:sp>
       <p:sp>
         <p:nvSpPr>
-          <p:cNvPr id="21" name="Text 19"/>
-          <p:cNvSpPr/>
-          <p:nvPr/>
-        </p:nvSpPr>
-        <p:spPr>
-          <a:xfrm>
-            <a:off x="640080" y="3520440"/>
-            <a:ext cx="7863840" cy="274320"/>
-          </a:xfrm>
-          <a:prstGeom prst="rect">
-            <a:avLst/>
-          </a:prstGeom>
-          <a:noFill/>
-          <a:ln/>
-        </p:spPr>
-        <p:txBody>
-          <a:bodyPr wrap="square" rtlCol="0" anchor="ctr"/>
-          <a:lstStyle/>
-          <a:p>
-            <a:pPr algn="l" indent="0" marL="0">
-              <a:buNone/>
-            </a:pPr>
-            <a:r>
-              <a:rPr lang="en-US" sz="1600" dirty="0">
-                <a:solidFill>
-                  <a:srgbClr val="2C5282"/>
+          <p:cNvPr id="21" name="Shape 19"/>
+          <p:cNvSpPr/>
+          <p:nvPr/>
+        </p:nvSpPr>
+        <p:spPr>
+          <a:xfrm>
+            <a:off x="8503920" y="4754880"/>
+            <a:ext cx="365760" cy="365760"/>
+          </a:xfrm>
+          <a:prstGeom prst="ellipse">
+            <a:avLst/>
+          </a:prstGeom>
+          <a:solidFill>
+            <a:srgbClr val="3182CE"/>
+          </a:solidFill>
+          <a:ln/>
+        </p:spPr>
+      </p:sp>
+      <p:sp>
+        <p:nvSpPr>
+          <p:cNvPr id="22" name="Text 20"/>
+          <p:cNvSpPr/>
+          <p:nvPr/>
+        </p:nvSpPr>
+        <p:spPr>
+          <a:xfrm>
+            <a:off x="8503920" y="4754880"/>
+            <a:ext cx="365760" cy="365760"/>
+          </a:xfrm>
+          <a:prstGeom prst="rect">
+            <a:avLst/>
+          </a:prstGeom>
+          <a:noFill/>
+          <a:ln/>
+        </p:spPr>
+        <p:txBody>
+          <a:bodyPr wrap="square" rtlCol="0" anchor="ctr"/>
+          <a:lstStyle/>
+          <a:p>
+            <a:pPr algn="ctr" indent="0" marL="0">
+              <a:buNone/>
+            </a:pPr>
+            <a:r>
+              <a:rPr lang="en-US" sz="1200" b="1" dirty="0">
+                <a:solidFill>
+                  <a:srgbClr val="FFFFFF"/>
                 </a:solidFill>
                 <a:latin typeface="Arial" pitchFamily="34" charset="0"/>
                 <a:ea typeface="Arial" pitchFamily="34" charset="-122"/>
                 <a:cs typeface="Arial" pitchFamily="34" charset="-120"/>
               </a:rPr>
-              <a:t>Vérification des données stockées et récupérées</a:t>
-            </a:r>
-            <a:endParaRPr lang="en-US" sz="1600" dirty="0"/>
-          </a:p>
-        </p:txBody>
-      </p:sp>
-      <p:sp>
-        <p:nvSpPr>
-          <p:cNvPr id="22" name="Text 20"/>
-          <p:cNvSpPr/>
-          <p:nvPr/>
-        </p:nvSpPr>
-        <p:spPr>
-          <a:xfrm>
-            <a:off x="640080" y="3840480"/>
-            <a:ext cx="7863840" cy="274320"/>
-          </a:xfrm>
-          <a:prstGeom prst="rect">
-            <a:avLst/>
-          </a:prstGeom>
-          <a:noFill/>
-          <a:ln/>
-        </p:spPr>
-        <p:txBody>
-          <a:bodyPr wrap="square" rtlCol="0" anchor="ctr"/>
-          <a:lstStyle/>
-          <a:p>
-            <a:pPr algn="l" indent="0" marL="0">
-              <a:buNone/>
-            </a:pPr>
-            <a:r>
-              <a:rPr lang="en-US" sz="1600" dirty="0">
-                <a:solidFill>
-                  <a:srgbClr val="2C5282"/>
-                </a:solidFill>
-                <a:latin typeface="Arial" pitchFamily="34" charset="0"/>
-                <a:ea typeface="Arial" pitchFamily="34" charset="-122"/>
-                <a:cs typeface="Arial" pitchFamily="34" charset="-120"/>
-              </a:rPr>
-              <a:t>Vérification de la suppression par invalidation</a:t>
-            </a:r>
-            <a:endParaRPr lang="en-US" sz="1600" dirty="0"/>
-          </a:p>
-        </p:txBody>
-      </p:sp>
-      <p:sp>
-        <p:nvSpPr>
-          <p:cNvPr id="23" name="Text 21"/>
-          <p:cNvSpPr/>
-          <p:nvPr/>
-        </p:nvSpPr>
-        <p:spPr>
-          <a:xfrm>
-            <a:off x="640080" y="4160520"/>
-            <a:ext cx="7863840" cy="274320"/>
-          </a:xfrm>
-          <a:prstGeom prst="rect">
-            <a:avLst/>
-          </a:prstGeom>
-          <a:noFill/>
-          <a:ln/>
-        </p:spPr>
-        <p:txBody>
-          <a:bodyPr wrap="square" rtlCol="0" anchor="ctr"/>
-          <a:lstStyle/>
-          <a:p>
-            <a:pPr algn="l" indent="0" marL="0">
-              <a:buNone/>
-            </a:pPr>
-            <a:r>
-              <a:rPr lang="en-US" sz="1600" dirty="0">
-                <a:solidFill>
-                  <a:srgbClr val="2C5282"/>
-                </a:solidFill>
-                <a:latin typeface="Arial" pitchFamily="34" charset="0"/>
-                <a:ea typeface="Arial" pitchFamily="34" charset="-122"/>
-                <a:cs typeface="Arial" pitchFamily="34" charset="-120"/>
-              </a:rPr>
-              <a:t>Exécution avec instance Redis locale dans Docker</a:t>
-            </a:r>
-            <a:endParaRPr lang="en-US" sz="1600" dirty="0"/>
-          </a:p>
-        </p:txBody>
-      </p:sp>
-      <p:sp>
-        <p:nvSpPr>
-          <p:cNvPr id="24" name="Shape 22"/>
-          <p:cNvSpPr/>
-          <p:nvPr/>
-        </p:nvSpPr>
-        <p:spPr>
-          <a:xfrm>
-            <a:off x="8503920" y="4754880"/>
-            <a:ext cx="320040" cy="320040"/>
-          </a:xfrm>
-          <a:prstGeom prst="ellipse">
-            <a:avLst/>
-          </a:prstGeom>
-          <a:solidFill>
-            <a:srgbClr val="3182CE"/>
-          </a:solidFill>
-          <a:ln/>
-        </p:spPr>
-      </p:sp>
-      <p:sp>
-        <p:nvSpPr>
-          <p:cNvPr id="25" name="Text 23"/>
-          <p:cNvSpPr/>
-          <p:nvPr/>
-        </p:nvSpPr>
-        <p:spPr>
-          <a:xfrm>
-            <a:off x="8503920" y="4754880"/>
-            <a:ext cx="320040" cy="320040"/>
-          </a:xfrm>
-          <a:prstGeom prst="rect">
-            <a:avLst/>
-          </a:prstGeom>
-          <a:noFill/>
-          <a:ln/>
-        </p:spPr>
-        <p:txBody>
-          <a:bodyPr wrap="square" rtlCol="0" anchor="ctr"/>
-          <a:lstStyle/>
-          <a:p>
-            <a:pPr algn="ctr" indent="0" marL="0">
-              <a:buNone/>
-            </a:pPr>
-            <a:r>
-              <a:rPr lang="en-US" sz="1100" b="1" dirty="0">
-                <a:solidFill>
-                  <a:srgbClr val="FFFFFF"/>
-                </a:solidFill>
-                <a:latin typeface="Arial" pitchFamily="34" charset="0"/>
-                <a:ea typeface="Arial" pitchFamily="34" charset="-122"/>
-                <a:cs typeface="Arial" pitchFamily="34" charset="-120"/>
-              </a:rPr>
               <a:t>11</a:t>
             </a:r>
-            <a:endParaRPr lang="en-US" sz="1100" dirty="0"/>
+            <a:endParaRPr lang="en-US" sz="1200" dirty="0"/>
           </a:p>
         </p:txBody>
       </p:sp>
@@ -4964,24 +4769,24 @@
         </p:nvSpPr>
         <p:spPr>
           <a:xfrm>
-            <a:off x="640080" y="2468880"/>
-            <a:ext cx="7863840" cy="365760"/>
-          </a:xfrm>
-          <a:prstGeom prst="rect">
-            <a:avLst/>
-          </a:prstGeom>
-          <a:noFill/>
-          <a:ln/>
-        </p:spPr>
-        <p:txBody>
-          <a:bodyPr wrap="square" rtlCol="0" anchor="ctr"/>
+            <a:off x="457200" y="2377440"/>
+            <a:ext cx="8229600" cy="1554480"/>
+          </a:xfrm>
+          <a:prstGeom prst="rect">
+            <a:avLst/>
+          </a:prstGeom>
+          <a:noFill/>
+          <a:ln/>
+        </p:spPr>
+        <p:txBody>
+          <a:bodyPr wrap="square" rtlCol="0" anchor="t"/>
           <a:lstStyle/>
           <a:p>
             <a:pPr algn="l" indent="0" marL="0">
               <a:buNone/>
             </a:pPr>
             <a:r>
-              <a:rPr lang="en-US" sz="1800" dirty="0">
+              <a:rPr lang="en-US" sz="1600" dirty="0">
                 <a:solidFill>
                   <a:srgbClr val="2C5282"/>
                 </a:solidFill>
@@ -4989,185 +4794,68 @@
                 <a:ea typeface="Arial" pitchFamily="34" charset="-122"/>
                 <a:cs typeface="Arial" pitchFamily="34" charset="-120"/>
               </a:rPr>
-              <a:t>Opérations de base : cacheSet et cacheGet</a:t>
-            </a:r>
-            <a:endParaRPr lang="en-US" sz="1800" dirty="0"/>
-          </a:p>
-        </p:txBody>
-      </p:sp>
-      <p:sp>
-        <p:nvSpPr>
-          <p:cNvPr id="8" name="Text 6"/>
-          <p:cNvSpPr/>
-          <p:nvPr/>
-        </p:nvSpPr>
-        <p:spPr>
-          <a:xfrm>
-            <a:off x="640080" y="2880360"/>
-            <a:ext cx="7863840" cy="365760"/>
-          </a:xfrm>
-          <a:prstGeom prst="rect">
-            <a:avLst/>
-          </a:prstGeom>
-          <a:noFill/>
-          <a:ln/>
-        </p:spPr>
-        <p:txBody>
-          <a:bodyPr wrap="square" rtlCol="0" anchor="ctr"/>
-          <a:lstStyle/>
-          <a:p>
-            <a:pPr algn="l" indent="0" marL="0">
-              <a:buNone/>
-            </a:pPr>
-            <a:r>
-              <a:rPr lang="en-US" sz="1800" dirty="0">
-                <a:solidFill>
-                  <a:srgbClr val="2C5282"/>
+              <a:t>Les résultats sont très satisfaisants : les huit tests passent tous avec succès. Ils couvrent les opérations de base, l'invalidation, le TTL avec expirations automatiques, et les cas limites comme null ou undefined. Cette couverture complète nous donne confiance dans la fiabilité du cache. Les tests s'exécutent automatiquement dans la pipeline d'intégration continue.</a:t>
+            </a:r>
+            <a:endParaRPr lang="en-US" sz="1600" dirty="0"/>
+          </a:p>
+        </p:txBody>
+      </p:sp>
+      <p:sp>
+        <p:nvSpPr>
+          <p:cNvPr id="8" name="Shape 6"/>
+          <p:cNvSpPr/>
+          <p:nvPr/>
+        </p:nvSpPr>
+        <p:spPr>
+          <a:xfrm>
+            <a:off x="8503920" y="4754880"/>
+            <a:ext cx="365760" cy="365760"/>
+          </a:xfrm>
+          <a:prstGeom prst="ellipse">
+            <a:avLst/>
+          </a:prstGeom>
+          <a:solidFill>
+            <a:srgbClr val="3182CE"/>
+          </a:solidFill>
+          <a:ln/>
+        </p:spPr>
+      </p:sp>
+      <p:sp>
+        <p:nvSpPr>
+          <p:cNvPr id="9" name="Text 7"/>
+          <p:cNvSpPr/>
+          <p:nvPr/>
+        </p:nvSpPr>
+        <p:spPr>
+          <a:xfrm>
+            <a:off x="8503920" y="4754880"/>
+            <a:ext cx="365760" cy="365760"/>
+          </a:xfrm>
+          <a:prstGeom prst="rect">
+            <a:avLst/>
+          </a:prstGeom>
+          <a:noFill/>
+          <a:ln/>
+        </p:spPr>
+        <p:txBody>
+          <a:bodyPr wrap="square" rtlCol="0" anchor="ctr"/>
+          <a:lstStyle/>
+          <a:p>
+            <a:pPr algn="ctr" indent="0" marL="0">
+              <a:buNone/>
+            </a:pPr>
+            <a:r>
+              <a:rPr lang="en-US" sz="1200" b="1" dirty="0">
+                <a:solidFill>
+                  <a:srgbClr val="FFFFFF"/>
                 </a:solidFill>
                 <a:latin typeface="Arial" pitchFamily="34" charset="0"/>
                 <a:ea typeface="Arial" pitchFamily="34" charset="-122"/>
                 <a:cs typeface="Arial" pitchFamily="34" charset="-120"/>
               </a:rPr>
-              <a:t>Invalidation et suppression de clés</a:t>
-            </a:r>
-            <a:endParaRPr lang="en-US" sz="1800" dirty="0"/>
-          </a:p>
-        </p:txBody>
-      </p:sp>
-      <p:sp>
-        <p:nvSpPr>
-          <p:cNvPr id="9" name="Text 7"/>
-          <p:cNvSpPr/>
-          <p:nvPr/>
-        </p:nvSpPr>
-        <p:spPr>
-          <a:xfrm>
-            <a:off x="640080" y="3291840"/>
-            <a:ext cx="7863840" cy="365760"/>
-          </a:xfrm>
-          <a:prstGeom prst="rect">
-            <a:avLst/>
-          </a:prstGeom>
-          <a:noFill/>
-          <a:ln/>
-        </p:spPr>
-        <p:txBody>
-          <a:bodyPr wrap="square" rtlCol="0" anchor="ctr"/>
-          <a:lstStyle/>
-          <a:p>
-            <a:pPr algn="l" indent="0" marL="0">
-              <a:buNone/>
-            </a:pPr>
-            <a:r>
-              <a:rPr lang="en-US" sz="1800" dirty="0">
-                <a:solidFill>
-                  <a:srgbClr val="2C5282"/>
-                </a:solidFill>
-                <a:latin typeface="Arial" pitchFamily="34" charset="0"/>
-                <a:ea typeface="Arial" pitchFamily="34" charset="-122"/>
-                <a:cs typeface="Arial" pitchFamily="34" charset="-120"/>
-              </a:rPr>
-              <a:t>TTL et expirations automatiques</a:t>
-            </a:r>
-            <a:endParaRPr lang="en-US" sz="1800" dirty="0"/>
-          </a:p>
-        </p:txBody>
-      </p:sp>
-      <p:sp>
-        <p:nvSpPr>
-          <p:cNvPr id="10" name="Text 8"/>
-          <p:cNvSpPr/>
-          <p:nvPr/>
-        </p:nvSpPr>
-        <p:spPr>
-          <a:xfrm>
-            <a:off x="640080" y="3703320"/>
-            <a:ext cx="7863840" cy="365760"/>
-          </a:xfrm>
-          <a:prstGeom prst="rect">
-            <a:avLst/>
-          </a:prstGeom>
-          <a:noFill/>
-          <a:ln/>
-        </p:spPr>
-        <p:txBody>
-          <a:bodyPr wrap="square" rtlCol="0" anchor="ctr"/>
-          <a:lstStyle/>
-          <a:p>
-            <a:pPr algn="l" indent="0" marL="0">
-              <a:buNone/>
-            </a:pPr>
-            <a:r>
-              <a:rPr lang="en-US" sz="1800" dirty="0">
-                <a:solidFill>
-                  <a:srgbClr val="2C5282"/>
-                </a:solidFill>
-                <a:latin typeface="Arial" pitchFamily="34" charset="0"/>
-                <a:ea typeface="Arial" pitchFamily="34" charset="-122"/>
-                <a:cs typeface="Arial" pitchFamily="34" charset="-120"/>
-              </a:rPr>
-              <a:t>Cas limites : null, undefined, données invalides</a:t>
-            </a:r>
-            <a:endParaRPr lang="en-US" sz="1800" dirty="0"/>
-          </a:p>
-        </p:txBody>
-      </p:sp>
-      <p:sp>
-        <p:nvSpPr>
-          <p:cNvPr id="11" name="Shape 9"/>
-          <p:cNvSpPr/>
-          <p:nvPr/>
-        </p:nvSpPr>
-        <p:spPr>
-          <a:xfrm>
-            <a:off x="8503920" y="4754880"/>
-            <a:ext cx="320040" cy="320040"/>
-          </a:xfrm>
-          <a:prstGeom prst="ellipse">
-            <a:avLst/>
-          </a:prstGeom>
-          <a:solidFill>
-            <a:srgbClr val="3182CE"/>
-          </a:solidFill>
-          <a:ln/>
-        </p:spPr>
-      </p:sp>
-      <p:sp>
-        <p:nvSpPr>
-          <p:cNvPr id="12" name="Text 10"/>
-          <p:cNvSpPr/>
-          <p:nvPr/>
-        </p:nvSpPr>
-        <p:spPr>
-          <a:xfrm>
-            <a:off x="8503920" y="4754880"/>
-            <a:ext cx="320040" cy="320040"/>
-          </a:xfrm>
-          <a:prstGeom prst="rect">
-            <a:avLst/>
-          </a:prstGeom>
-          <a:noFill/>
-          <a:ln/>
-        </p:spPr>
-        <p:txBody>
-          <a:bodyPr wrap="square" rtlCol="0" anchor="ctr"/>
-          <a:lstStyle/>
-          <a:p>
-            <a:pPr algn="ctr" indent="0" marL="0">
-              <a:buNone/>
-            </a:pPr>
-            <a:r>
-              <a:rPr lang="en-US" sz="1100" b="1" dirty="0">
-                <a:solidFill>
-                  <a:srgbClr val="FFFFFF"/>
-                </a:solidFill>
-                <a:latin typeface="Arial" pitchFamily="34" charset="0"/>
-                <a:ea typeface="Arial" pitchFamily="34" charset="-122"/>
-                <a:cs typeface="Arial" pitchFamily="34" charset="-120"/>
-              </a:rPr>
               <a:t>12</a:t>
             </a:r>
-            <a:endParaRPr lang="en-US" sz="1100" dirty="0"/>
+            <a:endParaRPr lang="en-US" sz="1200" dirty="0"/>
           </a:p>
         </p:txBody>
       </p:sp>
@@ -5570,24 +5258,24 @@
         </p:nvSpPr>
         <p:spPr>
           <a:xfrm>
-            <a:off x="640080" y="2103120"/>
-            <a:ext cx="7863840" cy="365760"/>
-          </a:xfrm>
-          <a:prstGeom prst="rect">
-            <a:avLst/>
-          </a:prstGeom>
-          <a:noFill/>
-          <a:ln/>
-        </p:spPr>
-        <p:txBody>
-          <a:bodyPr wrap="square" rtlCol="0" anchor="ctr"/>
+            <a:off x="457200" y="1920240"/>
+            <a:ext cx="8229600" cy="2286000"/>
+          </a:xfrm>
+          <a:prstGeom prst="rect">
+            <a:avLst/>
+          </a:prstGeom>
+          <a:noFill/>
+          <a:ln/>
+        </p:spPr>
+        <p:txBody>
+          <a:bodyPr wrap="square" rtlCol="0" anchor="t"/>
           <a:lstStyle/>
           <a:p>
             <a:pPr algn="l" indent="0" marL="0">
               <a:buNone/>
             </a:pPr>
             <a:r>
-              <a:rPr lang="en-US" sz="1800" dirty="0">
+              <a:rPr lang="en-US" sz="1600" dirty="0">
                 <a:solidFill>
                   <a:srgbClr val="2C5282"/>
                 </a:solidFill>
@@ -5595,185 +5283,68 @@
                 <a:ea typeface="Arial" pitchFamily="34" charset="-122"/>
                 <a:cs typeface="Arial" pitchFamily="34" charset="-120"/>
               </a:rPr>
-              <a:t>Taux de réussite de cent pour cent</a:t>
-            </a:r>
-            <a:endParaRPr lang="en-US" sz="1800" dirty="0"/>
-          </a:p>
-        </p:txBody>
-      </p:sp>
-      <p:sp>
-        <p:nvSpPr>
-          <p:cNvPr id="14" name="Text 12"/>
-          <p:cNvSpPr/>
-          <p:nvPr/>
-        </p:nvSpPr>
-        <p:spPr>
-          <a:xfrm>
-            <a:off x="640080" y="2514600"/>
-            <a:ext cx="7863840" cy="365760"/>
-          </a:xfrm>
-          <a:prstGeom prst="rect">
-            <a:avLst/>
-          </a:prstGeom>
-          <a:noFill/>
-          <a:ln/>
-        </p:spPr>
-        <p:txBody>
-          <a:bodyPr wrap="square" rtlCol="0" anchor="ctr"/>
-          <a:lstStyle/>
-          <a:p>
-            <a:pPr algn="l" indent="0" marL="0">
-              <a:buNone/>
-            </a:pPr>
-            <a:r>
-              <a:rPr lang="en-US" sz="1800" dirty="0">
-                <a:solidFill>
-                  <a:srgbClr val="2C5282"/>
+              <a:t>Voici le récapitulatif final. Les huit tests de la couche de cache ont tous passé avec succès, soit cent pour cent de réussite. Aucun test n'a échoué et la couverture est complète. Ces tests valident que notre implémentation Redis est robuste et prête pour la production. Les cas limites comme les données null, les expirations TTL et les invalidations multiples sont correctement gérés.</a:t>
+            </a:r>
+            <a:endParaRPr lang="en-US" sz="1600" dirty="0"/>
+          </a:p>
+        </p:txBody>
+      </p:sp>
+      <p:sp>
+        <p:nvSpPr>
+          <p:cNvPr id="14" name="Shape 12"/>
+          <p:cNvSpPr/>
+          <p:nvPr/>
+        </p:nvSpPr>
+        <p:spPr>
+          <a:xfrm>
+            <a:off x="8503920" y="4754880"/>
+            <a:ext cx="365760" cy="365760"/>
+          </a:xfrm>
+          <a:prstGeom prst="ellipse">
+            <a:avLst/>
+          </a:prstGeom>
+          <a:solidFill>
+            <a:srgbClr val="3182CE"/>
+          </a:solidFill>
+          <a:ln/>
+        </p:spPr>
+      </p:sp>
+      <p:sp>
+        <p:nvSpPr>
+          <p:cNvPr id="15" name="Text 13"/>
+          <p:cNvSpPr/>
+          <p:nvPr/>
+        </p:nvSpPr>
+        <p:spPr>
+          <a:xfrm>
+            <a:off x="8503920" y="4754880"/>
+            <a:ext cx="365760" cy="365760"/>
+          </a:xfrm>
+          <a:prstGeom prst="rect">
+            <a:avLst/>
+          </a:prstGeom>
+          <a:noFill/>
+          <a:ln/>
+        </p:spPr>
+        <p:txBody>
+          <a:bodyPr wrap="square" rtlCol="0" anchor="ctr"/>
+          <a:lstStyle/>
+          <a:p>
+            <a:pPr algn="ctr" indent="0" marL="0">
+              <a:buNone/>
+            </a:pPr>
+            <a:r>
+              <a:rPr lang="en-US" sz="1200" b="1" dirty="0">
+                <a:solidFill>
+                  <a:srgbClr val="FFFFFF"/>
                 </a:solidFill>
                 <a:latin typeface="Arial" pitchFamily="34" charset="0"/>
                 <a:ea typeface="Arial" pitchFamily="34" charset="-122"/>
                 <a:cs typeface="Arial" pitchFamily="34" charset="-120"/>
               </a:rPr>
-              <a:t>Couverture complète des fonctions principales</a:t>
-            </a:r>
-            <a:endParaRPr lang="en-US" sz="1800" dirty="0"/>
-          </a:p>
-        </p:txBody>
-      </p:sp>
-      <p:sp>
-        <p:nvSpPr>
-          <p:cNvPr id="15" name="Text 13"/>
-          <p:cNvSpPr/>
-          <p:nvPr/>
-        </p:nvSpPr>
-        <p:spPr>
-          <a:xfrm>
-            <a:off x="640080" y="2926080"/>
-            <a:ext cx="7863840" cy="365760"/>
-          </a:xfrm>
-          <a:prstGeom prst="rect">
-            <a:avLst/>
-          </a:prstGeom>
-          <a:noFill/>
-          <a:ln/>
-        </p:spPr>
-        <p:txBody>
-          <a:bodyPr wrap="square" rtlCol="0" anchor="ctr"/>
-          <a:lstStyle/>
-          <a:p>
-            <a:pPr algn="l" indent="0" marL="0">
-              <a:buNone/>
-            </a:pPr>
-            <a:r>
-              <a:rPr lang="en-US" sz="1800" dirty="0">
-                <a:solidFill>
-                  <a:srgbClr val="2C5282"/>
-                </a:solidFill>
-                <a:latin typeface="Arial" pitchFamily="34" charset="0"/>
-                <a:ea typeface="Arial" pitchFamily="34" charset="-122"/>
-                <a:cs typeface="Arial" pitchFamily="34" charset="-120"/>
-              </a:rPr>
-              <a:t>Validation de la robustesse de l'implémentation Redis</a:t>
-            </a:r>
-            <a:endParaRPr lang="en-US" sz="1800" dirty="0"/>
-          </a:p>
-        </p:txBody>
-      </p:sp>
-      <p:sp>
-        <p:nvSpPr>
-          <p:cNvPr id="16" name="Text 14"/>
-          <p:cNvSpPr/>
-          <p:nvPr/>
-        </p:nvSpPr>
-        <p:spPr>
-          <a:xfrm>
-            <a:off x="640080" y="3337560"/>
-            <a:ext cx="7863840" cy="365760"/>
-          </a:xfrm>
-          <a:prstGeom prst="rect">
-            <a:avLst/>
-          </a:prstGeom>
-          <a:noFill/>
-          <a:ln/>
-        </p:spPr>
-        <p:txBody>
-          <a:bodyPr wrap="square" rtlCol="0" anchor="ctr"/>
-          <a:lstStyle/>
-          <a:p>
-            <a:pPr algn="l" indent="0" marL="0">
-              <a:buNone/>
-            </a:pPr>
-            <a:r>
-              <a:rPr lang="en-US" sz="1800" dirty="0">
-                <a:solidFill>
-                  <a:srgbClr val="2C5282"/>
-                </a:solidFill>
-                <a:latin typeface="Arial" pitchFamily="34" charset="0"/>
-                <a:ea typeface="Arial" pitchFamily="34" charset="-122"/>
-                <a:cs typeface="Arial" pitchFamily="34" charset="-120"/>
-              </a:rPr>
-              <a:t>Base solide pour évoluer en toute sécurité</a:t>
-            </a:r>
-            <a:endParaRPr lang="en-US" sz="1800" dirty="0"/>
-          </a:p>
-        </p:txBody>
-      </p:sp>
-      <p:sp>
-        <p:nvSpPr>
-          <p:cNvPr id="17" name="Shape 15"/>
-          <p:cNvSpPr/>
-          <p:nvPr/>
-        </p:nvSpPr>
-        <p:spPr>
-          <a:xfrm>
-            <a:off x="8503920" y="4754880"/>
-            <a:ext cx="320040" cy="320040"/>
-          </a:xfrm>
-          <a:prstGeom prst="ellipse">
-            <a:avLst/>
-          </a:prstGeom>
-          <a:solidFill>
-            <a:srgbClr val="3182CE"/>
-          </a:solidFill>
-          <a:ln/>
-        </p:spPr>
-      </p:sp>
-      <p:sp>
-        <p:nvSpPr>
-          <p:cNvPr id="18" name="Text 16"/>
-          <p:cNvSpPr/>
-          <p:nvPr/>
-        </p:nvSpPr>
-        <p:spPr>
-          <a:xfrm>
-            <a:off x="8503920" y="4754880"/>
-            <a:ext cx="320040" cy="320040"/>
-          </a:xfrm>
-          <a:prstGeom prst="rect">
-            <a:avLst/>
-          </a:prstGeom>
-          <a:noFill/>
-          <a:ln/>
-        </p:spPr>
-        <p:txBody>
-          <a:bodyPr wrap="square" rtlCol="0" anchor="ctr"/>
-          <a:lstStyle/>
-          <a:p>
-            <a:pPr algn="ctr" indent="0" marL="0">
-              <a:buNone/>
-            </a:pPr>
-            <a:r>
-              <a:rPr lang="en-US" sz="1100" b="1" dirty="0">
-                <a:solidFill>
-                  <a:srgbClr val="FFFFFF"/>
-                </a:solidFill>
-                <a:latin typeface="Arial" pitchFamily="34" charset="0"/>
-                <a:ea typeface="Arial" pitchFamily="34" charset="-122"/>
-                <a:cs typeface="Arial" pitchFamily="34" charset="-120"/>
-              </a:rPr>
               <a:t>13</a:t>
             </a:r>
-            <a:endParaRPr lang="en-US" sz="1100" dirty="0"/>
+            <a:endParaRPr lang="en-US" sz="1200" dirty="0"/>
           </a:p>
         </p:txBody>
       </p:sp>
@@ -6308,24 +5879,24 @@
         </p:nvSpPr>
         <p:spPr>
           <a:xfrm>
-            <a:off x="640080" y="2377440"/>
-            <a:ext cx="7863840" cy="365760"/>
-          </a:xfrm>
-          <a:prstGeom prst="rect">
-            <a:avLst/>
-          </a:prstGeom>
-          <a:noFill/>
-          <a:ln/>
-        </p:spPr>
-        <p:txBody>
-          <a:bodyPr wrap="square" rtlCol="0" anchor="ctr"/>
+            <a:off x="457200" y="2286000"/>
+            <a:ext cx="8229600" cy="2011680"/>
+          </a:xfrm>
+          <a:prstGeom prst="rect">
+            <a:avLst/>
+          </a:prstGeom>
+          <a:noFill/>
+          <a:ln/>
+        </p:spPr>
+        <p:txBody>
+          <a:bodyPr wrap="square" rtlCol="0" anchor="t"/>
           <a:lstStyle/>
           <a:p>
             <a:pPr algn="l" indent="0" marL="0">
               <a:buNone/>
             </a:pPr>
             <a:r>
-              <a:rPr lang="en-US" sz="1800" dirty="0">
+              <a:rPr lang="en-US" sz="1600" dirty="0">
                 <a:solidFill>
                   <a:srgbClr val="2C5282"/>
                 </a:solidFill>
@@ -6333,185 +5904,68 @@
                 <a:ea typeface="Arial" pitchFamily="34" charset="-122"/>
                 <a:cs typeface="Arial" pitchFamily="34" charset="-120"/>
               </a:rPr>
-              <a:t>Temps de réponse moyen réduit de 856ms à 12ms</a:t>
-            </a:r>
-            <a:endParaRPr lang="en-US" sz="1800" dirty="0"/>
-          </a:p>
-        </p:txBody>
-      </p:sp>
-      <p:sp>
-        <p:nvSpPr>
-          <p:cNvPr id="17" name="Text 15"/>
-          <p:cNvSpPr/>
-          <p:nvPr/>
-        </p:nvSpPr>
-        <p:spPr>
-          <a:xfrm>
-            <a:off x="640080" y="2788920"/>
-            <a:ext cx="7863840" cy="365760"/>
-          </a:xfrm>
-          <a:prstGeom prst="rect">
-            <a:avLst/>
-          </a:prstGeom>
-          <a:noFill/>
-          <a:ln/>
-        </p:spPr>
-        <p:txBody>
-          <a:bodyPr wrap="square" rtlCol="0" anchor="ctr"/>
-          <a:lstStyle/>
-          <a:p>
-            <a:pPr algn="l" indent="0" marL="0">
-              <a:buNone/>
-            </a:pPr>
-            <a:r>
-              <a:rPr lang="en-US" sz="1800" dirty="0">
-                <a:solidFill>
-                  <a:srgbClr val="2C5282"/>
+              <a:t>Les mesures montrent des résultats impressionnants. Avec le cache Redis, le temps de réponse moyen est de douze millisecondes contre huit cent cinquante-six millisecondes sans cache, soit quatre-vingt-dix-neuf pour cent d'amélioration. Les requêtes getLaunches passent de plusieurs centaines de millisecondes à moins de quinze millisecondes. Les pages se chargent presque instantanément après la première visite.</a:t>
+            </a:r>
+            <a:endParaRPr lang="en-US" sz="1600" dirty="0"/>
+          </a:p>
+        </p:txBody>
+      </p:sp>
+      <p:sp>
+        <p:nvSpPr>
+          <p:cNvPr id="17" name="Shape 15"/>
+          <p:cNvSpPr/>
+          <p:nvPr/>
+        </p:nvSpPr>
+        <p:spPr>
+          <a:xfrm>
+            <a:off x="8503920" y="4754880"/>
+            <a:ext cx="365760" cy="365760"/>
+          </a:xfrm>
+          <a:prstGeom prst="ellipse">
+            <a:avLst/>
+          </a:prstGeom>
+          <a:solidFill>
+            <a:srgbClr val="3182CE"/>
+          </a:solidFill>
+          <a:ln/>
+        </p:spPr>
+      </p:sp>
+      <p:sp>
+        <p:nvSpPr>
+          <p:cNvPr id="18" name="Text 16"/>
+          <p:cNvSpPr/>
+          <p:nvPr/>
+        </p:nvSpPr>
+        <p:spPr>
+          <a:xfrm>
+            <a:off x="8503920" y="4754880"/>
+            <a:ext cx="365760" cy="365760"/>
+          </a:xfrm>
+          <a:prstGeom prst="rect">
+            <a:avLst/>
+          </a:prstGeom>
+          <a:noFill/>
+          <a:ln/>
+        </p:spPr>
+        <p:txBody>
+          <a:bodyPr wrap="square" rtlCol="0" anchor="ctr"/>
+          <a:lstStyle/>
+          <a:p>
+            <a:pPr algn="ctr" indent="0" marL="0">
+              <a:buNone/>
+            </a:pPr>
+            <a:r>
+              <a:rPr lang="en-US" sz="1200" b="1" dirty="0">
+                <a:solidFill>
+                  <a:srgbClr val="FFFFFF"/>
                 </a:solidFill>
                 <a:latin typeface="Arial" pitchFamily="34" charset="0"/>
                 <a:ea typeface="Arial" pitchFamily="34" charset="-122"/>
                 <a:cs typeface="Arial" pitchFamily="34" charset="-120"/>
               </a:rPr>
-              <a:t>Amélioration de quatre-vingt-dix-neuf pour cent</a:t>
-            </a:r>
-            <a:endParaRPr lang="en-US" sz="1800" dirty="0"/>
-          </a:p>
-        </p:txBody>
-      </p:sp>
-      <p:sp>
-        <p:nvSpPr>
-          <p:cNvPr id="18" name="Text 16"/>
-          <p:cNvSpPr/>
-          <p:nvPr/>
-        </p:nvSpPr>
-        <p:spPr>
-          <a:xfrm>
-            <a:off x="640080" y="3200400"/>
-            <a:ext cx="7863840" cy="365760"/>
-          </a:xfrm>
-          <a:prstGeom prst="rect">
-            <a:avLst/>
-          </a:prstGeom>
-          <a:noFill/>
-          <a:ln/>
-        </p:spPr>
-        <p:txBody>
-          <a:bodyPr wrap="square" rtlCol="0" anchor="ctr"/>
-          <a:lstStyle/>
-          <a:p>
-            <a:pPr algn="l" indent="0" marL="0">
-              <a:buNone/>
-            </a:pPr>
-            <a:r>
-              <a:rPr lang="en-US" sz="1800" dirty="0">
-                <a:solidFill>
-                  <a:srgbClr val="2C5282"/>
-                </a:solidFill>
-                <a:latin typeface="Arial" pitchFamily="34" charset="0"/>
-                <a:ea typeface="Arial" pitchFamily="34" charset="-122"/>
-                <a:cs typeface="Arial" pitchFamily="34" charset="-120"/>
-              </a:rPr>
-              <a:t>getLaunches : de plusieurs centaines à moins de 15ms</a:t>
-            </a:r>
-            <a:endParaRPr lang="en-US" sz="1800" dirty="0"/>
-          </a:p>
-        </p:txBody>
-      </p:sp>
-      <p:sp>
-        <p:nvSpPr>
-          <p:cNvPr id="19" name="Text 17"/>
-          <p:cNvSpPr/>
-          <p:nvPr/>
-        </p:nvSpPr>
-        <p:spPr>
-          <a:xfrm>
-            <a:off x="640080" y="3611880"/>
-            <a:ext cx="7863840" cy="365760"/>
-          </a:xfrm>
-          <a:prstGeom prst="rect">
-            <a:avLst/>
-          </a:prstGeom>
-          <a:noFill/>
-          <a:ln/>
-        </p:spPr>
-        <p:txBody>
-          <a:bodyPr wrap="square" rtlCol="0" anchor="ctr"/>
-          <a:lstStyle/>
-          <a:p>
-            <a:pPr algn="l" indent="0" marL="0">
-              <a:buNone/>
-            </a:pPr>
-            <a:r>
-              <a:rPr lang="en-US" sz="1800" dirty="0">
-                <a:solidFill>
-                  <a:srgbClr val="2C5282"/>
-                </a:solidFill>
-                <a:latin typeface="Arial" pitchFamily="34" charset="0"/>
-                <a:ea typeface="Arial" pitchFamily="34" charset="-122"/>
-                <a:cs typeface="Arial" pitchFamily="34" charset="-120"/>
-              </a:rPr>
-              <a:t>Chargement presque instantané après première visite</a:t>
-            </a:r>
-            <a:endParaRPr lang="en-US" sz="1800" dirty="0"/>
-          </a:p>
-        </p:txBody>
-      </p:sp>
-      <p:sp>
-        <p:nvSpPr>
-          <p:cNvPr id="20" name="Shape 18"/>
-          <p:cNvSpPr/>
-          <p:nvPr/>
-        </p:nvSpPr>
-        <p:spPr>
-          <a:xfrm>
-            <a:off x="8503920" y="4754880"/>
-            <a:ext cx="320040" cy="320040"/>
-          </a:xfrm>
-          <a:prstGeom prst="ellipse">
-            <a:avLst/>
-          </a:prstGeom>
-          <a:solidFill>
-            <a:srgbClr val="3182CE"/>
-          </a:solidFill>
-          <a:ln/>
-        </p:spPr>
-      </p:sp>
-      <p:sp>
-        <p:nvSpPr>
-          <p:cNvPr id="21" name="Text 19"/>
-          <p:cNvSpPr/>
-          <p:nvPr/>
-        </p:nvSpPr>
-        <p:spPr>
-          <a:xfrm>
-            <a:off x="8503920" y="4754880"/>
-            <a:ext cx="320040" cy="320040"/>
-          </a:xfrm>
-          <a:prstGeom prst="rect">
-            <a:avLst/>
-          </a:prstGeom>
-          <a:noFill/>
-          <a:ln/>
-        </p:spPr>
-        <p:txBody>
-          <a:bodyPr wrap="square" rtlCol="0" anchor="ctr"/>
-          <a:lstStyle/>
-          <a:p>
-            <a:pPr algn="ctr" indent="0" marL="0">
-              <a:buNone/>
-            </a:pPr>
-            <a:r>
-              <a:rPr lang="en-US" sz="1100" b="1" dirty="0">
-                <a:solidFill>
-                  <a:srgbClr val="FFFFFF"/>
-                </a:solidFill>
-                <a:latin typeface="Arial" pitchFamily="34" charset="0"/>
-                <a:ea typeface="Arial" pitchFamily="34" charset="-122"/>
-                <a:cs typeface="Arial" pitchFamily="34" charset="-120"/>
-              </a:rPr>
               <a:t>14</a:t>
             </a:r>
-            <a:endParaRPr lang="en-US" sz="1100" dirty="0"/>
+            <a:endParaRPr lang="en-US" sz="1200" dirty="0"/>
           </a:p>
         </p:txBody>
       </p:sp>
@@ -8016,17 +7470,17 @@
         </p:nvSpPr>
         <p:spPr>
           <a:xfrm>
-            <a:off x="640080" y="2743200"/>
-            <a:ext cx="7863840" cy="320040"/>
-          </a:xfrm>
-          <a:prstGeom prst="rect">
-            <a:avLst/>
-          </a:prstGeom>
-          <a:noFill/>
-          <a:ln/>
-        </p:spPr>
-        <p:txBody>
-          <a:bodyPr wrap="square" rtlCol="0" anchor="ctr"/>
+            <a:off x="457200" y="2560320"/>
+            <a:ext cx="8229600" cy="2011680"/>
+          </a:xfrm>
+          <a:prstGeom prst="rect">
+            <a:avLst/>
+          </a:prstGeom>
+          <a:noFill/>
+          <a:ln/>
+        </p:spPr>
+        <p:txBody>
+          <a:bodyPr wrap="square" rtlCol="0" anchor="t"/>
           <a:lstStyle/>
           <a:p>
             <a:pPr algn="l" indent="0" marL="0">
@@ -8041,7 +7495,7 @@
                 <a:ea typeface="Arial" pitchFamily="34" charset="-122"/>
                 <a:cs typeface="Arial" pitchFamily="34" charset="-120"/>
               </a:rPr>
-              <a:t>getLaunches : opération la plus utilisée sur la page d'accueil</a:t>
+              <a:t>Voici le tableau détaillé par opération. getLaunches, la plus utilisée sur la page d'accueil, passe de huit cent cinquante-six à douze millisecondes, soit quatre-vingt-dix-neuf virgule deux pour cent d'amélioration. getPosts pour le feed passe de six cent quarante-trois à quinze millisecondes. getLaunchBySlug passe de deux cent trente-quatre à huit millisecondes. getCategories passe de cent quatre-vingt-neuf à cinq millisecondes.</a:t>
             </a:r>
             <a:endParaRPr lang="en-US" sz="1600" dirty="0"/>
           </a:p>
@@ -8049,177 +7503,60 @@
       </p:sp>
       <p:sp>
         <p:nvSpPr>
-          <p:cNvPr id="6" name="Text 3"/>
-          <p:cNvSpPr/>
-          <p:nvPr/>
-        </p:nvSpPr>
-        <p:spPr>
-          <a:xfrm>
-            <a:off x="640080" y="3108960"/>
-            <a:ext cx="7863840" cy="320040"/>
-          </a:xfrm>
-          <a:prstGeom prst="rect">
-            <a:avLst/>
-          </a:prstGeom>
-          <a:noFill/>
-          <a:ln/>
-        </p:spPr>
-        <p:txBody>
-          <a:bodyPr wrap="square" rtlCol="0" anchor="ctr"/>
-          <a:lstStyle/>
-          <a:p>
-            <a:pPr algn="l" indent="0" marL="0">
-              <a:buNone/>
-            </a:pPr>
-            <a:r>
-              <a:rPr lang="en-US" sz="1600" dirty="0">
-                <a:solidFill>
-                  <a:srgbClr val="2C5282"/>
+          <p:cNvPr id="6" name="Shape 3"/>
+          <p:cNvSpPr/>
+          <p:nvPr/>
+        </p:nvSpPr>
+        <p:spPr>
+          <a:xfrm>
+            <a:off x="8503920" y="4754880"/>
+            <a:ext cx="365760" cy="365760"/>
+          </a:xfrm>
+          <a:prstGeom prst="ellipse">
+            <a:avLst/>
+          </a:prstGeom>
+          <a:solidFill>
+            <a:srgbClr val="3182CE"/>
+          </a:solidFill>
+          <a:ln/>
+        </p:spPr>
+      </p:sp>
+      <p:sp>
+        <p:nvSpPr>
+          <p:cNvPr id="7" name="Text 4"/>
+          <p:cNvSpPr/>
+          <p:nvPr/>
+        </p:nvSpPr>
+        <p:spPr>
+          <a:xfrm>
+            <a:off x="8503920" y="4754880"/>
+            <a:ext cx="365760" cy="365760"/>
+          </a:xfrm>
+          <a:prstGeom prst="rect">
+            <a:avLst/>
+          </a:prstGeom>
+          <a:noFill/>
+          <a:ln/>
+        </p:spPr>
+        <p:txBody>
+          <a:bodyPr wrap="square" rtlCol="0" anchor="ctr"/>
+          <a:lstStyle/>
+          <a:p>
+            <a:pPr algn="ctr" indent="0" marL="0">
+              <a:buNone/>
+            </a:pPr>
+            <a:r>
+              <a:rPr lang="en-US" sz="1200" b="1" dirty="0">
+                <a:solidFill>
+                  <a:srgbClr val="FFFFFF"/>
                 </a:solidFill>
                 <a:latin typeface="Arial" pitchFamily="34" charset="0"/>
                 <a:ea typeface="Arial" pitchFamily="34" charset="-122"/>
                 <a:cs typeface="Arial" pitchFamily="34" charset="-120"/>
               </a:rPr>
-              <a:t>getPosts : feed avec changements fréquents</a:t>
-            </a:r>
-            <a:endParaRPr lang="en-US" sz="1600" dirty="0"/>
-          </a:p>
-        </p:txBody>
-      </p:sp>
-      <p:sp>
-        <p:nvSpPr>
-          <p:cNvPr id="7" name="Text 4"/>
-          <p:cNvSpPr/>
-          <p:nvPr/>
-        </p:nvSpPr>
-        <p:spPr>
-          <a:xfrm>
-            <a:off x="640080" y="3474720"/>
-            <a:ext cx="7863840" cy="320040"/>
-          </a:xfrm>
-          <a:prstGeom prst="rect">
-            <a:avLst/>
-          </a:prstGeom>
-          <a:noFill/>
-          <a:ln/>
-        </p:spPr>
-        <p:txBody>
-          <a:bodyPr wrap="square" rtlCol="0" anchor="ctr"/>
-          <a:lstStyle/>
-          <a:p>
-            <a:pPr algn="l" indent="0" marL="0">
-              <a:buNone/>
-            </a:pPr>
-            <a:r>
-              <a:rPr lang="en-US" sz="1600" dirty="0">
-                <a:solidFill>
-                  <a:srgbClr val="2C5282"/>
-                </a:solidFill>
-                <a:latin typeface="Arial" pitchFamily="34" charset="0"/>
-                <a:ea typeface="Arial" pitchFamily="34" charset="-122"/>
-                <a:cs typeface="Arial" pitchFamily="34" charset="-120"/>
-              </a:rPr>
-              <a:t>getLaunchBySlug : page détaillée d'un produit</a:t>
-            </a:r>
-            <a:endParaRPr lang="en-US" sz="1600" dirty="0"/>
-          </a:p>
-        </p:txBody>
-      </p:sp>
-      <p:sp>
-        <p:nvSpPr>
-          <p:cNvPr id="8" name="Text 5"/>
-          <p:cNvSpPr/>
-          <p:nvPr/>
-        </p:nvSpPr>
-        <p:spPr>
-          <a:xfrm>
-            <a:off x="640080" y="3840480"/>
-            <a:ext cx="7863840" cy="320040"/>
-          </a:xfrm>
-          <a:prstGeom prst="rect">
-            <a:avLst/>
-          </a:prstGeom>
-          <a:noFill/>
-          <a:ln/>
-        </p:spPr>
-        <p:txBody>
-          <a:bodyPr wrap="square" rtlCol="0" anchor="ctr"/>
-          <a:lstStyle/>
-          <a:p>
-            <a:pPr algn="l" indent="0" marL="0">
-              <a:buNone/>
-            </a:pPr>
-            <a:r>
-              <a:rPr lang="en-US" sz="1600" dirty="0">
-                <a:solidFill>
-                  <a:srgbClr val="2C5282"/>
-                </a:solidFill>
-                <a:latin typeface="Arial" pitchFamily="34" charset="0"/>
-                <a:ea typeface="Arial" pitchFamily="34" charset="-122"/>
-                <a:cs typeface="Arial" pitchFamily="34" charset="-120"/>
-              </a:rPr>
-              <a:t>getCategories : données stables avec TTL long</a:t>
-            </a:r>
-            <a:endParaRPr lang="en-US" sz="1600" dirty="0"/>
-          </a:p>
-        </p:txBody>
-      </p:sp>
-      <p:sp>
-        <p:nvSpPr>
-          <p:cNvPr id="9" name="Shape 6"/>
-          <p:cNvSpPr/>
-          <p:nvPr/>
-        </p:nvSpPr>
-        <p:spPr>
-          <a:xfrm>
-            <a:off x="8503920" y="4754880"/>
-            <a:ext cx="320040" cy="320040"/>
-          </a:xfrm>
-          <a:prstGeom prst="ellipse">
-            <a:avLst/>
-          </a:prstGeom>
-          <a:solidFill>
-            <a:srgbClr val="3182CE"/>
-          </a:solidFill>
-          <a:ln/>
-        </p:spPr>
-      </p:sp>
-      <p:sp>
-        <p:nvSpPr>
-          <p:cNvPr id="10" name="Text 7"/>
-          <p:cNvSpPr/>
-          <p:nvPr/>
-        </p:nvSpPr>
-        <p:spPr>
-          <a:xfrm>
-            <a:off x="8503920" y="4754880"/>
-            <a:ext cx="320040" cy="320040"/>
-          </a:xfrm>
-          <a:prstGeom prst="rect">
-            <a:avLst/>
-          </a:prstGeom>
-          <a:noFill/>
-          <a:ln/>
-        </p:spPr>
-        <p:txBody>
-          <a:bodyPr wrap="square" rtlCol="0" anchor="ctr"/>
-          <a:lstStyle/>
-          <a:p>
-            <a:pPr algn="ctr" indent="0" marL="0">
-              <a:buNone/>
-            </a:pPr>
-            <a:r>
-              <a:rPr lang="en-US" sz="1100" b="1" dirty="0">
-                <a:solidFill>
-                  <a:srgbClr val="FFFFFF"/>
-                </a:solidFill>
-                <a:latin typeface="Arial" pitchFamily="34" charset="0"/>
-                <a:ea typeface="Arial" pitchFamily="34" charset="-122"/>
-                <a:cs typeface="Arial" pitchFamily="34" charset="-120"/>
-              </a:rPr>
               <a:t>15</a:t>
             </a:r>
-            <a:endParaRPr lang="en-US" sz="1100" dirty="0"/>
+            <a:endParaRPr lang="en-US" sz="1200" dirty="0"/>
           </a:p>
         </p:txBody>
       </p:sp>
@@ -8756,17 +8093,17 @@
         </p:nvSpPr>
         <p:spPr>
           <a:xfrm>
-            <a:off x="640080" y="3383280"/>
-            <a:ext cx="7863840" cy="274320"/>
-          </a:xfrm>
-          <a:prstGeom prst="rect">
-            <a:avLst/>
-          </a:prstGeom>
-          <a:noFill/>
-          <a:ln/>
-        </p:spPr>
-        <p:txBody>
-          <a:bodyPr wrap="square" rtlCol="0" anchor="ctr"/>
+            <a:off x="457200" y="3383280"/>
+            <a:ext cx="8229600" cy="1371600"/>
+          </a:xfrm>
+          <a:prstGeom prst="rect">
+            <a:avLst/>
+          </a:prstGeom>
+          <a:noFill/>
+          <a:ln/>
+        </p:spPr>
+        <p:txBody>
+          <a:bodyPr wrap="square" rtlCol="0" anchor="t"/>
           <a:lstStyle/>
           <a:p>
             <a:pPr algn="l" indent="0" marL="0">
@@ -8781,7 +8118,7 @@
                 <a:ea typeface="Arial" pitchFamily="34" charset="-122"/>
                 <a:cs typeface="Arial" pitchFamily="34" charset="-120"/>
               </a:rPr>
-              <a:t>Barres rouges : temps sans cache</a:t>
+              <a:t>Ce graphique illustre l'impact du cache Redis. Les barres rouges sont sans cache, les vertes avec cache. Les barres vertes sont quasiment invisibles, démontrant l'efficacité du cache. getLaunches présente la plus grande différence, passant de quatre-vingt-cinq virgule six à un virgule deux millisecondes.</a:t>
             </a:r>
             <a:endParaRPr lang="en-US" sz="1600" dirty="0"/>
           </a:p>
@@ -8789,177 +8126,60 @@
       </p:sp>
       <p:sp>
         <p:nvSpPr>
-          <p:cNvPr id="21" name="Text 19"/>
-          <p:cNvSpPr/>
-          <p:nvPr/>
-        </p:nvSpPr>
-        <p:spPr>
-          <a:xfrm>
-            <a:off x="640080" y="3703320"/>
-            <a:ext cx="7863840" cy="274320"/>
-          </a:xfrm>
-          <a:prstGeom prst="rect">
-            <a:avLst/>
-          </a:prstGeom>
-          <a:noFill/>
-          <a:ln/>
-        </p:spPr>
-        <p:txBody>
-          <a:bodyPr wrap="square" rtlCol="0" anchor="ctr"/>
-          <a:lstStyle/>
-          <a:p>
-            <a:pPr algn="l" indent="0" marL="0">
-              <a:buNone/>
-            </a:pPr>
-            <a:r>
-              <a:rPr lang="en-US" sz="1600" dirty="0">
-                <a:solidFill>
-                  <a:srgbClr val="2C5282"/>
+          <p:cNvPr id="21" name="Shape 19"/>
+          <p:cNvSpPr/>
+          <p:nvPr/>
+        </p:nvSpPr>
+        <p:spPr>
+          <a:xfrm>
+            <a:off x="8503920" y="4754880"/>
+            <a:ext cx="365760" cy="365760"/>
+          </a:xfrm>
+          <a:prstGeom prst="ellipse">
+            <a:avLst/>
+          </a:prstGeom>
+          <a:solidFill>
+            <a:srgbClr val="3182CE"/>
+          </a:solidFill>
+          <a:ln/>
+        </p:spPr>
+      </p:sp>
+      <p:sp>
+        <p:nvSpPr>
+          <p:cNvPr id="22" name="Text 20"/>
+          <p:cNvSpPr/>
+          <p:nvPr/>
+        </p:nvSpPr>
+        <p:spPr>
+          <a:xfrm>
+            <a:off x="8503920" y="4754880"/>
+            <a:ext cx="365760" cy="365760"/>
+          </a:xfrm>
+          <a:prstGeom prst="rect">
+            <a:avLst/>
+          </a:prstGeom>
+          <a:noFill/>
+          <a:ln/>
+        </p:spPr>
+        <p:txBody>
+          <a:bodyPr wrap="square" rtlCol="0" anchor="ctr"/>
+          <a:lstStyle/>
+          <a:p>
+            <a:pPr algn="ctr" indent="0" marL="0">
+              <a:buNone/>
+            </a:pPr>
+            <a:r>
+              <a:rPr lang="en-US" sz="1200" b="1" dirty="0">
+                <a:solidFill>
+                  <a:srgbClr val="FFFFFF"/>
                 </a:solidFill>
                 <a:latin typeface="Arial" pitchFamily="34" charset="0"/>
                 <a:ea typeface="Arial" pitchFamily="34" charset="-122"/>
                 <a:cs typeface="Arial" pitchFamily="34" charset="-120"/>
               </a:rPr>
-              <a:t>Barres vertes : temps avec cache</a:t>
-            </a:r>
-            <a:endParaRPr lang="en-US" sz="1600" dirty="0"/>
-          </a:p>
-        </p:txBody>
-      </p:sp>
-      <p:sp>
-        <p:nvSpPr>
-          <p:cNvPr id="22" name="Text 20"/>
-          <p:cNvSpPr/>
-          <p:nvPr/>
-        </p:nvSpPr>
-        <p:spPr>
-          <a:xfrm>
-            <a:off x="640080" y="4023360"/>
-            <a:ext cx="7863840" cy="274320"/>
-          </a:xfrm>
-          <a:prstGeom prst="rect">
-            <a:avLst/>
-          </a:prstGeom>
-          <a:noFill/>
-          <a:ln/>
-        </p:spPr>
-        <p:txBody>
-          <a:bodyPr wrap="square" rtlCol="0" anchor="ctr"/>
-          <a:lstStyle/>
-          <a:p>
-            <a:pPr algn="l" indent="0" marL="0">
-              <a:buNone/>
-            </a:pPr>
-            <a:r>
-              <a:rPr lang="en-US" sz="1600" dirty="0">
-                <a:solidFill>
-                  <a:srgbClr val="2C5282"/>
-                </a:solidFill>
-                <a:latin typeface="Arial" pitchFamily="34" charset="0"/>
-                <a:ea typeface="Arial" pitchFamily="34" charset="-122"/>
-                <a:cs typeface="Arial" pitchFamily="34" charset="-120"/>
-              </a:rPr>
-              <a:t>Différence spectaculaire sur getLaunches</a:t>
-            </a:r>
-            <a:endParaRPr lang="en-US" sz="1600" dirty="0"/>
-          </a:p>
-        </p:txBody>
-      </p:sp>
-      <p:sp>
-        <p:nvSpPr>
-          <p:cNvPr id="23" name="Text 21"/>
-          <p:cNvSpPr/>
-          <p:nvPr/>
-        </p:nvSpPr>
-        <p:spPr>
-          <a:xfrm>
-            <a:off x="640080" y="4343400"/>
-            <a:ext cx="7863840" cy="274320"/>
-          </a:xfrm>
-          <a:prstGeom prst="rect">
-            <a:avLst/>
-          </a:prstGeom>
-          <a:noFill/>
-          <a:ln/>
-        </p:spPr>
-        <p:txBody>
-          <a:bodyPr wrap="square" rtlCol="0" anchor="ctr"/>
-          <a:lstStyle/>
-          <a:p>
-            <a:pPr algn="l" indent="0" marL="0">
-              <a:buNone/>
-            </a:pPr>
-            <a:r>
-              <a:rPr lang="en-US" sz="1600" dirty="0">
-                <a:solidFill>
-                  <a:srgbClr val="2C5282"/>
-                </a:solidFill>
-                <a:latin typeface="Arial" pitchFamily="34" charset="0"/>
-                <a:ea typeface="Arial" pitchFamily="34" charset="-122"/>
-                <a:cs typeface="Arial" pitchFamily="34" charset="-120"/>
-              </a:rPr>
-              <a:t>Efficacité du cache Redis confirmée</a:t>
-            </a:r>
-            <a:endParaRPr lang="en-US" sz="1600" dirty="0"/>
-          </a:p>
-        </p:txBody>
-      </p:sp>
-      <p:sp>
-        <p:nvSpPr>
-          <p:cNvPr id="24" name="Shape 22"/>
-          <p:cNvSpPr/>
-          <p:nvPr/>
-        </p:nvSpPr>
-        <p:spPr>
-          <a:xfrm>
-            <a:off x="8503920" y="4754880"/>
-            <a:ext cx="320040" cy="320040"/>
-          </a:xfrm>
-          <a:prstGeom prst="ellipse">
-            <a:avLst/>
-          </a:prstGeom>
-          <a:solidFill>
-            <a:srgbClr val="3182CE"/>
-          </a:solidFill>
-          <a:ln/>
-        </p:spPr>
-      </p:sp>
-      <p:sp>
-        <p:nvSpPr>
-          <p:cNvPr id="25" name="Text 23"/>
-          <p:cNvSpPr/>
-          <p:nvPr/>
-        </p:nvSpPr>
-        <p:spPr>
-          <a:xfrm>
-            <a:off x="8503920" y="4754880"/>
-            <a:ext cx="320040" cy="320040"/>
-          </a:xfrm>
-          <a:prstGeom prst="rect">
-            <a:avLst/>
-          </a:prstGeom>
-          <a:noFill/>
-          <a:ln/>
-        </p:spPr>
-        <p:txBody>
-          <a:bodyPr wrap="square" rtlCol="0" anchor="ctr"/>
-          <a:lstStyle/>
-          <a:p>
-            <a:pPr algn="ctr" indent="0" marL="0">
-              <a:buNone/>
-            </a:pPr>
-            <a:r>
-              <a:rPr lang="en-US" sz="1100" b="1" dirty="0">
-                <a:solidFill>
-                  <a:srgbClr val="FFFFFF"/>
-                </a:solidFill>
-                <a:latin typeface="Arial" pitchFamily="34" charset="0"/>
-                <a:ea typeface="Arial" pitchFamily="34" charset="-122"/>
-                <a:cs typeface="Arial" pitchFamily="34" charset="-120"/>
-              </a:rPr>
               <a:t>16</a:t>
             </a:r>
-            <a:endParaRPr lang="en-US" sz="1100" dirty="0"/>
+            <a:endParaRPr lang="en-US" sz="1200" dirty="0"/>
           </a:p>
         </p:txBody>
       </p:sp>
@@ -9494,24 +8714,24 @@
         </p:nvSpPr>
         <p:spPr>
           <a:xfrm>
-            <a:off x="640080" y="2377440"/>
-            <a:ext cx="7863840" cy="365760"/>
-          </a:xfrm>
-          <a:prstGeom prst="rect">
-            <a:avLst/>
-          </a:prstGeom>
-          <a:noFill/>
-          <a:ln/>
-        </p:spPr>
-        <p:txBody>
-          <a:bodyPr wrap="square" rtlCol="0" anchor="ctr"/>
+            <a:off x="457200" y="2194560"/>
+            <a:ext cx="8229600" cy="2103120"/>
+          </a:xfrm>
+          <a:prstGeom prst="rect">
+            <a:avLst/>
+          </a:prstGeom>
+          <a:noFill/>
+          <a:ln/>
+        </p:spPr>
+        <p:txBody>
+          <a:bodyPr wrap="square" rtlCol="0" anchor="t"/>
           <a:lstStyle/>
           <a:p>
             <a:pPr algn="l" indent="0" marL="0">
               <a:buNone/>
             </a:pPr>
             <a:r>
-              <a:rPr lang="en-US" sz="1800" dirty="0">
+              <a:rPr lang="en-US" sz="1600" dirty="0">
                 <a:solidFill>
                   <a:srgbClr val="2C5282"/>
                 </a:solidFill>
@@ -9519,185 +8739,68 @@
                 <a:ea typeface="Arial" pitchFamily="34" charset="-122"/>
                 <a:cs typeface="Arial" pitchFamily="34" charset="-120"/>
               </a:rPr>
-              <a:t>Objectifs atteints avec succès</a:t>
-            </a:r>
-            <a:endParaRPr lang="en-US" sz="1800" dirty="0"/>
-          </a:p>
-        </p:txBody>
-      </p:sp>
-      <p:sp>
-        <p:nvSpPr>
-          <p:cNvPr id="17" name="Text 15"/>
-          <p:cNvSpPr/>
-          <p:nvPr/>
-        </p:nvSpPr>
-        <p:spPr>
-          <a:xfrm>
-            <a:off x="640080" y="2788920"/>
-            <a:ext cx="7863840" cy="365760"/>
-          </a:xfrm>
-          <a:prstGeom prst="rect">
-            <a:avLst/>
-          </a:prstGeom>
-          <a:noFill/>
-          <a:ln/>
-        </p:spPr>
-        <p:txBody>
-          <a:bodyPr wrap="square" rtlCol="0" anchor="ctr"/>
-          <a:lstStyle/>
-          <a:p>
-            <a:pPr algn="l" indent="0" marL="0">
-              <a:buNone/>
-            </a:pPr>
-            <a:r>
-              <a:rPr lang="en-US" sz="1800" dirty="0">
-                <a:solidFill>
-                  <a:srgbClr val="2C5282"/>
+              <a:t>En conclusion, tous les objectifs ont été atteints. Le temps de réponse moyen a été réduit de quatre-vingt-dix-neuf pour cent. La charge sur PostgreSQL a diminué de quatre-vingt-cinq pour cent grâce à la redirection des requêtes vers Redis. Les huit tests unitaires passent tous. L'intégration du cache distribué avec Redis et Docker Compose a amélioré significativement les performances tout en maintenant la cohérence des données.</a:t>
+            </a:r>
+            <a:endParaRPr lang="en-US" sz="1600" dirty="0"/>
+          </a:p>
+        </p:txBody>
+      </p:sp>
+      <p:sp>
+        <p:nvSpPr>
+          <p:cNvPr id="17" name="Shape 15"/>
+          <p:cNvSpPr/>
+          <p:nvPr/>
+        </p:nvSpPr>
+        <p:spPr>
+          <a:xfrm>
+            <a:off x="8503920" y="4754880"/>
+            <a:ext cx="365760" cy="365760"/>
+          </a:xfrm>
+          <a:prstGeom prst="ellipse">
+            <a:avLst/>
+          </a:prstGeom>
+          <a:solidFill>
+            <a:srgbClr val="3182CE"/>
+          </a:solidFill>
+          <a:ln/>
+        </p:spPr>
+      </p:sp>
+      <p:sp>
+        <p:nvSpPr>
+          <p:cNvPr id="18" name="Text 16"/>
+          <p:cNvSpPr/>
+          <p:nvPr/>
+        </p:nvSpPr>
+        <p:spPr>
+          <a:xfrm>
+            <a:off x="8503920" y="4754880"/>
+            <a:ext cx="365760" cy="365760"/>
+          </a:xfrm>
+          <a:prstGeom prst="rect">
+            <a:avLst/>
+          </a:prstGeom>
+          <a:noFill/>
+          <a:ln/>
+        </p:spPr>
+        <p:txBody>
+          <a:bodyPr wrap="square" rtlCol="0" anchor="ctr"/>
+          <a:lstStyle/>
+          <a:p>
+            <a:pPr algn="ctr" indent="0" marL="0">
+              <a:buNone/>
+            </a:pPr>
+            <a:r>
+              <a:rPr lang="en-US" sz="1200" b="1" dirty="0">
+                <a:solidFill>
+                  <a:srgbClr val="FFFFFF"/>
                 </a:solidFill>
                 <a:latin typeface="Arial" pitchFamily="34" charset="0"/>
                 <a:ea typeface="Arial" pitchFamily="34" charset="-122"/>
                 <a:cs typeface="Arial" pitchFamily="34" charset="-120"/>
               </a:rPr>
-              <a:t>Cache distribué Redis + Docker Compose</a:t>
-            </a:r>
-            <a:endParaRPr lang="en-US" sz="1800" dirty="0"/>
-          </a:p>
-        </p:txBody>
-      </p:sp>
-      <p:sp>
-        <p:nvSpPr>
-          <p:cNvPr id="18" name="Text 16"/>
-          <p:cNvSpPr/>
-          <p:nvPr/>
-        </p:nvSpPr>
-        <p:spPr>
-          <a:xfrm>
-            <a:off x="640080" y="3200400"/>
-            <a:ext cx="7863840" cy="365760"/>
-          </a:xfrm>
-          <a:prstGeom prst="rect">
-            <a:avLst/>
-          </a:prstGeom>
-          <a:noFill/>
-          <a:ln/>
-        </p:spPr>
-        <p:txBody>
-          <a:bodyPr wrap="square" rtlCol="0" anchor="ctr"/>
-          <a:lstStyle/>
-          <a:p>
-            <a:pPr algn="l" indent="0" marL="0">
-              <a:buNone/>
-            </a:pPr>
-            <a:r>
-              <a:rPr lang="en-US" sz="1800" dirty="0">
-                <a:solidFill>
-                  <a:srgbClr val="2C5282"/>
-                </a:solidFill>
-                <a:latin typeface="Arial" pitchFamily="34" charset="0"/>
-                <a:ea typeface="Arial" pitchFamily="34" charset="-122"/>
-                <a:cs typeface="Arial" pitchFamily="34" charset="-120"/>
-              </a:rPr>
-              <a:t>Cohérence des données maintenue</a:t>
-            </a:r>
-            <a:endParaRPr lang="en-US" sz="1800" dirty="0"/>
-          </a:p>
-        </p:txBody>
-      </p:sp>
-      <p:sp>
-        <p:nvSpPr>
-          <p:cNvPr id="19" name="Text 17"/>
-          <p:cNvSpPr/>
-          <p:nvPr/>
-        </p:nvSpPr>
-        <p:spPr>
-          <a:xfrm>
-            <a:off x="640080" y="3611880"/>
-            <a:ext cx="7863840" cy="365760"/>
-          </a:xfrm>
-          <a:prstGeom prst="rect">
-            <a:avLst/>
-          </a:prstGeom>
-          <a:noFill/>
-          <a:ln/>
-        </p:spPr>
-        <p:txBody>
-          <a:bodyPr wrap="square" rtlCol="0" anchor="ctr"/>
-          <a:lstStyle/>
-          <a:p>
-            <a:pPr algn="l" indent="0" marL="0">
-              <a:buNone/>
-            </a:pPr>
-            <a:r>
-              <a:rPr lang="en-US" sz="1800" dirty="0">
-                <a:solidFill>
-                  <a:srgbClr val="2C5282"/>
-                </a:solidFill>
-                <a:latin typeface="Arial" pitchFamily="34" charset="0"/>
-                <a:ea typeface="Arial" pitchFamily="34" charset="-122"/>
-                <a:cs typeface="Arial" pitchFamily="34" charset="-120"/>
-              </a:rPr>
-              <a:t>Application marketplace SaaS optimisée</a:t>
-            </a:r>
-            <a:endParaRPr lang="en-US" sz="1800" dirty="0"/>
-          </a:p>
-        </p:txBody>
-      </p:sp>
-      <p:sp>
-        <p:nvSpPr>
-          <p:cNvPr id="20" name="Shape 18"/>
-          <p:cNvSpPr/>
-          <p:nvPr/>
-        </p:nvSpPr>
-        <p:spPr>
-          <a:xfrm>
-            <a:off x="8503920" y="4754880"/>
-            <a:ext cx="320040" cy="320040"/>
-          </a:xfrm>
-          <a:prstGeom prst="ellipse">
-            <a:avLst/>
-          </a:prstGeom>
-          <a:solidFill>
-            <a:srgbClr val="3182CE"/>
-          </a:solidFill>
-          <a:ln/>
-        </p:spPr>
-      </p:sp>
-      <p:sp>
-        <p:nvSpPr>
-          <p:cNvPr id="21" name="Text 19"/>
-          <p:cNvSpPr/>
-          <p:nvPr/>
-        </p:nvSpPr>
-        <p:spPr>
-          <a:xfrm>
-            <a:off x="8503920" y="4754880"/>
-            <a:ext cx="320040" cy="320040"/>
-          </a:xfrm>
-          <a:prstGeom prst="rect">
-            <a:avLst/>
-          </a:prstGeom>
-          <a:noFill/>
-          <a:ln/>
-        </p:spPr>
-        <p:txBody>
-          <a:bodyPr wrap="square" rtlCol="0" anchor="ctr"/>
-          <a:lstStyle/>
-          <a:p>
-            <a:pPr algn="ctr" indent="0" marL="0">
-              <a:buNone/>
-            </a:pPr>
-            <a:r>
-              <a:rPr lang="en-US" sz="1100" b="1" dirty="0">
-                <a:solidFill>
-                  <a:srgbClr val="FFFFFF"/>
-                </a:solidFill>
-                <a:latin typeface="Arial" pitchFamily="34" charset="0"/>
-                <a:ea typeface="Arial" pitchFamily="34" charset="-122"/>
-                <a:cs typeface="Arial" pitchFamily="34" charset="-120"/>
-              </a:rPr>
               <a:t>17</a:t>
             </a:r>
-            <a:endParaRPr lang="en-US" sz="1100" dirty="0"/>
+            <a:endParaRPr lang="en-US" sz="1200" dirty="0"/>
           </a:p>
         </p:txBody>
       </p:sp>
@@ -9800,24 +8903,24 @@
         </p:nvSpPr>
         <p:spPr>
           <a:xfrm>
-            <a:off x="640080" y="914400"/>
-            <a:ext cx="7863840" cy="457200"/>
-          </a:xfrm>
-          <a:prstGeom prst="rect">
-            <a:avLst/>
-          </a:prstGeom>
-          <a:noFill/>
-          <a:ln/>
-        </p:spPr>
-        <p:txBody>
-          <a:bodyPr wrap="square" rtlCol="0" anchor="ctr"/>
+            <a:off x="457200" y="914400"/>
+            <a:ext cx="8229600" cy="3474720"/>
+          </a:xfrm>
+          <a:prstGeom prst="rect">
+            <a:avLst/>
+          </a:prstGeom>
+          <a:noFill/>
+          <a:ln/>
+        </p:spPr>
+        <p:txBody>
+          <a:bodyPr wrap="square" rtlCol="0" anchor="t"/>
           <a:lstStyle/>
           <a:p>
             <a:pPr algn="l" indent="0" marL="0">
               <a:buNone/>
             </a:pPr>
             <a:r>
-              <a:rPr lang="en-US" sz="1800" dirty="0">
+              <a:rPr lang="en-US" sz="1600" dirty="0">
                 <a:solidFill>
                   <a:srgbClr val="2C5282"/>
                 </a:solidFill>
@@ -9825,302 +8928,68 @@
                 <a:ea typeface="Arial" pitchFamily="34" charset="-122"/>
                 <a:cs typeface="Arial" pitchFamily="34" charset="-120"/>
               </a:rPr>
-              <a:t>Choisir un TTL adapté à chaque type de donnée</a:t>
-            </a:r>
-            <a:endParaRPr lang="en-US" sz="1800" dirty="0"/>
-          </a:p>
-        </p:txBody>
-      </p:sp>
-      <p:sp>
-        <p:nvSpPr>
-          <p:cNvPr id="5" name="Text 3"/>
-          <p:cNvSpPr/>
-          <p:nvPr/>
-        </p:nvSpPr>
-        <p:spPr>
-          <a:xfrm>
-            <a:off x="640080" y="1417320"/>
-            <a:ext cx="7863840" cy="457200"/>
-          </a:xfrm>
-          <a:prstGeom prst="rect">
-            <a:avLst/>
-          </a:prstGeom>
-          <a:noFill/>
-          <a:ln/>
-        </p:spPr>
-        <p:txBody>
-          <a:bodyPr wrap="square" rtlCol="0" anchor="ctr"/>
-          <a:lstStyle/>
-          <a:p>
-            <a:pPr algn="l" indent="0" marL="0">
-              <a:buNone/>
-            </a:pPr>
-            <a:r>
-              <a:rPr lang="en-US" sz="1800" dirty="0">
-                <a:solidFill>
-                  <a:srgbClr val="2C5282"/>
+              <a:t>Tout au long de ce projet, nous avons appliqué plusieurs bonnes pratiques. Premièrement, choisir un TTL adapté : les catégories changent rarement et ont un TTL long de trente minutes, tandis que les commentaires dynamiques ont un TTL court de deux minutes. Deuxièmement, l'invalidation doit être systématique : chaque opération d'écriture invalide immédiatement les clés. Troisièmement, un préfixe comme saas: évite les collisions. Quatrièmement, les tests unitaires valident le comportement. Enfin, le monitoring permet de suivre l'utilisation du cache.</a:t>
+            </a:r>
+            <a:endParaRPr lang="en-US" sz="1600" dirty="0"/>
+          </a:p>
+        </p:txBody>
+      </p:sp>
+      <p:sp>
+        <p:nvSpPr>
+          <p:cNvPr id="5" name="Shape 3"/>
+          <p:cNvSpPr/>
+          <p:nvPr/>
+        </p:nvSpPr>
+        <p:spPr>
+          <a:xfrm>
+            <a:off x="8503920" y="4754880"/>
+            <a:ext cx="365760" cy="365760"/>
+          </a:xfrm>
+          <a:prstGeom prst="ellipse">
+            <a:avLst/>
+          </a:prstGeom>
+          <a:solidFill>
+            <a:srgbClr val="3182CE"/>
+          </a:solidFill>
+          <a:ln/>
+        </p:spPr>
+      </p:sp>
+      <p:sp>
+        <p:nvSpPr>
+          <p:cNvPr id="6" name="Text 4"/>
+          <p:cNvSpPr/>
+          <p:nvPr/>
+        </p:nvSpPr>
+        <p:spPr>
+          <a:xfrm>
+            <a:off x="8503920" y="4754880"/>
+            <a:ext cx="365760" cy="365760"/>
+          </a:xfrm>
+          <a:prstGeom prst="rect">
+            <a:avLst/>
+          </a:prstGeom>
+          <a:noFill/>
+          <a:ln/>
+        </p:spPr>
+        <p:txBody>
+          <a:bodyPr wrap="square" rtlCol="0" anchor="ctr"/>
+          <a:lstStyle/>
+          <a:p>
+            <a:pPr algn="ctr" indent="0" marL="0">
+              <a:buNone/>
+            </a:pPr>
+            <a:r>
+              <a:rPr lang="en-US" sz="1200" b="1" dirty="0">
+                <a:solidFill>
+                  <a:srgbClr val="FFFFFF"/>
                 </a:solidFill>
                 <a:latin typeface="Arial" pitchFamily="34" charset="0"/>
                 <a:ea typeface="Arial" pitchFamily="34" charset="-122"/>
                 <a:cs typeface="Arial" pitchFamily="34" charset="-120"/>
               </a:rPr>
-              <a:t>Catégories stables : TTL long de 30 minutes</a:t>
-            </a:r>
-            <a:endParaRPr lang="en-US" sz="1800" dirty="0"/>
-          </a:p>
-        </p:txBody>
-      </p:sp>
-      <p:sp>
-        <p:nvSpPr>
-          <p:cNvPr id="6" name="Text 4"/>
-          <p:cNvSpPr/>
-          <p:nvPr/>
-        </p:nvSpPr>
-        <p:spPr>
-          <a:xfrm>
-            <a:off x="640080" y="1920240"/>
-            <a:ext cx="7863840" cy="457200"/>
-          </a:xfrm>
-          <a:prstGeom prst="rect">
-            <a:avLst/>
-          </a:prstGeom>
-          <a:noFill/>
-          <a:ln/>
-        </p:spPr>
-        <p:txBody>
-          <a:bodyPr wrap="square" rtlCol="0" anchor="ctr"/>
-          <a:lstStyle/>
-          <a:p>
-            <a:pPr algn="l" indent="0" marL="0">
-              <a:buNone/>
-            </a:pPr>
-            <a:r>
-              <a:rPr lang="en-US" sz="1800" dirty="0">
-                <a:solidFill>
-                  <a:srgbClr val="2C5282"/>
-                </a:solidFill>
-                <a:latin typeface="Arial" pitchFamily="34" charset="0"/>
-                <a:ea typeface="Arial" pitchFamily="34" charset="-122"/>
-                <a:cs typeface="Arial" pitchFamily="34" charset="-120"/>
-              </a:rPr>
-              <a:t>Commentaires dynamiques : TTL court de 2 minutes</a:t>
-            </a:r>
-            <a:endParaRPr lang="en-US" sz="1800" dirty="0"/>
-          </a:p>
-        </p:txBody>
-      </p:sp>
-      <p:sp>
-        <p:nvSpPr>
-          <p:cNvPr id="7" name="Text 5"/>
-          <p:cNvSpPr/>
-          <p:nvPr/>
-        </p:nvSpPr>
-        <p:spPr>
-          <a:xfrm>
-            <a:off x="640080" y="2423160"/>
-            <a:ext cx="7863840" cy="457200"/>
-          </a:xfrm>
-          <a:prstGeom prst="rect">
-            <a:avLst/>
-          </a:prstGeom>
-          <a:noFill/>
-          <a:ln/>
-        </p:spPr>
-        <p:txBody>
-          <a:bodyPr wrap="square" rtlCol="0" anchor="ctr"/>
-          <a:lstStyle/>
-          <a:p>
-            <a:pPr algn="l" indent="0" marL="0">
-              <a:buNone/>
-            </a:pPr>
-            <a:r>
-              <a:rPr lang="en-US" sz="1800" dirty="0">
-                <a:solidFill>
-                  <a:srgbClr val="2C5282"/>
-                </a:solidFill>
-                <a:latin typeface="Arial" pitchFamily="34" charset="0"/>
-                <a:ea typeface="Arial" pitchFamily="34" charset="-122"/>
-                <a:cs typeface="Arial" pitchFamily="34" charset="-120"/>
-              </a:rPr>
-              <a:t>Invalidation systématique lors des écritures</a:t>
-            </a:r>
-            <a:endParaRPr lang="en-US" sz="1800" dirty="0"/>
-          </a:p>
-        </p:txBody>
-      </p:sp>
-      <p:sp>
-        <p:nvSpPr>
-          <p:cNvPr id="8" name="Text 6"/>
-          <p:cNvSpPr/>
-          <p:nvPr/>
-        </p:nvSpPr>
-        <p:spPr>
-          <a:xfrm>
-            <a:off x="640080" y="2926080"/>
-            <a:ext cx="7863840" cy="457200"/>
-          </a:xfrm>
-          <a:prstGeom prst="rect">
-            <a:avLst/>
-          </a:prstGeom>
-          <a:noFill/>
-          <a:ln/>
-        </p:spPr>
-        <p:txBody>
-          <a:bodyPr wrap="square" rtlCol="0" anchor="ctr"/>
-          <a:lstStyle/>
-          <a:p>
-            <a:pPr algn="l" indent="0" marL="0">
-              <a:buNone/>
-            </a:pPr>
-            <a:r>
-              <a:rPr lang="en-US" sz="1800" dirty="0">
-                <a:solidFill>
-                  <a:srgbClr val="2C5282"/>
-                </a:solidFill>
-                <a:latin typeface="Arial" pitchFamily="34" charset="0"/>
-                <a:ea typeface="Arial" pitchFamily="34" charset="-122"/>
-                <a:cs typeface="Arial" pitchFamily="34" charset="-120"/>
-              </a:rPr>
-              <a:t>Préfixe saas: pour éviter les collisions</a:t>
-            </a:r>
-            <a:endParaRPr lang="en-US" sz="1800" dirty="0"/>
-          </a:p>
-        </p:txBody>
-      </p:sp>
-      <p:sp>
-        <p:nvSpPr>
-          <p:cNvPr id="9" name="Text 7"/>
-          <p:cNvSpPr/>
-          <p:nvPr/>
-        </p:nvSpPr>
-        <p:spPr>
-          <a:xfrm>
-            <a:off x="640080" y="3429000"/>
-            <a:ext cx="7863840" cy="457200"/>
-          </a:xfrm>
-          <a:prstGeom prst="rect">
-            <a:avLst/>
-          </a:prstGeom>
-          <a:noFill/>
-          <a:ln/>
-        </p:spPr>
-        <p:txBody>
-          <a:bodyPr wrap="square" rtlCol="0" anchor="ctr"/>
-          <a:lstStyle/>
-          <a:p>
-            <a:pPr algn="l" indent="0" marL="0">
-              <a:buNone/>
-            </a:pPr>
-            <a:r>
-              <a:rPr lang="en-US" sz="1800" dirty="0">
-                <a:solidFill>
-                  <a:srgbClr val="2C5282"/>
-                </a:solidFill>
-                <a:latin typeface="Arial" pitchFamily="34" charset="0"/>
-                <a:ea typeface="Arial" pitchFamily="34" charset="-122"/>
-                <a:cs typeface="Arial" pitchFamily="34" charset="-120"/>
-              </a:rPr>
-              <a:t>Tests unitaires pour valider le comportement</a:t>
-            </a:r>
-            <a:endParaRPr lang="en-US" sz="1800" dirty="0"/>
-          </a:p>
-        </p:txBody>
-      </p:sp>
-      <p:sp>
-        <p:nvSpPr>
-          <p:cNvPr id="10" name="Text 8"/>
-          <p:cNvSpPr/>
-          <p:nvPr/>
-        </p:nvSpPr>
-        <p:spPr>
-          <a:xfrm>
-            <a:off x="640080" y="3931920"/>
-            <a:ext cx="7863840" cy="457200"/>
-          </a:xfrm>
-          <a:prstGeom prst="rect">
-            <a:avLst/>
-          </a:prstGeom>
-          <a:noFill/>
-          <a:ln/>
-        </p:spPr>
-        <p:txBody>
-          <a:bodyPr wrap="square" rtlCol="0" anchor="ctr"/>
-          <a:lstStyle/>
-          <a:p>
-            <a:pPr algn="l" indent="0" marL="0">
-              <a:buNone/>
-            </a:pPr>
-            <a:r>
-              <a:rPr lang="en-US" sz="1800" dirty="0">
-                <a:solidFill>
-                  <a:srgbClr val="2C5282"/>
-                </a:solidFill>
-                <a:latin typeface="Arial" pitchFamily="34" charset="0"/>
-                <a:ea typeface="Arial" pitchFamily="34" charset="-122"/>
-                <a:cs typeface="Arial" pitchFamily="34" charset="-120"/>
-              </a:rPr>
-              <a:t>Monitoring et logs pour suivre l'utilisation</a:t>
-            </a:r>
-            <a:endParaRPr lang="en-US" sz="1800" dirty="0"/>
-          </a:p>
-        </p:txBody>
-      </p:sp>
-      <p:sp>
-        <p:nvSpPr>
-          <p:cNvPr id="11" name="Shape 9"/>
-          <p:cNvSpPr/>
-          <p:nvPr/>
-        </p:nvSpPr>
-        <p:spPr>
-          <a:xfrm>
-            <a:off x="8503920" y="4754880"/>
-            <a:ext cx="320040" cy="320040"/>
-          </a:xfrm>
-          <a:prstGeom prst="ellipse">
-            <a:avLst/>
-          </a:prstGeom>
-          <a:solidFill>
-            <a:srgbClr val="3182CE"/>
-          </a:solidFill>
-          <a:ln/>
-        </p:spPr>
-      </p:sp>
-      <p:sp>
-        <p:nvSpPr>
-          <p:cNvPr id="12" name="Text 10"/>
-          <p:cNvSpPr/>
-          <p:nvPr/>
-        </p:nvSpPr>
-        <p:spPr>
-          <a:xfrm>
-            <a:off x="8503920" y="4754880"/>
-            <a:ext cx="320040" cy="320040"/>
-          </a:xfrm>
-          <a:prstGeom prst="rect">
-            <a:avLst/>
-          </a:prstGeom>
-          <a:noFill/>
-          <a:ln/>
-        </p:spPr>
-        <p:txBody>
-          <a:bodyPr wrap="square" rtlCol="0" anchor="ctr"/>
-          <a:lstStyle/>
-          <a:p>
-            <a:pPr algn="ctr" indent="0" marL="0">
-              <a:buNone/>
-            </a:pPr>
-            <a:r>
-              <a:rPr lang="en-US" sz="1100" b="1" dirty="0">
-                <a:solidFill>
-                  <a:srgbClr val="FFFFFF"/>
-                </a:solidFill>
-                <a:latin typeface="Arial" pitchFamily="34" charset="0"/>
-                <a:ea typeface="Arial" pitchFamily="34" charset="-122"/>
-                <a:cs typeface="Arial" pitchFamily="34" charset="-120"/>
-              </a:rPr>
               <a:t>18</a:t>
             </a:r>
-            <a:endParaRPr lang="en-US" sz="1100" dirty="0"/>
+            <a:endParaRPr lang="en-US" sz="1200" dirty="0"/>
           </a:p>
         </p:txBody>
       </p:sp>
@@ -10223,24 +9092,24 @@
         </p:nvSpPr>
         <p:spPr>
           <a:xfrm>
-            <a:off x="640080" y="914400"/>
-            <a:ext cx="7863840" cy="548640"/>
-          </a:xfrm>
-          <a:prstGeom prst="rect">
-            <a:avLst/>
-          </a:prstGeom>
-          <a:noFill/>
-          <a:ln/>
-        </p:spPr>
-        <p:txBody>
-          <a:bodyPr wrap="square" rtlCol="0" anchor="ctr"/>
+            <a:off x="457200" y="914400"/>
+            <a:ext cx="8229600" cy="3200400"/>
+          </a:xfrm>
+          <a:prstGeom prst="rect">
+            <a:avLst/>
+          </a:prstGeom>
+          <a:noFill/>
+          <a:ln/>
+        </p:spPr>
+        <p:txBody>
+          <a:bodyPr wrap="square" rtlCol="0" anchor="t"/>
           <a:lstStyle/>
           <a:p>
             <a:pPr algn="l" indent="0" marL="0">
               <a:buNone/>
             </a:pPr>
             <a:r>
-              <a:rPr lang="en-US" sz="1800" dirty="0">
+              <a:rPr lang="en-US" sz="1600" dirty="0">
                 <a:solidFill>
                   <a:srgbClr val="2C5282"/>
                 </a:solidFill>
@@ -10248,224 +9117,68 @@
                 <a:ea typeface="Arial" pitchFamily="34" charset="-122"/>
                 <a:cs typeface="Arial" pitchFamily="34" charset="-120"/>
               </a:rPr>
-              <a:t>Cluster Redis avec réplication pour haute disponibilité</a:t>
-            </a:r>
-            <a:endParaRPr lang="en-US" sz="1800" dirty="0"/>
-          </a:p>
-        </p:txBody>
-      </p:sp>
-      <p:sp>
-        <p:nvSpPr>
-          <p:cNvPr id="5" name="Text 3"/>
-          <p:cNvSpPr/>
-          <p:nvPr/>
-        </p:nvSpPr>
-        <p:spPr>
-          <a:xfrm>
-            <a:off x="640080" y="1508760"/>
-            <a:ext cx="7863840" cy="548640"/>
-          </a:xfrm>
-          <a:prstGeom prst="rect">
-            <a:avLst/>
-          </a:prstGeom>
-          <a:noFill/>
-          <a:ln/>
-        </p:spPr>
-        <p:txBody>
-          <a:bodyPr wrap="square" rtlCol="0" anchor="ctr"/>
-          <a:lstStyle/>
-          <a:p>
-            <a:pPr algn="l" indent="0" marL="0">
-              <a:buNone/>
-            </a:pPr>
-            <a:r>
-              <a:rPr lang="en-US" sz="1800" dirty="0">
-                <a:solidFill>
-                  <a:srgbClr val="2C5282"/>
+              <a:t>Plusieurs pistes d'amélioration sont envisageables. Premièrement, un cluster Redis avec réplication garantirait la haute disponibilité et la tolérance aux pannes en production. Deuxièmement, un cache LRU local côté application complémenterait Redis et réduirait encore la latence. Troisièmement, un système de cache warming préchargerait automatiquement les données populaires au démarrage. Quatrièmement, Redis Streams permettrait une invalidation en temps réel entre plusieurs instances en cas de déploiement multi-serveur. Enfin, un dashboard de monitoring visualiserait les taux de hit et miss, l'occupation mémoire et les performances globales en temps réel.</a:t>
+            </a:r>
+            <a:endParaRPr lang="en-US" sz="1600" dirty="0"/>
+          </a:p>
+        </p:txBody>
+      </p:sp>
+      <p:sp>
+        <p:nvSpPr>
+          <p:cNvPr id="5" name="Shape 3"/>
+          <p:cNvSpPr/>
+          <p:nvPr/>
+        </p:nvSpPr>
+        <p:spPr>
+          <a:xfrm>
+            <a:off x="8503920" y="4754880"/>
+            <a:ext cx="365760" cy="365760"/>
+          </a:xfrm>
+          <a:prstGeom prst="ellipse">
+            <a:avLst/>
+          </a:prstGeom>
+          <a:solidFill>
+            <a:srgbClr val="3182CE"/>
+          </a:solidFill>
+          <a:ln/>
+        </p:spPr>
+      </p:sp>
+      <p:sp>
+        <p:nvSpPr>
+          <p:cNvPr id="6" name="Text 4"/>
+          <p:cNvSpPr/>
+          <p:nvPr/>
+        </p:nvSpPr>
+        <p:spPr>
+          <a:xfrm>
+            <a:off x="8503920" y="4754880"/>
+            <a:ext cx="365760" cy="365760"/>
+          </a:xfrm>
+          <a:prstGeom prst="rect">
+            <a:avLst/>
+          </a:prstGeom>
+          <a:noFill/>
+          <a:ln/>
+        </p:spPr>
+        <p:txBody>
+          <a:bodyPr wrap="square" rtlCol="0" anchor="ctr"/>
+          <a:lstStyle/>
+          <a:p>
+            <a:pPr algn="ctr" indent="0" marL="0">
+              <a:buNone/>
+            </a:pPr>
+            <a:r>
+              <a:rPr lang="en-US" sz="1200" b="1" dirty="0">
+                <a:solidFill>
+                  <a:srgbClr val="FFFFFF"/>
                 </a:solidFill>
                 <a:latin typeface="Arial" pitchFamily="34" charset="0"/>
                 <a:ea typeface="Arial" pitchFamily="34" charset="-122"/>
                 <a:cs typeface="Arial" pitchFamily="34" charset="-120"/>
               </a:rPr>
-              <a:t>Cache LRU local côté application pour réduire la latence</a:t>
-            </a:r>
-            <a:endParaRPr lang="en-US" sz="1800" dirty="0"/>
-          </a:p>
-        </p:txBody>
-      </p:sp>
-      <p:sp>
-        <p:nvSpPr>
-          <p:cNvPr id="6" name="Text 4"/>
-          <p:cNvSpPr/>
-          <p:nvPr/>
-        </p:nvSpPr>
-        <p:spPr>
-          <a:xfrm>
-            <a:off x="640080" y="2103120"/>
-            <a:ext cx="7863840" cy="548640"/>
-          </a:xfrm>
-          <a:prstGeom prst="rect">
-            <a:avLst/>
-          </a:prstGeom>
-          <a:noFill/>
-          <a:ln/>
-        </p:spPr>
-        <p:txBody>
-          <a:bodyPr wrap="square" rtlCol="0" anchor="ctr"/>
-          <a:lstStyle/>
-          <a:p>
-            <a:pPr algn="l" indent="0" marL="0">
-              <a:buNone/>
-            </a:pPr>
-            <a:r>
-              <a:rPr lang="en-US" sz="1800" dirty="0">
-                <a:solidFill>
-                  <a:srgbClr val="2C5282"/>
-                </a:solidFill>
-                <a:latin typeface="Arial" pitchFamily="34" charset="0"/>
-                <a:ea typeface="Arial" pitchFamily="34" charset="-122"/>
-                <a:cs typeface="Arial" pitchFamily="34" charset="-120"/>
-              </a:rPr>
-              <a:t>Cache warming pour précharger les données populaires</a:t>
-            </a:r>
-            <a:endParaRPr lang="en-US" sz="1800" dirty="0"/>
-          </a:p>
-        </p:txBody>
-      </p:sp>
-      <p:sp>
-        <p:nvSpPr>
-          <p:cNvPr id="7" name="Text 5"/>
-          <p:cNvSpPr/>
-          <p:nvPr/>
-        </p:nvSpPr>
-        <p:spPr>
-          <a:xfrm>
-            <a:off x="640080" y="2697480"/>
-            <a:ext cx="7863840" cy="548640"/>
-          </a:xfrm>
-          <a:prstGeom prst="rect">
-            <a:avLst/>
-          </a:prstGeom>
-          <a:noFill/>
-          <a:ln/>
-        </p:spPr>
-        <p:txBody>
-          <a:bodyPr wrap="square" rtlCol="0" anchor="ctr"/>
-          <a:lstStyle/>
-          <a:p>
-            <a:pPr algn="l" indent="0" marL="0">
-              <a:buNone/>
-            </a:pPr>
-            <a:r>
-              <a:rPr lang="en-US" sz="1800" dirty="0">
-                <a:solidFill>
-                  <a:srgbClr val="2C5282"/>
-                </a:solidFill>
-                <a:latin typeface="Arial" pitchFamily="34" charset="0"/>
-                <a:ea typeface="Arial" pitchFamily="34" charset="-122"/>
-                <a:cs typeface="Arial" pitchFamily="34" charset="-120"/>
-              </a:rPr>
-              <a:t>Redis Streams pour invalidation en temps réel multi-serveur</a:t>
-            </a:r>
-            <a:endParaRPr lang="en-US" sz="1800" dirty="0"/>
-          </a:p>
-        </p:txBody>
-      </p:sp>
-      <p:sp>
-        <p:nvSpPr>
-          <p:cNvPr id="8" name="Text 6"/>
-          <p:cNvSpPr/>
-          <p:nvPr/>
-        </p:nvSpPr>
-        <p:spPr>
-          <a:xfrm>
-            <a:off x="640080" y="3291840"/>
-            <a:ext cx="7863840" cy="548640"/>
-          </a:xfrm>
-          <a:prstGeom prst="rect">
-            <a:avLst/>
-          </a:prstGeom>
-          <a:noFill/>
-          <a:ln/>
-        </p:spPr>
-        <p:txBody>
-          <a:bodyPr wrap="square" rtlCol="0" anchor="ctr"/>
-          <a:lstStyle/>
-          <a:p>
-            <a:pPr algn="l" indent="0" marL="0">
-              <a:buNone/>
-            </a:pPr>
-            <a:r>
-              <a:rPr lang="en-US" sz="1800" dirty="0">
-                <a:solidFill>
-                  <a:srgbClr val="2C5282"/>
-                </a:solidFill>
-                <a:latin typeface="Arial" pitchFamily="34" charset="0"/>
-                <a:ea typeface="Arial" pitchFamily="34" charset="-122"/>
-                <a:cs typeface="Arial" pitchFamily="34" charset="-120"/>
-              </a:rPr>
-              <a:t>Dashboard de monitoring des taux de hit et miss</a:t>
-            </a:r>
-            <a:endParaRPr lang="en-US" sz="1800" dirty="0"/>
-          </a:p>
-        </p:txBody>
-      </p:sp>
-      <p:sp>
-        <p:nvSpPr>
-          <p:cNvPr id="9" name="Shape 7"/>
-          <p:cNvSpPr/>
-          <p:nvPr/>
-        </p:nvSpPr>
-        <p:spPr>
-          <a:xfrm>
-            <a:off x="8503920" y="4754880"/>
-            <a:ext cx="320040" cy="320040"/>
-          </a:xfrm>
-          <a:prstGeom prst="ellipse">
-            <a:avLst/>
-          </a:prstGeom>
-          <a:solidFill>
-            <a:srgbClr val="3182CE"/>
-          </a:solidFill>
-          <a:ln/>
-        </p:spPr>
-      </p:sp>
-      <p:sp>
-        <p:nvSpPr>
-          <p:cNvPr id="10" name="Text 8"/>
-          <p:cNvSpPr/>
-          <p:nvPr/>
-        </p:nvSpPr>
-        <p:spPr>
-          <a:xfrm>
-            <a:off x="8503920" y="4754880"/>
-            <a:ext cx="320040" cy="320040"/>
-          </a:xfrm>
-          <a:prstGeom prst="rect">
-            <a:avLst/>
-          </a:prstGeom>
-          <a:noFill/>
-          <a:ln/>
-        </p:spPr>
-        <p:txBody>
-          <a:bodyPr wrap="square" rtlCol="0" anchor="ctr"/>
-          <a:lstStyle/>
-          <a:p>
-            <a:pPr algn="ctr" indent="0" marL="0">
-              <a:buNone/>
-            </a:pPr>
-            <a:r>
-              <a:rPr lang="en-US" sz="1100" b="1" dirty="0">
-                <a:solidFill>
-                  <a:srgbClr val="FFFFFF"/>
-                </a:solidFill>
-                <a:latin typeface="Arial" pitchFamily="34" charset="0"/>
-                <a:ea typeface="Arial" pitchFamily="34" charset="-122"/>
-                <a:cs typeface="Arial" pitchFamily="34" charset="-120"/>
-              </a:rPr>
               <a:t>19</a:t>
             </a:r>
-            <a:endParaRPr lang="en-US" sz="1100" dirty="0"/>
+            <a:endParaRPr lang="en-US" sz="1200" dirty="0"/>
           </a:p>
         </p:txBody>
       </p:sp>
@@ -11238,7 +9951,7 @@
                 <a:ea typeface="Arial" pitchFamily="34" charset="-122"/>
                 <a:cs typeface="Arial" pitchFamily="34" charset="-120"/>
               </a:rPr>
-              <a:t>HEEC Marrakech - 2026</a:t>
+              <a:t>2026</a:t>
             </a:r>
             <a:endParaRPr lang="en-US" sz="1600" dirty="0"/>
           </a:p>
@@ -11253,23 +9966,23 @@
         <p:spPr>
           <a:xfrm>
             <a:off x="457200" y="3383280"/>
-            <a:ext cx="8229600" cy="365760"/>
-          </a:xfrm>
-          <a:prstGeom prst="rect">
-            <a:avLst/>
-          </a:prstGeom>
-          <a:noFill/>
-          <a:ln/>
-        </p:spPr>
-        <p:txBody>
-          <a:bodyPr wrap="square" rtlCol="0" anchor="ctr"/>
-          <a:lstStyle/>
-          <a:p>
-            <a:pPr algn="ctr" indent="0" marL="0">
-              <a:buNone/>
-            </a:pPr>
-            <a:r>
-              <a:rPr lang="en-US" sz="1800" dirty="0">
+            <a:ext cx="8229600" cy="1371600"/>
+          </a:xfrm>
+          <a:prstGeom prst="rect">
+            <a:avLst/>
+          </a:prstGeom>
+          <a:noFill/>
+          <a:ln/>
+        </p:spPr>
+        <p:txBody>
+          <a:bodyPr wrap="square" rtlCol="0" anchor="t"/>
+          <a:lstStyle/>
+          <a:p>
+            <a:pPr algn="l" indent="0" marL="0">
+              <a:buNone/>
+            </a:pPr>
+            <a:r>
+              <a:rPr lang="en-US" sz="1600" dirty="0">
                 <a:solidFill>
                   <a:srgbClr val="2C5282"/>
                 </a:solidFill>
@@ -11277,22 +9990,42 @@
                 <a:ea typeface="Arial" pitchFamily="34" charset="-122"/>
                 <a:cs typeface="Arial" pitchFamily="34" charset="-120"/>
               </a:rPr>
-              <a:t>Merci pour votre attention</a:t>
-            </a:r>
-            <a:endParaRPr lang="en-US" sz="1800" dirty="0"/>
-          </a:p>
-        </p:txBody>
-      </p:sp>
-      <p:sp>
-        <p:nvSpPr>
-          <p:cNvPr id="10" name="Text 8"/>
-          <p:cNvSpPr/>
-          <p:nvPr/>
-        </p:nvSpPr>
-        <p:spPr>
-          <a:xfrm>
-            <a:off x="457200" y="3794760"/>
-            <a:ext cx="8229600" cy="365760"/>
+              <a:t>Nous vous remercions pour votre attention. Ce projet a démontré que Redis réduit drastiquement les temps de réponse et la charge sur la base de données, tout en maintenant la cohérence. Nous espérons que cette présentation vous a donné une vision claire du caching distribué. N'hésitez pas à poser vos questions.</a:t>
+            </a:r>
+            <a:endParaRPr lang="en-US" sz="1600" dirty="0"/>
+          </a:p>
+        </p:txBody>
+      </p:sp>
+      <p:sp>
+        <p:nvSpPr>
+          <p:cNvPr id="10" name="Shape 8"/>
+          <p:cNvSpPr/>
+          <p:nvPr/>
+        </p:nvSpPr>
+        <p:spPr>
+          <a:xfrm>
+            <a:off x="8503920" y="4754880"/>
+            <a:ext cx="365760" cy="365760"/>
+          </a:xfrm>
+          <a:prstGeom prst="ellipse">
+            <a:avLst/>
+          </a:prstGeom>
+          <a:solidFill>
+            <a:srgbClr val="3182CE"/>
+          </a:solidFill>
+          <a:ln/>
+        </p:spPr>
+      </p:sp>
+      <p:sp>
+        <p:nvSpPr>
+          <p:cNvPr id="11" name="Text 9"/>
+          <p:cNvSpPr/>
+          <p:nvPr/>
+        </p:nvSpPr>
+        <p:spPr>
+          <a:xfrm>
+            <a:off x="8503920" y="4754880"/>
+            <a:ext cx="365760" cy="365760"/>
           </a:xfrm>
           <a:prstGeom prst="rect">
             <a:avLst/>
@@ -11308,115 +10041,17 @@
               <a:buNone/>
             </a:pPr>
             <a:r>
-              <a:rPr lang="en-US" sz="1800" dirty="0">
-                <a:solidFill>
-                  <a:srgbClr val="2C5282"/>
+              <a:rPr lang="en-US" sz="1200" b="1" dirty="0">
+                <a:solidFill>
+                  <a:srgbClr val="FFFFFF"/>
                 </a:solidFill>
                 <a:latin typeface="Arial" pitchFamily="34" charset="0"/>
                 <a:ea typeface="Arial" pitchFamily="34" charset="-122"/>
                 <a:cs typeface="Arial" pitchFamily="34" charset="-120"/>
               </a:rPr>
-              <a:t>Ce projet a démontré l'efficacité du cache distribué</a:t>
-            </a:r>
-            <a:endParaRPr lang="en-US" sz="1800" dirty="0"/>
-          </a:p>
-        </p:txBody>
-      </p:sp>
-      <p:sp>
-        <p:nvSpPr>
-          <p:cNvPr id="11" name="Text 9"/>
-          <p:cNvSpPr/>
-          <p:nvPr/>
-        </p:nvSpPr>
-        <p:spPr>
-          <a:xfrm>
-            <a:off x="457200" y="4206240"/>
-            <a:ext cx="8229600" cy="365760"/>
-          </a:xfrm>
-          <a:prstGeom prst="rect">
-            <a:avLst/>
-          </a:prstGeom>
-          <a:noFill/>
-          <a:ln/>
-        </p:spPr>
-        <p:txBody>
-          <a:bodyPr wrap="square" rtlCol="0" anchor="ctr"/>
-          <a:lstStyle/>
-          <a:p>
-            <a:pPr algn="ctr" indent="0" marL="0">
-              <a:buNone/>
-            </a:pPr>
-            <a:r>
-              <a:rPr lang="en-US" sz="1800" dirty="0">
-                <a:solidFill>
-                  <a:srgbClr val="2C5282"/>
-                </a:solidFill>
-                <a:latin typeface="Arial" pitchFamily="34" charset="0"/>
-                <a:ea typeface="Arial" pitchFamily="34" charset="-122"/>
-                <a:cs typeface="Arial" pitchFamily="34" charset="-120"/>
-              </a:rPr>
-              <a:t>N'hésitez pas à poser vos questions</a:t>
-            </a:r>
-            <a:endParaRPr lang="en-US" sz="1800" dirty="0"/>
-          </a:p>
-        </p:txBody>
-      </p:sp>
-      <p:sp>
-        <p:nvSpPr>
-          <p:cNvPr id="12" name="Shape 10"/>
-          <p:cNvSpPr/>
-          <p:nvPr/>
-        </p:nvSpPr>
-        <p:spPr>
-          <a:xfrm>
-            <a:off x="8503920" y="4754880"/>
-            <a:ext cx="320040" cy="320040"/>
-          </a:xfrm>
-          <a:prstGeom prst="ellipse">
-            <a:avLst/>
-          </a:prstGeom>
-          <a:solidFill>
-            <a:srgbClr val="3182CE"/>
-          </a:solidFill>
-          <a:ln/>
-        </p:spPr>
-      </p:sp>
-      <p:sp>
-        <p:nvSpPr>
-          <p:cNvPr id="13" name="Text 11"/>
-          <p:cNvSpPr/>
-          <p:nvPr/>
-        </p:nvSpPr>
-        <p:spPr>
-          <a:xfrm>
-            <a:off x="8503920" y="4754880"/>
-            <a:ext cx="320040" cy="320040"/>
-          </a:xfrm>
-          <a:prstGeom prst="rect">
-            <a:avLst/>
-          </a:prstGeom>
-          <a:noFill/>
-          <a:ln/>
-        </p:spPr>
-        <p:txBody>
-          <a:bodyPr wrap="square" rtlCol="0" anchor="ctr"/>
-          <a:lstStyle/>
-          <a:p>
-            <a:pPr algn="ctr" indent="0" marL="0">
-              <a:buNone/>
-            </a:pPr>
-            <a:r>
-              <a:rPr lang="en-US" sz="1100" b="1" dirty="0">
-                <a:solidFill>
-                  <a:srgbClr val="FFFFFF"/>
-                </a:solidFill>
-                <a:latin typeface="Arial" pitchFamily="34" charset="0"/>
-                <a:ea typeface="Arial" pitchFamily="34" charset="-122"/>
-                <a:cs typeface="Arial" pitchFamily="34" charset="-120"/>
-              </a:rPr>
               <a:t>20</a:t>
             </a:r>
-            <a:endParaRPr lang="en-US" sz="1100" dirty="0"/>
+            <a:endParaRPr lang="en-US" sz="1200" dirty="0"/>
           </a:p>
         </p:txBody>
       </p:sp>
@@ -11715,11 +10350,11 @@
         <p:spPr>
           <a:xfrm>
             <a:off x="457200" y="3657600"/>
-            <a:ext cx="8229600" cy="1097280"/>
+            <a:ext cx="8229600" cy="914400"/>
           </a:xfrm>
           <a:prstGeom prst="roundRect">
             <a:avLst>
-              <a:gd name="adj" fmla="val 8333"/>
+              <a:gd name="adj" fmla="val 10000"/>
             </a:avLst>
           </a:prstGeom>
           <a:solidFill>
@@ -11781,7 +10416,7 @@
         <p:spPr>
           <a:xfrm>
             <a:off x="640080" y="4069080"/>
-            <a:ext cx="7863840" cy="640080"/>
+            <a:ext cx="7863840" cy="457200"/>
           </a:xfrm>
           <a:prstGeom prst="rect">
             <a:avLst/>
@@ -16090,17 +14725,17 @@
         </p:nvSpPr>
         <p:spPr>
           <a:xfrm>
-            <a:off x="640080" y="3566160"/>
-            <a:ext cx="7863840" cy="256032"/>
-          </a:xfrm>
-          <a:prstGeom prst="rect">
-            <a:avLst/>
-          </a:prstGeom>
-          <a:noFill/>
-          <a:ln/>
-        </p:spPr>
-        <p:txBody>
-          <a:bodyPr wrap="square" rtlCol="0" anchor="ctr"/>
+            <a:off x="457200" y="3383280"/>
+            <a:ext cx="8229600" cy="1371600"/>
+          </a:xfrm>
+          <a:prstGeom prst="rect">
+            <a:avLst/>
+          </a:prstGeom>
+          <a:noFill/>
+          <a:ln/>
+        </p:spPr>
+        <p:txBody>
+          <a:bodyPr wrap="square" rtlCol="0" anchor="t"/>
           <a:lstStyle/>
           <a:p>
             <a:pPr algn="l" indent="0" marL="0">
@@ -16115,7 +14750,7 @@
                 <a:ea typeface="Arial" pitchFamily="34" charset="-122"/>
                 <a:cs typeface="Arial" pitchFamily="34" charset="-120"/>
               </a:rPr>
-              <a:t>Clé unique générée avec filter, sort, search</a:t>
+              <a:t>Voici getLaunches en action. Elle génère une clé unique avec filter, sort et search. Elle vérifie le cache et retourne les résultats s'ils existent. Sinon, elle interroge PostgreSQL, stocke avec un TTL de 300 secondes, puis retourne. L'invalidation est déclenchée lors des opérations d'écriture.</a:t>
             </a:r>
             <a:endParaRPr lang="en-US" sz="1600" dirty="0"/>
           </a:p>
@@ -16123,177 +14758,60 @@
       </p:sp>
       <p:sp>
         <p:nvSpPr>
-          <p:cNvPr id="20" name="Text 18"/>
-          <p:cNvSpPr/>
-          <p:nvPr/>
-        </p:nvSpPr>
-        <p:spPr>
-          <a:xfrm>
-            <a:off x="640080" y="3858768"/>
-            <a:ext cx="7863840" cy="256032"/>
-          </a:xfrm>
-          <a:prstGeom prst="rect">
-            <a:avLst/>
-          </a:prstGeom>
-          <a:noFill/>
-          <a:ln/>
-        </p:spPr>
-        <p:txBody>
-          <a:bodyPr wrap="square" rtlCol="0" anchor="ctr"/>
-          <a:lstStyle/>
-          <a:p>
-            <a:pPr algn="l" indent="0" marL="0">
-              <a:buNone/>
-            </a:pPr>
-            <a:r>
-              <a:rPr lang="en-US" sz="1600" dirty="0">
-                <a:solidFill>
-                  <a:srgbClr val="2C5282"/>
+          <p:cNvPr id="20" name="Shape 18"/>
+          <p:cNvSpPr/>
+          <p:nvPr/>
+        </p:nvSpPr>
+        <p:spPr>
+          <a:xfrm>
+            <a:off x="8503920" y="4754880"/>
+            <a:ext cx="365760" cy="365760"/>
+          </a:xfrm>
+          <a:prstGeom prst="ellipse">
+            <a:avLst/>
+          </a:prstGeom>
+          <a:solidFill>
+            <a:srgbClr val="3182CE"/>
+          </a:solidFill>
+          <a:ln/>
+        </p:spPr>
+      </p:sp>
+      <p:sp>
+        <p:nvSpPr>
+          <p:cNvPr id="21" name="Text 19"/>
+          <p:cNvSpPr/>
+          <p:nvPr/>
+        </p:nvSpPr>
+        <p:spPr>
+          <a:xfrm>
+            <a:off x="8503920" y="4754880"/>
+            <a:ext cx="365760" cy="365760"/>
+          </a:xfrm>
+          <a:prstGeom prst="rect">
+            <a:avLst/>
+          </a:prstGeom>
+          <a:noFill/>
+          <a:ln/>
+        </p:spPr>
+        <p:txBody>
+          <a:bodyPr wrap="square" rtlCol="0" anchor="ctr"/>
+          <a:lstStyle/>
+          <a:p>
+            <a:pPr algn="ctr" indent="0" marL="0">
+              <a:buNone/>
+            </a:pPr>
+            <a:r>
+              <a:rPr lang="en-US" sz="1200" b="1" dirty="0">
+                <a:solidFill>
+                  <a:srgbClr val="FFFFFF"/>
                 </a:solidFill>
                 <a:latin typeface="Arial" pitchFamily="34" charset="0"/>
                 <a:ea typeface="Arial" pitchFamily="34" charset="-122"/>
                 <a:cs typeface="Arial" pitchFamily="34" charset="-120"/>
               </a:rPr>
-              <a:t>TTL de 300 secondes pour les lancements</a:t>
-            </a:r>
-            <a:endParaRPr lang="en-US" sz="1600" dirty="0"/>
-          </a:p>
-        </p:txBody>
-      </p:sp>
-      <p:sp>
-        <p:nvSpPr>
-          <p:cNvPr id="21" name="Text 19"/>
-          <p:cNvSpPr/>
-          <p:nvPr/>
-        </p:nvSpPr>
-        <p:spPr>
-          <a:xfrm>
-            <a:off x="640080" y="4151376"/>
-            <a:ext cx="7863840" cy="256032"/>
-          </a:xfrm>
-          <a:prstGeom prst="rect">
-            <a:avLst/>
-          </a:prstGeom>
-          <a:noFill/>
-          <a:ln/>
-        </p:spPr>
-        <p:txBody>
-          <a:bodyPr wrap="square" rtlCol="0" anchor="ctr"/>
-          <a:lstStyle/>
-          <a:p>
-            <a:pPr algn="l" indent="0" marL="0">
-              <a:buNone/>
-            </a:pPr>
-            <a:r>
-              <a:rPr lang="en-US" sz="1600" dirty="0">
-                <a:solidFill>
-                  <a:srgbClr val="2C5282"/>
-                </a:solidFill>
-                <a:latin typeface="Arial" pitchFamily="34" charset="0"/>
-                <a:ea typeface="Arial" pitchFamily="34" charset="-122"/>
-                <a:cs typeface="Arial" pitchFamily="34" charset="-120"/>
-              </a:rPr>
-              <a:t>Invalidation déclenchée lors des écritures</a:t>
-            </a:r>
-            <a:endParaRPr lang="en-US" sz="1600" dirty="0"/>
-          </a:p>
-        </p:txBody>
-      </p:sp>
-      <p:sp>
-        <p:nvSpPr>
-          <p:cNvPr id="22" name="Text 20"/>
-          <p:cNvSpPr/>
-          <p:nvPr/>
-        </p:nvSpPr>
-        <p:spPr>
-          <a:xfrm>
-            <a:off x="640080" y="4443984"/>
-            <a:ext cx="7863840" cy="256032"/>
-          </a:xfrm>
-          <a:prstGeom prst="rect">
-            <a:avLst/>
-          </a:prstGeom>
-          <a:noFill/>
-          <a:ln/>
-        </p:spPr>
-        <p:txBody>
-          <a:bodyPr wrap="square" rtlCol="0" anchor="ctr"/>
-          <a:lstStyle/>
-          <a:p>
-            <a:pPr algn="l" indent="0" marL="0">
-              <a:buNone/>
-            </a:pPr>
-            <a:r>
-              <a:rPr lang="en-US" sz="1600" dirty="0">
-                <a:solidFill>
-                  <a:srgbClr val="2C5282"/>
-                </a:solidFill>
-                <a:latin typeface="Arial" pitchFamily="34" charset="0"/>
-                <a:ea typeface="Arial" pitchFamily="34" charset="-122"/>
-                <a:cs typeface="Arial" pitchFamily="34" charset="-120"/>
-              </a:rPr>
-              <a:t>Opérations similaires pour getPosts, getCategories</a:t>
-            </a:r>
-            <a:endParaRPr lang="en-US" sz="1600" dirty="0"/>
-          </a:p>
-        </p:txBody>
-      </p:sp>
-      <p:sp>
-        <p:nvSpPr>
-          <p:cNvPr id="23" name="Shape 21"/>
-          <p:cNvSpPr/>
-          <p:nvPr/>
-        </p:nvSpPr>
-        <p:spPr>
-          <a:xfrm>
-            <a:off x="8503920" y="4754880"/>
-            <a:ext cx="320040" cy="320040"/>
-          </a:xfrm>
-          <a:prstGeom prst="ellipse">
-            <a:avLst/>
-          </a:prstGeom>
-          <a:solidFill>
-            <a:srgbClr val="3182CE"/>
-          </a:solidFill>
-          <a:ln/>
-        </p:spPr>
-      </p:sp>
-      <p:sp>
-        <p:nvSpPr>
-          <p:cNvPr id="24" name="Text 22"/>
-          <p:cNvSpPr/>
-          <p:nvPr/>
-        </p:nvSpPr>
-        <p:spPr>
-          <a:xfrm>
-            <a:off x="8503920" y="4754880"/>
-            <a:ext cx="320040" cy="320040"/>
-          </a:xfrm>
-          <a:prstGeom prst="rect">
-            <a:avLst/>
-          </a:prstGeom>
-          <a:noFill/>
-          <a:ln/>
-        </p:spPr>
-        <p:txBody>
-          <a:bodyPr wrap="square" rtlCol="0" anchor="ctr"/>
-          <a:lstStyle/>
-          <a:p>
-            <a:pPr algn="ctr" indent="0" marL="0">
-              <a:buNone/>
-            </a:pPr>
-            <a:r>
-              <a:rPr lang="en-US" sz="1100" b="1" dirty="0">
-                <a:solidFill>
-                  <a:srgbClr val="FFFFFF"/>
-                </a:solidFill>
-                <a:latin typeface="Arial" pitchFamily="34" charset="0"/>
-                <a:ea typeface="Arial" pitchFamily="34" charset="-122"/>
-                <a:cs typeface="Arial" pitchFamily="34" charset="-120"/>
-              </a:rPr>
               <a:t>8</a:t>
             </a:r>
-            <a:endParaRPr lang="en-US" sz="1100" dirty="0"/>
+            <a:endParaRPr lang="en-US" sz="1200" dirty="0"/>
           </a:p>
         </p:txBody>
       </p:sp>
@@ -16808,17 +15326,17 @@
         </p:nvSpPr>
         <p:spPr>
           <a:xfrm>
-            <a:off x="640080" y="3108960"/>
-            <a:ext cx="7863840" cy="274320"/>
-          </a:xfrm>
-          <a:prstGeom prst="rect">
-            <a:avLst/>
-          </a:prstGeom>
-          <a:noFill/>
-          <a:ln/>
-        </p:spPr>
-        <p:txBody>
-          <a:bodyPr wrap="square" rtlCol="0" anchor="ctr"/>
+            <a:off x="457200" y="3108960"/>
+            <a:ext cx="8229600" cy="1463040"/>
+          </a:xfrm>
+          <a:prstGeom prst="rect">
+            <a:avLst/>
+          </a:prstGeom>
+          <a:noFill/>
+          <a:ln/>
+        </p:spPr>
+        <p:txBody>
+          <a:bodyPr wrap="square" rtlCol="0" anchor="t"/>
           <a:lstStyle/>
           <a:p>
             <a:pPr algn="l" indent="0" marL="0">
@@ -16833,7 +15351,7 @@
                 <a:ea typeface="Arial" pitchFamily="34" charset="-122"/>
                 <a:cs typeface="Arial" pitchFamily="34" charset="-120"/>
               </a:rPr>
-              <a:t>Clé générée à partir de sort, type et search</a:t>
+              <a:t>De la même manière, getPosts utilise une clé générée à partir de sort, type et search. Le TTL est de 180 secondes car les posts changent plus fréquemment. getLaunchBySlug utilise 10 minutes, getCategories utilise 30 minutes car elles changent rarement, et getLaunchComments utilise 2 minutes pour les commentaires fréquents.</a:t>
             </a:r>
             <a:endParaRPr lang="en-US" sz="1600" dirty="0"/>
           </a:p>
@@ -16841,216 +15359,60 @@
       </p:sp>
       <p:sp>
         <p:nvSpPr>
-          <p:cNvPr id="16" name="Text 14"/>
-          <p:cNvSpPr/>
-          <p:nvPr/>
-        </p:nvSpPr>
-        <p:spPr>
-          <a:xfrm>
-            <a:off x="640080" y="3429000"/>
-            <a:ext cx="7863840" cy="274320"/>
-          </a:xfrm>
-          <a:prstGeom prst="rect">
-            <a:avLst/>
-          </a:prstGeom>
-          <a:noFill/>
-          <a:ln/>
-        </p:spPr>
-        <p:txBody>
-          <a:bodyPr wrap="square" rtlCol="0" anchor="ctr"/>
-          <a:lstStyle/>
-          <a:p>
-            <a:pPr algn="l" indent="0" marL="0">
-              <a:buNone/>
-            </a:pPr>
-            <a:r>
-              <a:rPr lang="en-US" sz="1600" dirty="0">
-                <a:solidFill>
-                  <a:srgbClr val="2C5282"/>
+          <p:cNvPr id="16" name="Shape 14"/>
+          <p:cNvSpPr/>
+          <p:nvPr/>
+        </p:nvSpPr>
+        <p:spPr>
+          <a:xfrm>
+            <a:off x="8503920" y="4754880"/>
+            <a:ext cx="365760" cy="365760"/>
+          </a:xfrm>
+          <a:prstGeom prst="ellipse">
+            <a:avLst/>
+          </a:prstGeom>
+          <a:solidFill>
+            <a:srgbClr val="3182CE"/>
+          </a:solidFill>
+          <a:ln/>
+        </p:spPr>
+      </p:sp>
+      <p:sp>
+        <p:nvSpPr>
+          <p:cNvPr id="17" name="Text 15"/>
+          <p:cNvSpPr/>
+          <p:nvPr/>
+        </p:nvSpPr>
+        <p:spPr>
+          <a:xfrm>
+            <a:off x="8503920" y="4754880"/>
+            <a:ext cx="365760" cy="365760"/>
+          </a:xfrm>
+          <a:prstGeom prst="rect">
+            <a:avLst/>
+          </a:prstGeom>
+          <a:noFill/>
+          <a:ln/>
+        </p:spPr>
+        <p:txBody>
+          <a:bodyPr wrap="square" rtlCol="0" anchor="ctr"/>
+          <a:lstStyle/>
+          <a:p>
+            <a:pPr algn="ctr" indent="0" marL="0">
+              <a:buNone/>
+            </a:pPr>
+            <a:r>
+              <a:rPr lang="en-US" sz="1200" b="1" dirty="0">
+                <a:solidFill>
+                  <a:srgbClr val="FFFFFF"/>
                 </a:solidFill>
                 <a:latin typeface="Arial" pitchFamily="34" charset="0"/>
                 <a:ea typeface="Arial" pitchFamily="34" charset="-122"/>
                 <a:cs typeface="Arial" pitchFamily="34" charset="-120"/>
               </a:rPr>
-              <a:t>TTL de 180s car les posts changent fréquemment</a:t>
-            </a:r>
-            <a:endParaRPr lang="en-US" sz="1600" dirty="0"/>
-          </a:p>
-        </p:txBody>
-      </p:sp>
-      <p:sp>
-        <p:nvSpPr>
-          <p:cNvPr id="17" name="Text 15"/>
-          <p:cNvSpPr/>
-          <p:nvPr/>
-        </p:nvSpPr>
-        <p:spPr>
-          <a:xfrm>
-            <a:off x="640080" y="3749040"/>
-            <a:ext cx="7863840" cy="274320"/>
-          </a:xfrm>
-          <a:prstGeom prst="rect">
-            <a:avLst/>
-          </a:prstGeom>
-          <a:noFill/>
-          <a:ln/>
-        </p:spPr>
-        <p:txBody>
-          <a:bodyPr wrap="square" rtlCol="0" anchor="ctr"/>
-          <a:lstStyle/>
-          <a:p>
-            <a:pPr algn="l" indent="0" marL="0">
-              <a:buNone/>
-            </a:pPr>
-            <a:r>
-              <a:rPr lang="en-US" sz="1600" dirty="0">
-                <a:solidFill>
-                  <a:srgbClr val="2C5282"/>
-                </a:solidFill>
-                <a:latin typeface="Arial" pitchFamily="34" charset="0"/>
-                <a:ea typeface="Arial" pitchFamily="34" charset="-122"/>
-                <a:cs typeface="Arial" pitchFamily="34" charset="-120"/>
-              </a:rPr>
-              <a:t>getLaunchBySlug : 10 minutes</a:t>
-            </a:r>
-            <a:endParaRPr lang="en-US" sz="1600" dirty="0"/>
-          </a:p>
-        </p:txBody>
-      </p:sp>
-      <p:sp>
-        <p:nvSpPr>
-          <p:cNvPr id="18" name="Text 16"/>
-          <p:cNvSpPr/>
-          <p:nvPr/>
-        </p:nvSpPr>
-        <p:spPr>
-          <a:xfrm>
-            <a:off x="640080" y="4069080"/>
-            <a:ext cx="7863840" cy="274320"/>
-          </a:xfrm>
-          <a:prstGeom prst="rect">
-            <a:avLst/>
-          </a:prstGeom>
-          <a:noFill/>
-          <a:ln/>
-        </p:spPr>
-        <p:txBody>
-          <a:bodyPr wrap="square" rtlCol="0" anchor="ctr"/>
-          <a:lstStyle/>
-          <a:p>
-            <a:pPr algn="l" indent="0" marL="0">
-              <a:buNone/>
-            </a:pPr>
-            <a:r>
-              <a:rPr lang="en-US" sz="1600" dirty="0">
-                <a:solidFill>
-                  <a:srgbClr val="2C5282"/>
-                </a:solidFill>
-                <a:latin typeface="Arial" pitchFamily="34" charset="0"/>
-                <a:ea typeface="Arial" pitchFamily="34" charset="-122"/>
-                <a:cs typeface="Arial" pitchFamily="34" charset="-120"/>
-              </a:rPr>
-              <a:t>getCategories : 30 minutes</a:t>
-            </a:r>
-            <a:endParaRPr lang="en-US" sz="1600" dirty="0"/>
-          </a:p>
-        </p:txBody>
-      </p:sp>
-      <p:sp>
-        <p:nvSpPr>
-          <p:cNvPr id="19" name="Text 17"/>
-          <p:cNvSpPr/>
-          <p:nvPr/>
-        </p:nvSpPr>
-        <p:spPr>
-          <a:xfrm>
-            <a:off x="640080" y="4389120"/>
-            <a:ext cx="7863840" cy="274320"/>
-          </a:xfrm>
-          <a:prstGeom prst="rect">
-            <a:avLst/>
-          </a:prstGeom>
-          <a:noFill/>
-          <a:ln/>
-        </p:spPr>
-        <p:txBody>
-          <a:bodyPr wrap="square" rtlCol="0" anchor="ctr"/>
-          <a:lstStyle/>
-          <a:p>
-            <a:pPr algn="l" indent="0" marL="0">
-              <a:buNone/>
-            </a:pPr>
-            <a:r>
-              <a:rPr lang="en-US" sz="1600" dirty="0">
-                <a:solidFill>
-                  <a:srgbClr val="2C5282"/>
-                </a:solidFill>
-                <a:latin typeface="Arial" pitchFamily="34" charset="0"/>
-                <a:ea typeface="Arial" pitchFamily="34" charset="-122"/>
-                <a:cs typeface="Arial" pitchFamily="34" charset="-120"/>
-              </a:rPr>
-              <a:t>getLaunchComments : 2 minutes</a:t>
-            </a:r>
-            <a:endParaRPr lang="en-US" sz="1600" dirty="0"/>
-          </a:p>
-        </p:txBody>
-      </p:sp>
-      <p:sp>
-        <p:nvSpPr>
-          <p:cNvPr id="20" name="Shape 18"/>
-          <p:cNvSpPr/>
-          <p:nvPr/>
-        </p:nvSpPr>
-        <p:spPr>
-          <a:xfrm>
-            <a:off x="8503920" y="4754880"/>
-            <a:ext cx="320040" cy="320040"/>
-          </a:xfrm>
-          <a:prstGeom prst="ellipse">
-            <a:avLst/>
-          </a:prstGeom>
-          <a:solidFill>
-            <a:srgbClr val="3182CE"/>
-          </a:solidFill>
-          <a:ln/>
-        </p:spPr>
-      </p:sp>
-      <p:sp>
-        <p:nvSpPr>
-          <p:cNvPr id="21" name="Text 19"/>
-          <p:cNvSpPr/>
-          <p:nvPr/>
-        </p:nvSpPr>
-        <p:spPr>
-          <a:xfrm>
-            <a:off x="8503920" y="4754880"/>
-            <a:ext cx="320040" cy="320040"/>
-          </a:xfrm>
-          <a:prstGeom prst="rect">
-            <a:avLst/>
-          </a:prstGeom>
-          <a:noFill/>
-          <a:ln/>
-        </p:spPr>
-        <p:txBody>
-          <a:bodyPr wrap="square" rtlCol="0" anchor="ctr"/>
-          <a:lstStyle/>
-          <a:p>
-            <a:pPr algn="ctr" indent="0" marL="0">
-              <a:buNone/>
-            </a:pPr>
-            <a:r>
-              <a:rPr lang="en-US" sz="1100" b="1" dirty="0">
-                <a:solidFill>
-                  <a:srgbClr val="FFFFFF"/>
-                </a:solidFill>
-                <a:latin typeface="Arial" pitchFamily="34" charset="0"/>
-                <a:ea typeface="Arial" pitchFamily="34" charset="-122"/>
-                <a:cs typeface="Arial" pitchFamily="34" charset="-120"/>
-              </a:rPr>
               <a:t>9</a:t>
             </a:r>
-            <a:endParaRPr lang="en-US" sz="1100" dirty="0"/>
+            <a:endParaRPr lang="en-US" sz="1200" dirty="0"/>
           </a:p>
         </p:txBody>
       </p:sp>

</xml_diff>

<commit_message>
Slides have minimal text, full speaking scripts moved to speaker notes, 10 slides Omar/Iliass split
</commit_message>
<xml_diff>
--- a/output/Presentation_Cache_Redis.pptx
+++ b/output/Presentation_Cache_Redis.pptx
@@ -511,7 +511,7 @@
           <a:p>
             <a:r>
               <a:rPr lang="en-US" dirty="0"/>
-              <a:t>Bonjour, je suis Omar Sarsar et je suis accompagné d'Iliass Hariz. Nous allons présenter notre projet d'intégration d'un cache distribué Redis dans une application marketplace SaaS. Nous allons décrire le contexte, l'architecture, l'implémentation, les tests et les résultats.</a:t>
+              <a:t>Bonjour, je suis Omar Sarsar et je suis accompagné d'Iliass Hariz. Nous allons présenter notre projet d'intégration d'un cache distribué Redis dans une application marketplace SaaS. Ce projet a été réalisé dans le cadre de notre formation. Nous allons décrire le contexte, l'architecture, l'implémentation, les tests et les résultats.</a:t>
             </a:r>
             <a:endParaRPr lang="en-US" dirty="0"/>
           </a:p>
@@ -599,7 +599,7 @@
           <a:p>
             <a:r>
               <a:rPr lang="en-US" dirty="0"/>
-              <a:t>Nous vous remercions pour votre attention. Ce projet a demontre que Redis reduit drastiquement les temps de reponse et la charge sur la base de donnees, tout en maintenant la coherence. Nous esperons que cette presentation vous a donne une vision claire du caching distribue.</a:t>
+              <a:t>Nous vous remercions pour votre attention. Ce projet a demontre que Redis peut reduire drastiquement les temps de reponse et la charge sur la base de donnees, tout en maintenant la coherence des donnees grace a une strategie d'invalidation appropriee. Nous esperons que cette presentation vous a donne une vision claire des avantages et des bonnes pratiques du caching distribue. N'hesitez pas a nous poser des questions sur les aspects techniques, les performances ou les ameliorations futures envisagees.</a:t>
             </a:r>
             <a:endParaRPr lang="en-US" dirty="0"/>
           </a:p>
@@ -687,7 +687,7 @@
           <a:p>
             <a:r>
               <a:rPr lang="en-US" dirty="0"/>
-              <a:t>Ce projet intègre un cache distribué Redis dans une application marketplace SaaS. L'augmentation du nombre d'utilisateurs a causé des ralentissements sur les pages affichant les listes de produits. L'objectif est d'améliorer les performances en vérifiant le cache avant PostgreSQL.</a:t>
+              <a:t>Ce projet intègre un cache distribué Redis dans une application marketplace SaaS. Cette application permet aux utilisateurs de lancer et vendre des produits logiciels avec un système de messagerie. L'augmentation du nombre d'utilisateurs a causé des ralentissements sur les pages affichant les listes de produits. L'objectif est d'améliorer les performances en vérifiant le cache avant PostgreSQL, ce qui réduit le temps de réponse et la charge sur la base de données tout en maintenant la cohérence via une stratégie d'invalidation. Pour atteindre cet objectif, nous avons déployé Redis avec Docker Compose, modifié l'application pour utiliser le cache en lecture et écriture, puis mesuré l'amélioration des performances.</a:t>
             </a:r>
             <a:endParaRPr lang="en-US" dirty="0"/>
           </a:p>
@@ -775,7 +775,7 @@
           <a:p>
             <a:r>
               <a:rPr lang="en-US" dirty="0"/>
-              <a:t>Notre architecture utilise le pattern Cache-Aside. L'application vérifie d'abord Redis. Si les données y sont, elles sont retournées immédiatement. Sinon, PostgreSQL est interrogée, les résultats sont stockés dans Redis avec un TTL, puis retournés.</a:t>
+              <a:t>Notre architecture utilise le pattern Cache-Aside, aussi appele Lazy Loading. Quand l'application Next.js recoit une requete, elle verifie d'abord si les donnees sont disponibles dans le cache Redis. Si elles y sont, l'application les retourne immediatement sans interroger la base de donnees. Si les donnees ne sont pas dans le cache, l'application les recupere depuis PostgreSQL, les stocke dans Redis avec un temps de vie defini, puis les retourne au client. Cette approche permet de servir les requetes frequentes directement depuis la memoire, ce qui est beaucoup plus rapide que d'interroger la base de donnees a chaque fois.</a:t>
             </a:r>
             <a:endParaRPr lang="en-US" dirty="0"/>
           </a:p>
@@ -863,7 +863,7 @@
           <a:p>
             <a:r>
               <a:rPr lang="en-US" dirty="0"/>
-              <a:t>L'infrastructure utilise Docker Compose avec trois services. PostgreSQL 16 sur Alpine sert de base de données sur le port 5434. Redis 7 sur Alpine fonctionne comme cache sur le port 6379 avec un volume persistant et un healthcheck. La couche d'abstraction simplifie l'intégration.</a:t>
+              <a:t>L'infrastructure de notre projet est entierement containerisee avec Docker Compose. Nous utilisons PostgreSQL version 16 sur Alpine comme base de donnees principale, Redis version 7 sur Alpine comme serveur de cache distribue en memoire, et notre application Next.js est construite a partir d'un Dockerfile personnalise. La configuration Redis inclut un volume persistant pour les donnees nomme redis_data, un healthcheck integre pour surveiller l'etat du service, et une connexion via la variable d'environnement REDIS_URL. Le demarrage automatique est gere par Docker Compose, ce qui facilite grandement le deploiement et la maintenance de l'infrastructure.</a:t>
             </a:r>
             <a:endParaRPr lang="en-US" dirty="0"/>
           </a:p>
@@ -951,7 +951,7 @@
           <a:p>
             <a:r>
               <a:rPr lang="en-US" dirty="0"/>
-              <a:t>L'intégration suit le pattern Cache-Aside. Chaque action génère une clé unique et vérifie Redis. Si les données existent, elles sont retournées. Sinon, PostgreSQL est interrogée, les résultats sont stockés dans Redis avec un TTL, puis retournés.</a:t>
+              <a:t>La couche d'abstraction du cache est le coeur de notre solution. Elle se trouve dans le fichier src/lib/cache.ts et fournit une interface simple et reutilisable pour interagir avec Redis. La fonction cacheGet permet de recuperer des donnees en specifiant le type generique T pour le typage TypeScript. Elle recupere la valeur depuis Redis et la parse depuis JSON. La fonction cacheSet permet de stocker des donnees avec un temps de vie configurable, qui est de 300 secondes par defaut mais peut etre ajuste selon les besoins. Cette abstraction cache toute la complexite de la connexion Redis et de la serialisation JSON, ce qui rend l'integration tres simple dans le reste de l'application.</a:t>
             </a:r>
             <a:endParaRPr lang="en-US" dirty="0"/>
           </a:p>
@@ -1039,7 +1039,7 @@
           <a:p>
             <a:r>
               <a:rPr lang="en-US" dirty="0"/>
-              <a:t>Transition : Iliass Hariz prend la suite. L'invalidation est essentielle pour la cohérence. Chaque opération d'écriture invalide immédiatement le cache. Nous avons mis en place des tests unitaires avec Jest couvrant cacheSet, cacheGet et invalidateCache.</a:t>
+              <a:t>L'integration du cache dans les actions de l'application suit le pattern Cache-Aside que nous avons vu precedemment. Concretement, quand une action est appelee comme getLaunches ou getPosts, elle genere d'abord une cle de cache unique basee sur les parametres de la requete. Ensuite, elle verifie si des donnees sont deja presentes dans Redis avec cette cle. Si c'est le cas, elles sont retournees immediatement. Sinon, l'action interroge la base de donnees PostgreSQL, stocke les resultats dans Redis avec un TTL approprie, puis les retourne. Cette logique est appliquee de maniere coherente sur toutes les operations de lecture frequentes.</a:t>
             </a:r>
             <a:endParaRPr lang="en-US" dirty="0"/>
           </a:p>
@@ -1127,7 +1127,7 @@
           <a:p>
             <a:r>
               <a:rPr lang="en-US" dirty="0"/>
-              <a:t>Les resultats sont tres satisfaisants : les huit tests passent tous avec succes, soit cent pour cent de reussite. Ces tests couvrent les operations de base, l'invalidation, le TTL avec expirations automatiques, et les cas limites comme null ou undefined.</a:t>
+              <a:t>Transition : Iliass Hariz prend la suite. La strategie d'invalidation du cache est essentielle pour maintenir la coherence des donnees. Chaque fois qu'une operation d'ecriture est effectuee comme la creation, la mise a jour, la suppression ou l'upvote d'un lancement, le cache est invalide immediatement. La fonction invalidateCache supprime les cles correspondantes de Redis pour forcer les relectures ulterieures a aller chercher les donnees dans la base de donnees. Nous utilisons egalement le TTL comme mecanisme d'expiration automatique. Les cles de cache sont normalisees avec un prefixe saas: pour eviter les collisions et faciliter la gestion.</a:t>
             </a:r>
             <a:endParaRPr lang="en-US" dirty="0"/>
           </a:p>
@@ -1215,7 +1215,7 @@
           <a:p>
             <a:r>
               <a:rPr lang="en-US" dirty="0"/>
-              <a:t>Les mesures montrent des resultats impressionnants. Avec le cache Redis, le temps de reponse moyen est de douze millisecondes contre huit cent cinquante-six millisecondes sans cache, soit quatre-vingt-dix-neuf pour cent d'amelioration. Les requetes getLaunches passent de plusieurs centaines de millisecondes a moins de quinze millisecondes.</a:t>
+              <a:t>Les resultats des tests unitaires sont tres satisfaisants. Les huit tests ecrits passent tous avec succes, soit cent pour cent de reussite. Ces tests couvrent les operations de base comme cacheGet et cacheSet, l'invalidation avec invalidateCache, le comportement du TTL avec les expirations automatiques, et des cas limites comme la gestion des donnees null ou undefined. La couverture est complete pour les fonctions principales de la couche d'abstraction. Ces resultats nous donnent confiance dans la fiabilite du cache et nous permettent d'evoluer en toute securite. Les tests sont executes automatiquement dans la pipeline d'integration continue.</a:t>
             </a:r>
             <a:endParaRPr lang="en-US" dirty="0"/>
           </a:p>
@@ -1303,7 +1303,7 @@
           <a:p>
             <a:r>
               <a:rPr lang="en-US" dirty="0"/>
-              <a:t>En conclusion, tous les objectifs ont ete atteints. Le temps de reponse moyen a ete reduit de quatre-vingt-dix-neuf pour cent. La charge sur PostgreSQL a diminue de quatre-vingt-cinq pour cent. Les huit tests unitaires passent tous. Pour l'avenir, nous envisageons un cluster Redis avec replication.</a:t>
+              <a:t>Les mesures de performance montrent des resultats impressionnants. Avec le cache Redis, le temps de reponse moyen est de douze millisecondes contre huit cent cinquante-six millisecondes sans cache, soit quatre-vingt-dix-neuf pour cent d'amelioration. Les requetes getLaunches, les plus frequentes sur la page d'accueil, passent de plusieurs centaines de millisecondes a moins de quinze millisecondes. L'operation getPosts pour le feed passe de six cent quarante-trois a quinze millisecondes. getLaunchBySlug pour la page detaillee d'un produit passe de deux cent trente-quatre a huit millisecondes. Enfin, getCategories, qui change rarement, passe de cent quatre-vingt-neuf a cinq millisecondes. Ces resultats demontrent l'efficacite du cache Redis sur tous les types de requetes.</a:t>
             </a:r>
             <a:endParaRPr lang="en-US" dirty="0"/>
           </a:p>
@@ -1762,8 +1762,8 @@
         </p:nvSpPr>
         <p:spPr>
           <a:xfrm>
-            <a:off x="457200" y="2286000"/>
-            <a:ext cx="8229600" cy="457200"/>
+            <a:off x="457200" y="2560320"/>
+            <a:ext cx="8229600" cy="365760"/>
           </a:xfrm>
           <a:prstGeom prst="rect">
             <a:avLst/>
@@ -1779,17 +1779,17 @@
               <a:buNone/>
             </a:pPr>
             <a:r>
-              <a:rPr lang="en-US" sz="1800" dirty="0">
-                <a:solidFill>
-                  <a:srgbClr val="E2E8F0"/>
-                </a:solidFill>
-                <a:latin typeface="Arial" pitchFamily="34" charset="0"/>
-                <a:ea typeface="Arial" pitchFamily="34" charset="-122"/>
-                <a:cs typeface="Arial" pitchFamily="34" charset="-120"/>
-              </a:rPr>
-              <a:t>Intégration d'un cache distribué (Redis) à une application web existante</a:t>
-            </a:r>
-            <a:endParaRPr lang="en-US" sz="1800" dirty="0"/>
+              <a:rPr lang="en-US" sz="2000" b="1" dirty="0">
+                <a:solidFill>
+                  <a:srgbClr val="FFFFFF"/>
+                </a:solidFill>
+                <a:latin typeface="Arial" pitchFamily="34" charset="0"/>
+                <a:ea typeface="Arial" pitchFamily="34" charset="-122"/>
+                <a:cs typeface="Arial" pitchFamily="34" charset="-120"/>
+              </a:rPr>
+              <a:t>Omar Sarsar &amp; Iliass Hariz</a:t>
+            </a:r>
+            <a:endParaRPr lang="en-US" sz="2000" dirty="0"/>
           </a:p>
         </p:txBody>
       </p:sp>
@@ -1801,46 +1801,7 @@
         </p:nvSpPr>
         <p:spPr>
           <a:xfrm>
-            <a:off x="457200" y="2926080"/>
-            <a:ext cx="8229600" cy="365760"/>
-          </a:xfrm>
-          <a:prstGeom prst="rect">
-            <a:avLst/>
-          </a:prstGeom>
-          <a:noFill/>
-          <a:ln/>
-        </p:spPr>
-        <p:txBody>
-          <a:bodyPr wrap="square" rtlCol="0" anchor="ctr"/>
-          <a:lstStyle/>
-          <a:p>
-            <a:pPr algn="ctr" indent="0" marL="0">
-              <a:buNone/>
-            </a:pPr>
-            <a:r>
-              <a:rPr lang="en-US" sz="2000" b="1" dirty="0">
-                <a:solidFill>
-                  <a:srgbClr val="FFFFFF"/>
-                </a:solidFill>
-                <a:latin typeface="Arial" pitchFamily="34" charset="0"/>
-                <a:ea typeface="Arial" pitchFamily="34" charset="-122"/>
-                <a:cs typeface="Arial" pitchFamily="34" charset="-120"/>
-              </a:rPr>
-              <a:t>Omar Sarsar &amp; Iliass Hariz</a:t>
-            </a:r>
-            <a:endParaRPr lang="en-US" sz="2000" dirty="0"/>
-          </a:p>
-        </p:txBody>
-      </p:sp>
-      <p:sp>
-        <p:nvSpPr>
-          <p:cNvPr id="6" name="Text 4"/>
-          <p:cNvSpPr/>
-          <p:nvPr/>
-        </p:nvSpPr>
-        <p:spPr>
-          <a:xfrm>
-            <a:off x="457200" y="3383280"/>
+            <a:off x="457200" y="3017520"/>
             <a:ext cx="8229600" cy="274320"/>
           </a:xfrm>
           <a:prstGeom prst="rect">
@@ -2010,11 +1971,11 @@
         <p:spPr>
           <a:xfrm>
             <a:off x="2286000" y="2286000"/>
-            <a:ext cx="4572000" cy="1097280"/>
+            <a:ext cx="4572000" cy="914400"/>
           </a:xfrm>
           <a:prstGeom prst="roundRect">
             <a:avLst>
-              <a:gd name="adj" fmla="val 8333"/>
+              <a:gd name="adj" fmla="val 10000"/>
             </a:avLst>
           </a:prstGeom>
           <a:solidFill>
@@ -2036,8 +1997,8 @@
         </p:nvSpPr>
         <p:spPr>
           <a:xfrm>
-            <a:off x="2286000" y="2331720"/>
-            <a:ext cx="4572000" cy="274320"/>
+            <a:off x="2286000" y="2468880"/>
+            <a:ext cx="4572000" cy="320040"/>
           </a:xfrm>
           <a:prstGeom prst="rect">
             <a:avLst/>
@@ -2053,7 +2014,46 @@
               <a:buNone/>
             </a:pPr>
             <a:r>
-              <a:rPr lang="en-US" sz="1400" dirty="0">
+              <a:rPr lang="en-US" sz="2000" b="1" dirty="0">
+                <a:solidFill>
+                  <a:srgbClr val="FFFFFF"/>
+                </a:solidFill>
+                <a:latin typeface="Arial" pitchFamily="34" charset="0"/>
+                <a:ea typeface="Arial" pitchFamily="34" charset="-122"/>
+                <a:cs typeface="Arial" pitchFamily="34" charset="-120"/>
+              </a:rPr>
+              <a:t>Omar Sarsar &amp; Iliass Hariz</a:t>
+            </a:r>
+            <a:endParaRPr lang="en-US" sz="2000" dirty="0"/>
+          </a:p>
+        </p:txBody>
+      </p:sp>
+      <p:sp>
+        <p:nvSpPr>
+          <p:cNvPr id="7" name="Text 5"/>
+          <p:cNvSpPr/>
+          <p:nvPr/>
+        </p:nvSpPr>
+        <p:spPr>
+          <a:xfrm>
+            <a:off x="2286000" y="2834640"/>
+            <a:ext cx="4572000" cy="228600"/>
+          </a:xfrm>
+          <a:prstGeom prst="rect">
+            <a:avLst/>
+          </a:prstGeom>
+          <a:noFill/>
+          <a:ln/>
+        </p:spPr>
+        <p:txBody>
+          <a:bodyPr wrap="square" rtlCol="0" anchor="ctr"/>
+          <a:lstStyle/>
+          <a:p>
+            <a:pPr algn="ctr" indent="0" marL="0">
+              <a:buNone/>
+            </a:pPr>
+            <a:r>
+              <a:rPr lang="en-US" sz="1600" dirty="0">
                 <a:solidFill>
                   <a:srgbClr val="E2E8F0"/>
                 </a:solidFill>
@@ -2061,126 +2061,9 @@
                 <a:ea typeface="Arial" pitchFamily="34" charset="-122"/>
                 <a:cs typeface="Arial" pitchFamily="34" charset="-120"/>
               </a:rPr>
-              <a:t>Presente par</a:t>
-            </a:r>
-            <a:endParaRPr lang="en-US" sz="1400" dirty="0"/>
-          </a:p>
-        </p:txBody>
-      </p:sp>
-      <p:sp>
-        <p:nvSpPr>
-          <p:cNvPr id="7" name="Text 5"/>
-          <p:cNvSpPr/>
-          <p:nvPr/>
-        </p:nvSpPr>
-        <p:spPr>
-          <a:xfrm>
-            <a:off x="2286000" y="2606040"/>
-            <a:ext cx="4572000" cy="320040"/>
-          </a:xfrm>
-          <a:prstGeom prst="rect">
-            <a:avLst/>
-          </a:prstGeom>
-          <a:noFill/>
-          <a:ln/>
-        </p:spPr>
-        <p:txBody>
-          <a:bodyPr wrap="square" rtlCol="0" anchor="ctr"/>
-          <a:lstStyle/>
-          <a:p>
-            <a:pPr algn="ctr" indent="0" marL="0">
-              <a:buNone/>
-            </a:pPr>
-            <a:r>
-              <a:rPr lang="en-US" sz="2000" b="1" dirty="0">
-                <a:solidFill>
-                  <a:srgbClr val="FFFFFF"/>
-                </a:solidFill>
-                <a:latin typeface="Arial" pitchFamily="34" charset="0"/>
-                <a:ea typeface="Arial" pitchFamily="34" charset="-122"/>
-                <a:cs typeface="Arial" pitchFamily="34" charset="-120"/>
-              </a:rPr>
-              <a:t>Omar Sarsar &amp; Iliass Hariz</a:t>
-            </a:r>
-            <a:endParaRPr lang="en-US" sz="2000" dirty="0"/>
-          </a:p>
-        </p:txBody>
-      </p:sp>
-      <p:sp>
-        <p:nvSpPr>
-          <p:cNvPr id="8" name="Text 6"/>
-          <p:cNvSpPr/>
-          <p:nvPr/>
-        </p:nvSpPr>
-        <p:spPr>
-          <a:xfrm>
-            <a:off x="2286000" y="2926080"/>
-            <a:ext cx="4572000" cy="274320"/>
-          </a:xfrm>
-          <a:prstGeom prst="rect">
-            <a:avLst/>
-          </a:prstGeom>
-          <a:noFill/>
-          <a:ln/>
-        </p:spPr>
-        <p:txBody>
-          <a:bodyPr wrap="square" rtlCol="0" anchor="ctr"/>
-          <a:lstStyle/>
-          <a:p>
-            <a:pPr algn="ctr" indent="0" marL="0">
-              <a:buNone/>
-            </a:pPr>
-            <a:r>
-              <a:rPr lang="en-US" sz="1600" dirty="0">
-                <a:solidFill>
-                  <a:srgbClr val="E2E8F0"/>
-                </a:solidFill>
-                <a:latin typeface="Arial" pitchFamily="34" charset="0"/>
-                <a:ea typeface="Arial" pitchFamily="34" charset="-122"/>
-                <a:cs typeface="Arial" pitchFamily="34" charset="-120"/>
-              </a:rPr>
               <a:t>2026</a:t>
             </a:r>
             <a:endParaRPr lang="en-US" sz="1600" dirty="0"/>
-          </a:p>
-        </p:txBody>
-      </p:sp>
-      <p:sp>
-        <p:nvSpPr>
-          <p:cNvPr id="9" name="Text 7"/>
-          <p:cNvSpPr/>
-          <p:nvPr/>
-        </p:nvSpPr>
-        <p:spPr>
-          <a:xfrm>
-            <a:off x="457200" y="3566160"/>
-            <a:ext cx="8229600" cy="1097280"/>
-          </a:xfrm>
-          <a:prstGeom prst="rect">
-            <a:avLst/>
-          </a:prstGeom>
-          <a:noFill/>
-          <a:ln/>
-        </p:spPr>
-        <p:txBody>
-          <a:bodyPr wrap="square" rtlCol="0" anchor="t"/>
-          <a:lstStyle/>
-          <a:p>
-            <a:pPr algn="ctr" indent="0" marL="0">
-              <a:buNone/>
-            </a:pPr>
-            <a:r>
-              <a:rPr lang="en-US" sz="1800" dirty="0">
-                <a:solidFill>
-                  <a:srgbClr val="E2E8F0"/>
-                </a:solidFill>
-                <a:latin typeface="Arial" pitchFamily="34" charset="0"/>
-                <a:ea typeface="Arial" pitchFamily="34" charset="-122"/>
-                <a:cs typeface="Arial" pitchFamily="34" charset="-120"/>
-              </a:rPr>
-              <a:t>Nous vous remercions pour votre attention. Ce projet a demontre que Redis reduit drastiquement les temps de reponse et la charge sur la base de donnees, tout en maintenant la coherence. N'hesitez pas a poser vos questions.</a:t>
-            </a:r>
-            <a:endParaRPr lang="en-US" sz="1800" dirty="0"/>
           </a:p>
         </p:txBody>
       </p:sp>
@@ -2249,7 +2132,7 @@
                 <a:ea typeface="Arial" pitchFamily="34" charset="-122"/>
                 <a:cs typeface="Arial" pitchFamily="34" charset="-120"/>
               </a:rPr>
-              <a:t>Introduction et Contexte</a:t>
+              <a:t>Contexte et Objectifs</a:t>
             </a:r>
             <a:endParaRPr lang="en-US" sz="3200" dirty="0"/>
           </a:p>
@@ -2283,24 +2166,24 @@
         </p:nvSpPr>
         <p:spPr>
           <a:xfrm>
-            <a:off x="457200" y="1097280"/>
-            <a:ext cx="8229600" cy="1645920"/>
-          </a:xfrm>
-          <a:prstGeom prst="rect">
-            <a:avLst/>
-          </a:prstGeom>
-          <a:noFill/>
-          <a:ln/>
-        </p:spPr>
-        <p:txBody>
-          <a:bodyPr wrap="square" rtlCol="0" anchor="t"/>
+            <a:off x="640080" y="1188720"/>
+            <a:ext cx="7863840" cy="457200"/>
+          </a:xfrm>
+          <a:prstGeom prst="rect">
+            <a:avLst/>
+          </a:prstGeom>
+          <a:noFill/>
+          <a:ln/>
+        </p:spPr>
+        <p:txBody>
+          <a:bodyPr wrap="square" rtlCol="0" anchor="ctr"/>
           <a:lstStyle/>
           <a:p>
             <a:pPr algn="l" indent="0" marL="0">
               <a:buNone/>
             </a:pPr>
             <a:r>
-              <a:rPr lang="en-US" sz="1800" dirty="0">
+              <a:rPr lang="en-US" sz="2200" dirty="0">
                 <a:solidFill>
                   <a:srgbClr val="E2E8F0"/>
                 </a:solidFill>
@@ -2308,33 +2191,50 @@
                 <a:ea typeface="Arial" pitchFamily="34" charset="-122"/>
                 <a:cs typeface="Arial" pitchFamily="34" charset="-120"/>
               </a:rPr>
-              <a:t>Ce projet vise a integrer un cache distribue (Redis) a une application web existante de type marketplace SaaS. L'augmentation du nombre d'utilisateurs a cause des ralentissements sur les pages affichant les listes de produits. L'objectif principal est d'ameliorer les performances en verifiant prealablement si les donnees sont disponibles dans le cache.</a:t>
-            </a:r>
-            <a:endParaRPr lang="en-US" sz="1800" dirty="0"/>
-          </a:p>
-        </p:txBody>
-      </p:sp>
-      <p:sp>
-        <p:nvSpPr>
-          <p:cNvPr id="5" name="Shape 3"/>
-          <p:cNvSpPr/>
-          <p:nvPr/>
-        </p:nvSpPr>
-        <p:spPr>
-          <a:xfrm>
-            <a:off x="457200" y="2560320"/>
-            <a:ext cx="8229600" cy="2194560"/>
-          </a:xfrm>
-          <a:prstGeom prst="roundRect">
-            <a:avLst>
-              <a:gd name="adj" fmla="val 4167"/>
-            </a:avLst>
-          </a:prstGeom>
-          <a:solidFill>
-            <a:srgbClr val="2C5282"/>
-          </a:solidFill>
-          <a:ln/>
-        </p:spPr>
+              <a:t>Application marketplace SaaS</a:t>
+            </a:r>
+            <a:endParaRPr lang="en-US" sz="2200" dirty="0"/>
+          </a:p>
+        </p:txBody>
+      </p:sp>
+      <p:sp>
+        <p:nvSpPr>
+          <p:cNvPr id="5" name="Text 3"/>
+          <p:cNvSpPr/>
+          <p:nvPr/>
+        </p:nvSpPr>
+        <p:spPr>
+          <a:xfrm>
+            <a:off x="640080" y="1737360"/>
+            <a:ext cx="7863840" cy="457200"/>
+          </a:xfrm>
+          <a:prstGeom prst="rect">
+            <a:avLst/>
+          </a:prstGeom>
+          <a:noFill/>
+          <a:ln/>
+        </p:spPr>
+        <p:txBody>
+          <a:bodyPr wrap="square" rtlCol="0" anchor="ctr"/>
+          <a:lstStyle/>
+          <a:p>
+            <a:pPr algn="l" indent="0" marL="0">
+              <a:buNone/>
+            </a:pPr>
+            <a:r>
+              <a:rPr lang="en-US" sz="2200" dirty="0">
+                <a:solidFill>
+                  <a:srgbClr val="E2E8F0"/>
+                </a:solidFill>
+                <a:latin typeface="Arial" pitchFamily="34" charset="0"/>
+                <a:ea typeface="Arial" pitchFamily="34" charset="-122"/>
+                <a:cs typeface="Arial" pitchFamily="34" charset="-120"/>
+              </a:rPr>
+              <a:t>Ralentissements sur les pages de listes</a:t>
+            </a:r>
+            <a:endParaRPr lang="en-US" sz="2200" dirty="0"/>
+          </a:p>
+        </p:txBody>
       </p:sp>
       <p:sp>
         <p:nvSpPr>
@@ -2344,8 +2244,8 @@
         </p:nvSpPr>
         <p:spPr>
           <a:xfrm>
-            <a:off x="640080" y="2651760"/>
-            <a:ext cx="7863840" cy="365760"/>
+            <a:off x="640080" y="2286000"/>
+            <a:ext cx="7863840" cy="457200"/>
           </a:xfrm>
           <a:prstGeom prst="rect">
             <a:avLst/>
@@ -2361,15 +2261,15 @@
               <a:buNone/>
             </a:pPr>
             <a:r>
-              <a:rPr lang="en-US" sz="2200" b="1" dirty="0">
-                <a:solidFill>
-                  <a:srgbClr val="FFFFFF"/>
-                </a:solidFill>
-                <a:latin typeface="Arial" pitchFamily="34" charset="0"/>
-                <a:ea typeface="Arial" pitchFamily="34" charset="-122"/>
-                <a:cs typeface="Arial" pitchFamily="34" charset="-120"/>
-              </a:rPr>
-              <a:t>Plan de la Présentation</a:t>
+              <a:rPr lang="en-US" sz="2200" dirty="0">
+                <a:solidFill>
+                  <a:srgbClr val="E2E8F0"/>
+                </a:solidFill>
+                <a:latin typeface="Arial" pitchFamily="34" charset="0"/>
+                <a:ea typeface="Arial" pitchFamily="34" charset="-122"/>
+                <a:cs typeface="Arial" pitchFamily="34" charset="-120"/>
+              </a:rPr>
+              <a:t>Solution : cache distribué Redis</a:t>
             </a:r>
             <a:endParaRPr lang="en-US" sz="2200" dirty="0"/>
           </a:p>
@@ -2383,8 +2283,8 @@
         </p:nvSpPr>
         <p:spPr>
           <a:xfrm>
-            <a:off x="640080" y="3108960"/>
-            <a:ext cx="7863840" cy="365760"/>
+            <a:off x="640080" y="2834640"/>
+            <a:ext cx="7863840" cy="457200"/>
           </a:xfrm>
           <a:prstGeom prst="rect">
             <a:avLst/>
@@ -2400,7 +2300,7 @@
               <a:buNone/>
             </a:pPr>
             <a:r>
-              <a:rPr lang="en-US" sz="1800" dirty="0">
+              <a:rPr lang="en-US" sz="2200" dirty="0">
                 <a:solidFill>
                   <a:srgbClr val="E2E8F0"/>
                 </a:solidFill>
@@ -2408,9 +2308,9 @@
                 <a:ea typeface="Arial" pitchFamily="34" charset="-122"/>
                 <a:cs typeface="Arial" pitchFamily="34" charset="-120"/>
               </a:rPr>
-              <a:t>1. Architecture du système avec Cache-Aside</a:t>
-            </a:r>
-            <a:endParaRPr lang="en-US" sz="1800" dirty="0"/>
+              <a:t>Déploiement avec Docker Compose</a:t>
+            </a:r>
+            <a:endParaRPr lang="en-US" sz="2200" dirty="0"/>
           </a:p>
         </p:txBody>
       </p:sp>
@@ -2422,8 +2322,8 @@
         </p:nvSpPr>
         <p:spPr>
           <a:xfrm>
-            <a:off x="640080" y="3520440"/>
-            <a:ext cx="7863840" cy="365760"/>
+            <a:off x="640080" y="3383280"/>
+            <a:ext cx="7863840" cy="457200"/>
           </a:xfrm>
           <a:prstGeom prst="rect">
             <a:avLst/>
@@ -2439,7 +2339,7 @@
               <a:buNone/>
             </a:pPr>
             <a:r>
-              <a:rPr lang="en-US" sz="1800" dirty="0">
+              <a:rPr lang="en-US" sz="2200" dirty="0">
                 <a:solidFill>
                   <a:srgbClr val="E2E8F0"/>
                 </a:solidFill>
@@ -2447,126 +2347,9 @@
                 <a:ea typeface="Arial" pitchFamily="34" charset="-122"/>
                 <a:cs typeface="Arial" pitchFamily="34" charset="-120"/>
               </a:rPr>
-              <a:t>2. Infrastructure Docker et couche d'abstraction</a:t>
-            </a:r>
-            <a:endParaRPr lang="en-US" sz="1800" dirty="0"/>
-          </a:p>
-        </p:txBody>
-      </p:sp>
-      <p:sp>
-        <p:nvSpPr>
-          <p:cNvPr id="9" name="Text 7"/>
-          <p:cNvSpPr/>
-          <p:nvPr/>
-        </p:nvSpPr>
-        <p:spPr>
-          <a:xfrm>
-            <a:off x="640080" y="3931920"/>
-            <a:ext cx="7863840" cy="365760"/>
-          </a:xfrm>
-          <a:prstGeom prst="rect">
-            <a:avLst/>
-          </a:prstGeom>
-          <a:noFill/>
-          <a:ln/>
-        </p:spPr>
-        <p:txBody>
-          <a:bodyPr wrap="square" rtlCol="0" anchor="ctr"/>
-          <a:lstStyle/>
-          <a:p>
-            <a:pPr algn="l" indent="0" marL="0">
-              <a:buNone/>
-            </a:pPr>
-            <a:r>
-              <a:rPr lang="en-US" sz="1800" dirty="0">
-                <a:solidFill>
-                  <a:srgbClr val="E2E8F0"/>
-                </a:solidFill>
-                <a:latin typeface="Arial" pitchFamily="34" charset="0"/>
-                <a:ea typeface="Arial" pitchFamily="34" charset="-122"/>
-                <a:cs typeface="Arial" pitchFamily="34" charset="-120"/>
-              </a:rPr>
-              <a:t>3. Intégration dans les actions et invalidation</a:t>
-            </a:r>
-            <a:endParaRPr lang="en-US" sz="1800" dirty="0"/>
-          </a:p>
-        </p:txBody>
-      </p:sp>
-      <p:sp>
-        <p:nvSpPr>
-          <p:cNvPr id="10" name="Text 8"/>
-          <p:cNvSpPr/>
-          <p:nvPr/>
-        </p:nvSpPr>
-        <p:spPr>
-          <a:xfrm>
-            <a:off x="640080" y="4343400"/>
-            <a:ext cx="7863840" cy="365760"/>
-          </a:xfrm>
-          <a:prstGeom prst="rect">
-            <a:avLst/>
-          </a:prstGeom>
-          <a:noFill/>
-          <a:ln/>
-        </p:spPr>
-        <p:txBody>
-          <a:bodyPr wrap="square" rtlCol="0" anchor="ctr"/>
-          <a:lstStyle/>
-          <a:p>
-            <a:pPr algn="l" indent="0" marL="0">
-              <a:buNone/>
-            </a:pPr>
-            <a:r>
-              <a:rPr lang="en-US" sz="1800" dirty="0">
-                <a:solidFill>
-                  <a:srgbClr val="E2E8F0"/>
-                </a:solidFill>
-                <a:latin typeface="Arial" pitchFamily="34" charset="0"/>
-                <a:ea typeface="Arial" pitchFamily="34" charset="-122"/>
-                <a:cs typeface="Arial" pitchFamily="34" charset="-120"/>
-              </a:rPr>
-              <a:t>4. Tests unitaires et validation (Iliass Hariz)</a:t>
-            </a:r>
-            <a:endParaRPr lang="en-US" sz="1800" dirty="0"/>
-          </a:p>
-        </p:txBody>
-      </p:sp>
-      <p:sp>
-        <p:nvSpPr>
-          <p:cNvPr id="11" name="Text 9"/>
-          <p:cNvSpPr/>
-          <p:nvPr/>
-        </p:nvSpPr>
-        <p:spPr>
-          <a:xfrm>
-            <a:off x="640080" y="4754880"/>
-            <a:ext cx="7863840" cy="365760"/>
-          </a:xfrm>
-          <a:prstGeom prst="rect">
-            <a:avLst/>
-          </a:prstGeom>
-          <a:noFill/>
-          <a:ln/>
-        </p:spPr>
-        <p:txBody>
-          <a:bodyPr wrap="square" rtlCol="0" anchor="ctr"/>
-          <a:lstStyle/>
-          <a:p>
-            <a:pPr algn="l" indent="0" marL="0">
-              <a:buNone/>
-            </a:pPr>
-            <a:r>
-              <a:rPr lang="en-US" sz="1800" dirty="0">
-                <a:solidFill>
-                  <a:srgbClr val="E2E8F0"/>
-                </a:solidFill>
-                <a:latin typeface="Arial" pitchFamily="34" charset="0"/>
-                <a:ea typeface="Arial" pitchFamily="34" charset="-122"/>
-                <a:cs typeface="Arial" pitchFamily="34" charset="-120"/>
-              </a:rPr>
-              <a:t>5. Mesures de performance et résultats (Iliass Hariz)</a:t>
-            </a:r>
-            <a:endParaRPr lang="en-US" sz="1800" dirty="0"/>
+              <a:t>Mesure de l'amélioration des performances</a:t>
+            </a:r>
+            <a:endParaRPr lang="en-US" sz="2200" dirty="0"/>
           </a:p>
         </p:txBody>
       </p:sp>
@@ -2669,24 +2452,24 @@
         </p:nvSpPr>
         <p:spPr>
           <a:xfrm>
-            <a:off x="457200" y="914400"/>
-            <a:ext cx="8229600" cy="1645920"/>
-          </a:xfrm>
-          <a:prstGeom prst="rect">
-            <a:avLst/>
-          </a:prstGeom>
-          <a:noFill/>
-          <a:ln/>
-        </p:spPr>
-        <p:txBody>
-          <a:bodyPr wrap="square" rtlCol="0" anchor="t"/>
+            <a:off x="640080" y="1005840"/>
+            <a:ext cx="7863840" cy="457200"/>
+          </a:xfrm>
+          <a:prstGeom prst="rect">
+            <a:avLst/>
+          </a:prstGeom>
+          <a:noFill/>
+          <a:ln/>
+        </p:spPr>
+        <p:txBody>
+          <a:bodyPr wrap="square" rtlCol="0" anchor="ctr"/>
           <a:lstStyle/>
           <a:p>
             <a:pPr algn="l" indent="0" marL="0">
               <a:buNone/>
             </a:pPr>
             <a:r>
-              <a:rPr lang="en-US" sz="1800" dirty="0">
+              <a:rPr lang="en-US" sz="2200" dirty="0">
                 <a:solidFill>
                   <a:srgbClr val="E2E8F0"/>
                 </a:solidFill>
@@ -2694,21 +2477,138 @@
                 <a:ea typeface="Arial" pitchFamily="34" charset="-122"/>
                 <a:cs typeface="Arial" pitchFamily="34" charset="-120"/>
               </a:rPr>
-              <a:t>Notre architecture repose sur le pattern Cache-Aside. L'application verifie d'abord Redis. Si les donnees y sont, elles sont retournees immediatement. Sinon, PostgreSQL est interrogee, les resultats sont stockes dans Redis avec un TTL, puis retournes. Cette approche sert les requetes frequentes depuis la memoire.</a:t>
-            </a:r>
-            <a:endParaRPr lang="en-US" sz="1800" dirty="0"/>
-          </a:p>
-        </p:txBody>
-      </p:sp>
-      <p:sp>
-        <p:nvSpPr>
-          <p:cNvPr id="5" name="Shape 3"/>
-          <p:cNvSpPr/>
-          <p:nvPr/>
-        </p:nvSpPr>
-        <p:spPr>
-          <a:xfrm>
-            <a:off x="3200400" y="2377440"/>
+              <a:t>Pattern Cache-Aside (Lazy Loading)</a:t>
+            </a:r>
+            <a:endParaRPr lang="en-US" sz="2200" dirty="0"/>
+          </a:p>
+        </p:txBody>
+      </p:sp>
+      <p:sp>
+        <p:nvSpPr>
+          <p:cNvPr id="5" name="Text 3"/>
+          <p:cNvSpPr/>
+          <p:nvPr/>
+        </p:nvSpPr>
+        <p:spPr>
+          <a:xfrm>
+            <a:off x="640080" y="1554480"/>
+            <a:ext cx="7863840" cy="457200"/>
+          </a:xfrm>
+          <a:prstGeom prst="rect">
+            <a:avLst/>
+          </a:prstGeom>
+          <a:noFill/>
+          <a:ln/>
+        </p:spPr>
+        <p:txBody>
+          <a:bodyPr wrap="square" rtlCol="0" anchor="ctr"/>
+          <a:lstStyle/>
+          <a:p>
+            <a:pPr algn="l" indent="0" marL="0">
+              <a:buNone/>
+            </a:pPr>
+            <a:r>
+              <a:rPr lang="en-US" sz="2200" dirty="0">
+                <a:solidFill>
+                  <a:srgbClr val="E2E8F0"/>
+                </a:solidFill>
+                <a:latin typeface="Arial" pitchFamily="34" charset="0"/>
+                <a:ea typeface="Arial" pitchFamily="34" charset="-122"/>
+                <a:cs typeface="Arial" pitchFamily="34" charset="-120"/>
+              </a:rPr>
+              <a:t>Vérification du cache avant la base de données</a:t>
+            </a:r>
+            <a:endParaRPr lang="en-US" sz="2200" dirty="0"/>
+          </a:p>
+        </p:txBody>
+      </p:sp>
+      <p:sp>
+        <p:nvSpPr>
+          <p:cNvPr id="6" name="Text 4"/>
+          <p:cNvSpPr/>
+          <p:nvPr/>
+        </p:nvSpPr>
+        <p:spPr>
+          <a:xfrm>
+            <a:off x="640080" y="2103120"/>
+            <a:ext cx="7863840" cy="457200"/>
+          </a:xfrm>
+          <a:prstGeom prst="rect">
+            <a:avLst/>
+          </a:prstGeom>
+          <a:noFill/>
+          <a:ln/>
+        </p:spPr>
+        <p:txBody>
+          <a:bodyPr wrap="square" rtlCol="0" anchor="ctr"/>
+          <a:lstStyle/>
+          <a:p>
+            <a:pPr algn="l" indent="0" marL="0">
+              <a:buNone/>
+            </a:pPr>
+            <a:r>
+              <a:rPr lang="en-US" sz="2200" dirty="0">
+                <a:solidFill>
+                  <a:srgbClr val="E2E8F0"/>
+                </a:solidFill>
+                <a:latin typeface="Arial" pitchFamily="34" charset="0"/>
+                <a:ea typeface="Arial" pitchFamily="34" charset="-122"/>
+                <a:cs typeface="Arial" pitchFamily="34" charset="-120"/>
+              </a:rPr>
+              <a:t>Stockage des résultats avec TTL configurable</a:t>
+            </a:r>
+            <a:endParaRPr lang="en-US" sz="2200" dirty="0"/>
+          </a:p>
+        </p:txBody>
+      </p:sp>
+      <p:sp>
+        <p:nvSpPr>
+          <p:cNvPr id="7" name="Text 5"/>
+          <p:cNvSpPr/>
+          <p:nvPr/>
+        </p:nvSpPr>
+        <p:spPr>
+          <a:xfrm>
+            <a:off x="640080" y="2651760"/>
+            <a:ext cx="7863840" cy="457200"/>
+          </a:xfrm>
+          <a:prstGeom prst="rect">
+            <a:avLst/>
+          </a:prstGeom>
+          <a:noFill/>
+          <a:ln/>
+        </p:spPr>
+        <p:txBody>
+          <a:bodyPr wrap="square" rtlCol="0" anchor="ctr"/>
+          <a:lstStyle/>
+          <a:p>
+            <a:pPr algn="l" indent="0" marL="0">
+              <a:buNone/>
+            </a:pPr>
+            <a:r>
+              <a:rPr lang="en-US" sz="2200" dirty="0">
+                <a:solidFill>
+                  <a:srgbClr val="E2E8F0"/>
+                </a:solidFill>
+                <a:latin typeface="Arial" pitchFamily="34" charset="0"/>
+                <a:ea typeface="Arial" pitchFamily="34" charset="-122"/>
+                <a:cs typeface="Arial" pitchFamily="34" charset="-120"/>
+              </a:rPr>
+              <a:t>Réduction drastique du temps de réponse</a:t>
+            </a:r>
+            <a:endParaRPr lang="en-US" sz="2200" dirty="0"/>
+          </a:p>
+        </p:txBody>
+      </p:sp>
+      <p:sp>
+        <p:nvSpPr>
+          <p:cNvPr id="8" name="Shape 6"/>
+          <p:cNvSpPr/>
+          <p:nvPr/>
+        </p:nvSpPr>
+        <p:spPr>
+          <a:xfrm>
+            <a:off x="3200400" y="3474720"/>
             <a:ext cx="2743200" cy="640080"/>
           </a:xfrm>
           <a:prstGeom prst="roundRect">
@@ -2724,13 +2624,13 @@
       </p:sp>
       <p:sp>
         <p:nvSpPr>
-          <p:cNvPr id="6" name="Text 4"/>
-          <p:cNvSpPr/>
-          <p:nvPr/>
-        </p:nvSpPr>
-        <p:spPr>
-          <a:xfrm>
-            <a:off x="3200400" y="2377440"/>
+          <p:cNvPr id="9" name="Text 7"/>
+          <p:cNvSpPr/>
+          <p:nvPr/>
+        </p:nvSpPr>
+        <p:spPr>
+          <a:xfrm>
+            <a:off x="3200400" y="3474720"/>
             <a:ext cx="2743200" cy="640080"/>
           </a:xfrm>
           <a:prstGeom prst="rect">
@@ -2763,13 +2663,13 @@
       </p:sp>
       <p:sp>
         <p:nvSpPr>
-          <p:cNvPr id="7" name="Shape 5"/>
-          <p:cNvSpPr/>
-          <p:nvPr/>
-        </p:nvSpPr>
-        <p:spPr>
-          <a:xfrm>
-            <a:off x="457200" y="3383280"/>
+          <p:cNvPr id="10" name="Shape 8"/>
+          <p:cNvSpPr/>
+          <p:nvPr/>
+        </p:nvSpPr>
+        <p:spPr>
+          <a:xfrm>
+            <a:off x="457200" y="4206240"/>
             <a:ext cx="2743200" cy="640080"/>
           </a:xfrm>
           <a:prstGeom prst="roundRect">
@@ -2785,13 +2685,13 @@
       </p:sp>
       <p:sp>
         <p:nvSpPr>
-          <p:cNvPr id="8" name="Text 6"/>
-          <p:cNvSpPr/>
-          <p:nvPr/>
-        </p:nvSpPr>
-        <p:spPr>
-          <a:xfrm>
-            <a:off x="457200" y="3383280"/>
+          <p:cNvPr id="11" name="Text 9"/>
+          <p:cNvSpPr/>
+          <p:nvPr/>
+        </p:nvSpPr>
+        <p:spPr>
+          <a:xfrm>
+            <a:off x="457200" y="4206240"/>
             <a:ext cx="2743200" cy="640080"/>
           </a:xfrm>
           <a:prstGeom prst="rect">
@@ -2824,13 +2724,13 @@
       </p:sp>
       <p:sp>
         <p:nvSpPr>
-          <p:cNvPr id="9" name="Shape 7"/>
-          <p:cNvSpPr/>
-          <p:nvPr/>
-        </p:nvSpPr>
-        <p:spPr>
-          <a:xfrm>
-            <a:off x="5943600" y="3383280"/>
+          <p:cNvPr id="12" name="Shape 10"/>
+          <p:cNvSpPr/>
+          <p:nvPr/>
+        </p:nvSpPr>
+        <p:spPr>
+          <a:xfrm>
+            <a:off x="5943600" y="4206240"/>
             <a:ext cx="2743200" cy="640080"/>
           </a:xfrm>
           <a:prstGeom prst="roundRect">
@@ -2846,13 +2746,13 @@
       </p:sp>
       <p:sp>
         <p:nvSpPr>
-          <p:cNvPr id="10" name="Text 8"/>
-          <p:cNvSpPr/>
-          <p:nvPr/>
-        </p:nvSpPr>
-        <p:spPr>
-          <a:xfrm>
-            <a:off x="5943600" y="3383280"/>
+          <p:cNvPr id="13" name="Text 11"/>
+          <p:cNvSpPr/>
+          <p:nvPr/>
+        </p:nvSpPr>
+        <p:spPr>
+          <a:xfrm>
+            <a:off x="5943600" y="4206240"/>
             <a:ext cx="2743200" cy="640080"/>
           </a:xfrm>
           <a:prstGeom prst="rect">
@@ -2948,7 +2848,7 @@
                 <a:ea typeface="Arial" pitchFamily="34" charset="-122"/>
                 <a:cs typeface="Arial" pitchFamily="34" charset="-120"/>
               </a:rPr>
-              <a:t>Infrastructure Docker et Cache</a:t>
+              <a:t>Infrastructure Docker</a:t>
             </a:r>
             <a:endParaRPr lang="en-US" sz="2800" dirty="0"/>
           </a:p>
@@ -2973,45 +2873,6 @@
           </a:solidFill>
           <a:ln/>
         </p:spPr>
-      </p:sp>
-      <p:sp>
-        <p:nvSpPr>
-          <p:cNvPr id="4" name="Text 2"/>
-          <p:cNvSpPr/>
-          <p:nvPr/>
-        </p:nvSpPr>
-        <p:spPr>
-          <a:xfrm>
-            <a:off x="457200" y="914400"/>
-            <a:ext cx="8229600" cy="1828800"/>
-          </a:xfrm>
-          <a:prstGeom prst="rect">
-            <a:avLst/>
-          </a:prstGeom>
-          <a:noFill/>
-          <a:ln/>
-        </p:spPr>
-        <p:txBody>
-          <a:bodyPr wrap="square" rtlCol="0" anchor="t"/>
-          <a:lstStyle/>
-          <a:p>
-            <a:pPr algn="l" indent="0" marL="0">
-              <a:buNone/>
-            </a:pPr>
-            <a:r>
-              <a:rPr lang="en-US" sz="1800" dirty="0">
-                <a:solidFill>
-                  <a:srgbClr val="E2E8F0"/>
-                </a:solidFill>
-                <a:latin typeface="Arial" pitchFamily="34" charset="0"/>
-                <a:ea typeface="Arial" pitchFamily="34" charset="-122"/>
-                <a:cs typeface="Arial" pitchFamily="34" charset="-120"/>
-              </a:rPr>
-              <a:t>L'infrastructure est containerisee avec Docker Compose. PostgreSQL 16 sert de base de donnees sur le port 5434. Redis 7 fonctionne comme cache sur le port 6379 avec un volume persistant et un healthcheck. La couche d'abstraction fournit une interface simple : cacheGet recupere les donnees avec typage TypeScript, et cacheSet stocke avec un TTL configurable de 300 secondes.</a:t>
-            </a:r>
-            <a:endParaRPr lang="en-US" sz="1800" dirty="0"/>
-          </a:p>
-        </p:txBody>
       </p:sp>
       <p:graphicFrame>
         <p:nvGraphicFramePr>
@@ -3028,7 +2889,7 @@
           </p:nvPr>
         </p:nvGraphicFramePr>
         <p:xfrm>
-          <a:off x="457200" y="2743200"/>
+          <a:off x="457200" y="1005840"/>
           <a:ext cx="8229600" cy="914400"/>
         </p:xfrm>
         <a:graphic>
@@ -3036,10 +2897,9 @@
             <a:tbl>
               <a:tblPr/>
               <a:tblGrid>
-                <a:gridCol w="1828800"/>
+                <a:gridCol w="2286000"/>
                 <a:gridCol w="2743200"/>
-                <a:gridCol w="1828800"/>
-                <a:gridCol w="1828800"/>
+                <a:gridCol w="2286000"/>
               </a:tblGrid>
               <a:tr h="0">
                 <a:tc>
@@ -3051,7 +2911,7 @@
                         <a:buNone/>
                       </a:pPr>
                       <a:r>
-                        <a:rPr lang="en-US" sz="1600" dirty="0">
+                        <a:rPr lang="en-US" sz="1800" dirty="0">
                           <a:solidFill>
                             <a:srgbClr val="E2E8F0"/>
                           </a:solidFill>
@@ -3061,7 +2921,7 @@
                         </a:rPr>
                         <a:t>Service</a:t>
                       </a:r>
-                      <a:endParaRPr lang="en-US" sz="1600" dirty="0">
+                      <a:endParaRPr lang="en-US" sz="1800" dirty="0">
                         <a:latin typeface="Arial" charset="0"/>
                         <a:ea typeface="Arial" charset="0"/>
                         <a:cs typeface="Arial" charset="0"/>
@@ -3119,7 +2979,7 @@
                         <a:buNone/>
                       </a:pPr>
                       <a:r>
-                        <a:rPr lang="en-US" sz="1600" dirty="0">
+                        <a:rPr lang="en-US" sz="1800" dirty="0">
                           <a:solidFill>
                             <a:srgbClr val="E2E8F0"/>
                           </a:solidFill>
@@ -3129,7 +2989,7 @@
                         </a:rPr>
                         <a:t>Image</a:t>
                       </a:r>
-                      <a:endParaRPr lang="en-US" sz="1600" dirty="0">
+                      <a:endParaRPr lang="en-US" sz="1800" dirty="0">
                         <a:latin typeface="Arial" charset="0"/>
                         <a:ea typeface="Arial" charset="0"/>
                         <a:cs typeface="Arial" charset="0"/>
@@ -3187,7 +3047,7 @@
                         <a:buNone/>
                       </a:pPr>
                       <a:r>
-                        <a:rPr lang="en-US" sz="1600" dirty="0">
+                        <a:rPr lang="en-US" sz="1800" dirty="0">
                           <a:solidFill>
                             <a:srgbClr val="E2E8F0"/>
                           </a:solidFill>
@@ -3197,75 +3057,7 @@
                         </a:rPr>
                         <a:t>Port</a:t>
                       </a:r>
-                      <a:endParaRPr lang="en-US" sz="1600" dirty="0">
-                        <a:latin typeface="Arial" charset="0"/>
-                        <a:ea typeface="Arial" charset="0"/>
-                        <a:cs typeface="Arial" charset="0"/>
-                      </a:endParaRPr>
-                    </a:p>
-                  </a:txBody>
-                  <a:tcPr marL="91440" marR="91440" marT="45720" marB="45720" anchor="ctr">
-                    <a:lnL w="12700" cap="flat" cmpd="sng" algn="ctr">
-                      <a:solidFill>
-                        <a:srgbClr val="4A5568"/>
-                      </a:solidFill>
-                      <a:prstDash val="solid"/>
-                      <a:round/>
-                      <a:headEnd type="none" w="med" len="med"/>
-                      <a:tailEnd type="none" w="med" len="med"/>
-                    </a:lnL>
-                    <a:lnR w="12700" cap="flat" cmpd="sng" algn="ctr">
-                      <a:solidFill>
-                        <a:srgbClr val="4A5568"/>
-                      </a:solidFill>
-                      <a:prstDash val="solid"/>
-                      <a:round/>
-                      <a:headEnd type="none" w="med" len="med"/>
-                      <a:tailEnd type="none" w="med" len="med"/>
-                    </a:lnR>
-                    <a:lnT w="12700" cap="flat" cmpd="sng" algn="ctr">
-                      <a:solidFill>
-                        <a:srgbClr val="4A5568"/>
-                      </a:solidFill>
-                      <a:prstDash val="solid"/>
-                      <a:round/>
-                      <a:headEnd type="none" w="med" len="med"/>
-                      <a:tailEnd type="none" w="med" len="med"/>
-                    </a:lnT>
-                    <a:lnB w="12700" cap="flat" cmpd="sng" algn="ctr">
-                      <a:solidFill>
-                        <a:srgbClr val="4A5568"/>
-                      </a:solidFill>
-                      <a:prstDash val="solid"/>
-                      <a:round/>
-                      <a:headEnd type="none" w="med" len="med"/>
-                      <a:tailEnd type="none" w="med" len="med"/>
-                    </a:lnB>
-                    <a:solidFill>
-                      <a:srgbClr val="2C5282"/>
-                    </a:solidFill>
-                  </a:tcPr>
-                </a:tc>
-                <a:tc>
-                  <a:txBody>
-                    <a:bodyPr/>
-                    <a:lstStyle/>
-                    <a:p>
-                      <a:pPr algn="ctr" indent="0" marL="0">
-                        <a:buNone/>
-                      </a:pPr>
-                      <a:r>
-                        <a:rPr lang="en-US" sz="1600" dirty="0">
-                          <a:solidFill>
-                            <a:srgbClr val="E2E8F0"/>
-                          </a:solidFill>
-                          <a:latin typeface="Arial" pitchFamily="34" charset="0"/>
-                          <a:ea typeface="Arial" pitchFamily="34" charset="-122"/>
-                          <a:cs typeface="Arial" pitchFamily="34" charset="-120"/>
-                        </a:rPr>
-                        <a:t>Description</a:t>
-                      </a:r>
-                      <a:endParaRPr lang="en-US" sz="1600" dirty="0">
+                      <a:endParaRPr lang="en-US" sz="1800" dirty="0">
                         <a:latin typeface="Arial" charset="0"/>
                         <a:ea typeface="Arial" charset="0"/>
                         <a:cs typeface="Arial" charset="0"/>
@@ -3325,7 +3117,7 @@
                         <a:buNone/>
                       </a:pPr>
                       <a:r>
-                        <a:rPr lang="en-US" sz="1600" dirty="0">
+                        <a:rPr lang="en-US" sz="1800" dirty="0">
                           <a:solidFill>
                             <a:srgbClr val="E2E8F0"/>
                           </a:solidFill>
@@ -3335,7 +3127,7 @@
                         </a:rPr>
                         <a:t>PostgreSQL</a:t>
                       </a:r>
-                      <a:endParaRPr lang="en-US" sz="1600" dirty="0">
+                      <a:endParaRPr lang="en-US" sz="1800" dirty="0">
                         <a:latin typeface="Arial" charset="0"/>
                         <a:ea typeface="Arial" charset="0"/>
                         <a:cs typeface="Arial" charset="0"/>
@@ -3393,7 +3185,7 @@
                         <a:buNone/>
                       </a:pPr>
                       <a:r>
-                        <a:rPr lang="en-US" sz="1600" dirty="0">
+                        <a:rPr lang="en-US" sz="1800" dirty="0">
                           <a:solidFill>
                             <a:srgbClr val="E2E8F0"/>
                           </a:solidFill>
@@ -3403,7 +3195,7 @@
                         </a:rPr>
                         <a:t>postgres:16-alpine</a:t>
                       </a:r>
-                      <a:endParaRPr lang="en-US" sz="1600" dirty="0">
+                      <a:endParaRPr lang="en-US" sz="1800" dirty="0">
                         <a:latin typeface="Arial" charset="0"/>
                         <a:ea typeface="Arial" charset="0"/>
                         <a:cs typeface="Arial" charset="0"/>
@@ -3461,7 +3253,7 @@
                         <a:buNone/>
                       </a:pPr>
                       <a:r>
-                        <a:rPr lang="en-US" sz="1600" dirty="0">
+                        <a:rPr lang="en-US" sz="1800" dirty="0">
                           <a:solidFill>
                             <a:srgbClr val="E2E8F0"/>
                           </a:solidFill>
@@ -3471,75 +3263,7 @@
                         </a:rPr>
                         <a:t>5434:5432</a:t>
                       </a:r>
-                      <a:endParaRPr lang="en-US" sz="1600" dirty="0">
-                        <a:latin typeface="Arial" charset="0"/>
-                        <a:ea typeface="Arial" charset="0"/>
-                        <a:cs typeface="Arial" charset="0"/>
-                      </a:endParaRPr>
-                    </a:p>
-                  </a:txBody>
-                  <a:tcPr marL="91440" marR="91440" marT="45720" marB="45720" anchor="ctr">
-                    <a:lnL w="12700" cap="flat" cmpd="sng" algn="ctr">
-                      <a:solidFill>
-                        <a:srgbClr val="4A5568"/>
-                      </a:solidFill>
-                      <a:prstDash val="solid"/>
-                      <a:round/>
-                      <a:headEnd type="none" w="med" len="med"/>
-                      <a:tailEnd type="none" w="med" len="med"/>
-                    </a:lnL>
-                    <a:lnR w="12700" cap="flat" cmpd="sng" algn="ctr">
-                      <a:solidFill>
-                        <a:srgbClr val="4A5568"/>
-                      </a:solidFill>
-                      <a:prstDash val="solid"/>
-                      <a:round/>
-                      <a:headEnd type="none" w="med" len="med"/>
-                      <a:tailEnd type="none" w="med" len="med"/>
-                    </a:lnR>
-                    <a:lnT w="12700" cap="flat" cmpd="sng" algn="ctr">
-                      <a:solidFill>
-                        <a:srgbClr val="4A5568"/>
-                      </a:solidFill>
-                      <a:prstDash val="solid"/>
-                      <a:round/>
-                      <a:headEnd type="none" w="med" len="med"/>
-                      <a:tailEnd type="none" w="med" len="med"/>
-                    </a:lnT>
-                    <a:lnB w="12700" cap="flat" cmpd="sng" algn="ctr">
-                      <a:solidFill>
-                        <a:srgbClr val="4A5568"/>
-                      </a:solidFill>
-                      <a:prstDash val="solid"/>
-                      <a:round/>
-                      <a:headEnd type="none" w="med" len="med"/>
-                      <a:tailEnd type="none" w="med" len="med"/>
-                    </a:lnB>
-                    <a:solidFill>
-                      <a:srgbClr val="2C5282"/>
-                    </a:solidFill>
-                  </a:tcPr>
-                </a:tc>
-                <a:tc>
-                  <a:txBody>
-                    <a:bodyPr/>
-                    <a:lstStyle/>
-                    <a:p>
-                      <a:pPr algn="ctr" indent="0" marL="0">
-                        <a:buNone/>
-                      </a:pPr>
-                      <a:r>
-                        <a:rPr lang="en-US" sz="1600" dirty="0">
-                          <a:solidFill>
-                            <a:srgbClr val="E2E8F0"/>
-                          </a:solidFill>
-                          <a:latin typeface="Arial" pitchFamily="34" charset="0"/>
-                          <a:ea typeface="Arial" pitchFamily="34" charset="-122"/>
-                          <a:cs typeface="Arial" pitchFamily="34" charset="-120"/>
-                        </a:rPr>
-                        <a:t>Base de données</a:t>
-                      </a:r>
-                      <a:endParaRPr lang="en-US" sz="1600" dirty="0">
+                      <a:endParaRPr lang="en-US" sz="1800" dirty="0">
                         <a:latin typeface="Arial" charset="0"/>
                         <a:ea typeface="Arial" charset="0"/>
                         <a:cs typeface="Arial" charset="0"/>
@@ -3599,7 +3323,7 @@
                         <a:buNone/>
                       </a:pPr>
                       <a:r>
-                        <a:rPr lang="en-US" sz="1600" dirty="0">
+                        <a:rPr lang="en-US" sz="1800" dirty="0">
                           <a:solidFill>
                             <a:srgbClr val="E2E8F0"/>
                           </a:solidFill>
@@ -3609,7 +3333,7 @@
                         </a:rPr>
                         <a:t>Redis</a:t>
                       </a:r>
-                      <a:endParaRPr lang="en-US" sz="1600" dirty="0">
+                      <a:endParaRPr lang="en-US" sz="1800" dirty="0">
                         <a:latin typeface="Arial" charset="0"/>
                         <a:ea typeface="Arial" charset="0"/>
                         <a:cs typeface="Arial" charset="0"/>
@@ -3667,7 +3391,7 @@
                         <a:buNone/>
                       </a:pPr>
                       <a:r>
-                        <a:rPr lang="en-US" sz="1600" dirty="0">
+                        <a:rPr lang="en-US" sz="1800" dirty="0">
                           <a:solidFill>
                             <a:srgbClr val="E2E8F0"/>
                           </a:solidFill>
@@ -3677,7 +3401,7 @@
                         </a:rPr>
                         <a:t>redis:7-alpine</a:t>
                       </a:r>
-                      <a:endParaRPr lang="en-US" sz="1600" dirty="0">
+                      <a:endParaRPr lang="en-US" sz="1800" dirty="0">
                         <a:latin typeface="Arial" charset="0"/>
                         <a:ea typeface="Arial" charset="0"/>
                         <a:cs typeface="Arial" charset="0"/>
@@ -3735,7 +3459,7 @@
                         <a:buNone/>
                       </a:pPr>
                       <a:r>
-                        <a:rPr lang="en-US" sz="1600" dirty="0">
+                        <a:rPr lang="en-US" sz="1800" dirty="0">
                           <a:solidFill>
                             <a:srgbClr val="E2E8F0"/>
                           </a:solidFill>
@@ -3745,75 +3469,7 @@
                         </a:rPr>
                         <a:t>6379:6379</a:t>
                       </a:r>
-                      <a:endParaRPr lang="en-US" sz="1600" dirty="0">
-                        <a:latin typeface="Arial" charset="0"/>
-                        <a:ea typeface="Arial" charset="0"/>
-                        <a:cs typeface="Arial" charset="0"/>
-                      </a:endParaRPr>
-                    </a:p>
-                  </a:txBody>
-                  <a:tcPr marL="91440" marR="91440" marT="45720" marB="45720" anchor="ctr">
-                    <a:lnL w="12700" cap="flat" cmpd="sng" algn="ctr">
-                      <a:solidFill>
-                        <a:srgbClr val="4A5568"/>
-                      </a:solidFill>
-                      <a:prstDash val="solid"/>
-                      <a:round/>
-                      <a:headEnd type="none" w="med" len="med"/>
-                      <a:tailEnd type="none" w="med" len="med"/>
-                    </a:lnL>
-                    <a:lnR w="12700" cap="flat" cmpd="sng" algn="ctr">
-                      <a:solidFill>
-                        <a:srgbClr val="4A5568"/>
-                      </a:solidFill>
-                      <a:prstDash val="solid"/>
-                      <a:round/>
-                      <a:headEnd type="none" w="med" len="med"/>
-                      <a:tailEnd type="none" w="med" len="med"/>
-                    </a:lnR>
-                    <a:lnT w="12700" cap="flat" cmpd="sng" algn="ctr">
-                      <a:solidFill>
-                        <a:srgbClr val="4A5568"/>
-                      </a:solidFill>
-                      <a:prstDash val="solid"/>
-                      <a:round/>
-                      <a:headEnd type="none" w="med" len="med"/>
-                      <a:tailEnd type="none" w="med" len="med"/>
-                    </a:lnT>
-                    <a:lnB w="12700" cap="flat" cmpd="sng" algn="ctr">
-                      <a:solidFill>
-                        <a:srgbClr val="4A5568"/>
-                      </a:solidFill>
-                      <a:prstDash val="solid"/>
-                      <a:round/>
-                      <a:headEnd type="none" w="med" len="med"/>
-                      <a:tailEnd type="none" w="med" len="med"/>
-                    </a:lnB>
-                    <a:solidFill>
-                      <a:srgbClr val="2C5282"/>
-                    </a:solidFill>
-                  </a:tcPr>
-                </a:tc>
-                <a:tc>
-                  <a:txBody>
-                    <a:bodyPr/>
-                    <a:lstStyle/>
-                    <a:p>
-                      <a:pPr algn="ctr" indent="0" marL="0">
-                        <a:buNone/>
-                      </a:pPr>
-                      <a:r>
-                        <a:rPr lang="en-US" sz="1600" dirty="0">
-                          <a:solidFill>
-                            <a:srgbClr val="E2E8F0"/>
-                          </a:solidFill>
-                          <a:latin typeface="Arial" pitchFamily="34" charset="0"/>
-                          <a:ea typeface="Arial" pitchFamily="34" charset="-122"/>
-                          <a:cs typeface="Arial" pitchFamily="34" charset="-120"/>
-                        </a:rPr>
-                        <a:t>Cache distribué</a:t>
-                      </a:r>
-                      <a:endParaRPr lang="en-US" sz="1600" dirty="0">
+                      <a:endParaRPr lang="en-US" sz="1800" dirty="0">
                         <a:latin typeface="Arial" charset="0"/>
                         <a:ea typeface="Arial" charset="0"/>
                         <a:cs typeface="Arial" charset="0"/>
@@ -3873,7 +3529,7 @@
                         <a:buNone/>
                       </a:pPr>
                       <a:r>
-                        <a:rPr lang="en-US" sz="1600" dirty="0">
+                        <a:rPr lang="en-US" sz="1800" dirty="0">
                           <a:solidFill>
                             <a:srgbClr val="E2E8F0"/>
                           </a:solidFill>
@@ -3883,7 +3539,7 @@
                         </a:rPr>
                         <a:t>Next.js</a:t>
                       </a:r>
-                      <a:endParaRPr lang="en-US" sz="1600" dirty="0">
+                      <a:endParaRPr lang="en-US" sz="1800" dirty="0">
                         <a:latin typeface="Arial" charset="0"/>
                         <a:ea typeface="Arial" charset="0"/>
                         <a:cs typeface="Arial" charset="0"/>
@@ -3941,7 +3597,7 @@
                         <a:buNone/>
                       </a:pPr>
                       <a:r>
-                        <a:rPr lang="en-US" sz="1600" dirty="0">
+                        <a:rPr lang="en-US" sz="1800" dirty="0">
                           <a:solidFill>
                             <a:srgbClr val="E2E8F0"/>
                           </a:solidFill>
@@ -3951,7 +3607,7 @@
                         </a:rPr>
                         <a:t>Dockerfile.dev</a:t>
                       </a:r>
-                      <a:endParaRPr lang="en-US" sz="1600" dirty="0">
+                      <a:endParaRPr lang="en-US" sz="1800" dirty="0">
                         <a:latin typeface="Arial" charset="0"/>
                         <a:ea typeface="Arial" charset="0"/>
                         <a:cs typeface="Arial" charset="0"/>
@@ -4009,7 +3665,7 @@
                         <a:buNone/>
                       </a:pPr>
                       <a:r>
-                        <a:rPr lang="en-US" sz="1600" dirty="0">
+                        <a:rPr lang="en-US" sz="1800" dirty="0">
                           <a:solidFill>
                             <a:srgbClr val="E2E8F0"/>
                           </a:solidFill>
@@ -4019,75 +3675,7 @@
                         </a:rPr>
                         <a:t>3000:3000</a:t>
                       </a:r>
-                      <a:endParaRPr lang="en-US" sz="1600" dirty="0">
-                        <a:latin typeface="Arial" charset="0"/>
-                        <a:ea typeface="Arial" charset="0"/>
-                        <a:cs typeface="Arial" charset="0"/>
-                      </a:endParaRPr>
-                    </a:p>
-                  </a:txBody>
-                  <a:tcPr marL="91440" marR="91440" marT="45720" marB="45720" anchor="ctr">
-                    <a:lnL w="12700" cap="flat" cmpd="sng" algn="ctr">
-                      <a:solidFill>
-                        <a:srgbClr val="4A5568"/>
-                      </a:solidFill>
-                      <a:prstDash val="solid"/>
-                      <a:round/>
-                      <a:headEnd type="none" w="med" len="med"/>
-                      <a:tailEnd type="none" w="med" len="med"/>
-                    </a:lnL>
-                    <a:lnR w="12700" cap="flat" cmpd="sng" algn="ctr">
-                      <a:solidFill>
-                        <a:srgbClr val="4A5568"/>
-                      </a:solidFill>
-                      <a:prstDash val="solid"/>
-                      <a:round/>
-                      <a:headEnd type="none" w="med" len="med"/>
-                      <a:tailEnd type="none" w="med" len="med"/>
-                    </a:lnR>
-                    <a:lnT w="12700" cap="flat" cmpd="sng" algn="ctr">
-                      <a:solidFill>
-                        <a:srgbClr val="4A5568"/>
-                      </a:solidFill>
-                      <a:prstDash val="solid"/>
-                      <a:round/>
-                      <a:headEnd type="none" w="med" len="med"/>
-                      <a:tailEnd type="none" w="med" len="med"/>
-                    </a:lnT>
-                    <a:lnB w="12700" cap="flat" cmpd="sng" algn="ctr">
-                      <a:solidFill>
-                        <a:srgbClr val="4A5568"/>
-                      </a:solidFill>
-                      <a:prstDash val="solid"/>
-                      <a:round/>
-                      <a:headEnd type="none" w="med" len="med"/>
-                      <a:tailEnd type="none" w="med" len="med"/>
-                    </a:lnB>
-                    <a:solidFill>
-                      <a:srgbClr val="2C5282"/>
-                    </a:solidFill>
-                  </a:tcPr>
-                </a:tc>
-                <a:tc>
-                  <a:txBody>
-                    <a:bodyPr/>
-                    <a:lstStyle/>
-                    <a:p>
-                      <a:pPr algn="ctr" indent="0" marL="0">
-                        <a:buNone/>
-                      </a:pPr>
-                      <a:r>
-                        <a:rPr lang="en-US" sz="1600" dirty="0">
-                          <a:solidFill>
-                            <a:srgbClr val="E2E8F0"/>
-                          </a:solidFill>
-                          <a:latin typeface="Arial" pitchFamily="34" charset="0"/>
-                          <a:ea typeface="Arial" pitchFamily="34" charset="-122"/>
-                          <a:cs typeface="Arial" pitchFamily="34" charset="-120"/>
-                        </a:rPr>
-                        <a:t>Application web</a:t>
-                      </a:r>
-                      <a:endParaRPr lang="en-US" sz="1600" dirty="0">
+                      <a:endParaRPr lang="en-US" sz="1800" dirty="0">
                         <a:latin typeface="Arial" charset="0"/>
                         <a:ea typeface="Arial" charset="0"/>
                         <a:cs typeface="Arial" charset="0"/>
@@ -4141,6 +3729,162 @@
           </a:graphicData>
         </a:graphic>
       </p:graphicFrame>
+      <p:sp>
+        <p:nvSpPr>
+          <p:cNvPr id="5" name="Text 2"/>
+          <p:cNvSpPr/>
+          <p:nvPr/>
+        </p:nvSpPr>
+        <p:spPr>
+          <a:xfrm>
+            <a:off x="640080" y="3108960"/>
+            <a:ext cx="7863840" cy="411480"/>
+          </a:xfrm>
+          <a:prstGeom prst="rect">
+            <a:avLst/>
+          </a:prstGeom>
+          <a:noFill/>
+          <a:ln/>
+        </p:spPr>
+        <p:txBody>
+          <a:bodyPr wrap="square" rtlCol="0" anchor="ctr"/>
+          <a:lstStyle/>
+          <a:p>
+            <a:pPr algn="l" indent="0" marL="0">
+              <a:buNone/>
+            </a:pPr>
+            <a:r>
+              <a:rPr lang="en-US" sz="2000" dirty="0">
+                <a:solidFill>
+                  <a:srgbClr val="E2E8F0"/>
+                </a:solidFill>
+                <a:latin typeface="Arial" pitchFamily="34" charset="0"/>
+                <a:ea typeface="Arial" pitchFamily="34" charset="-122"/>
+                <a:cs typeface="Arial" pitchFamily="34" charset="-120"/>
+              </a:rPr>
+              <a:t>Docker Compose pour l'orchestration</a:t>
+            </a:r>
+            <a:endParaRPr lang="en-US" sz="2000" dirty="0"/>
+          </a:p>
+        </p:txBody>
+      </p:sp>
+      <p:sp>
+        <p:nvSpPr>
+          <p:cNvPr id="6" name="Text 3"/>
+          <p:cNvSpPr/>
+          <p:nvPr/>
+        </p:nvSpPr>
+        <p:spPr>
+          <a:xfrm>
+            <a:off x="640080" y="3566160"/>
+            <a:ext cx="7863840" cy="411480"/>
+          </a:xfrm>
+          <a:prstGeom prst="rect">
+            <a:avLst/>
+          </a:prstGeom>
+          <a:noFill/>
+          <a:ln/>
+        </p:spPr>
+        <p:txBody>
+          <a:bodyPr wrap="square" rtlCol="0" anchor="ctr"/>
+          <a:lstStyle/>
+          <a:p>
+            <a:pPr algn="l" indent="0" marL="0">
+              <a:buNone/>
+            </a:pPr>
+            <a:r>
+              <a:rPr lang="en-US" sz="2000" dirty="0">
+                <a:solidFill>
+                  <a:srgbClr val="E2E8F0"/>
+                </a:solidFill>
+                <a:latin typeface="Arial" pitchFamily="34" charset="0"/>
+                <a:ea typeface="Arial" pitchFamily="34" charset="-122"/>
+                <a:cs typeface="Arial" pitchFamily="34" charset="-120"/>
+              </a:rPr>
+              <a:t>Volume persistant redis_data</a:t>
+            </a:r>
+            <a:endParaRPr lang="en-US" sz="2000" dirty="0"/>
+          </a:p>
+        </p:txBody>
+      </p:sp>
+      <p:sp>
+        <p:nvSpPr>
+          <p:cNvPr id="7" name="Text 4"/>
+          <p:cNvSpPr/>
+          <p:nvPr/>
+        </p:nvSpPr>
+        <p:spPr>
+          <a:xfrm>
+            <a:off x="640080" y="4023360"/>
+            <a:ext cx="7863840" cy="411480"/>
+          </a:xfrm>
+          <a:prstGeom prst="rect">
+            <a:avLst/>
+          </a:prstGeom>
+          <a:noFill/>
+          <a:ln/>
+        </p:spPr>
+        <p:txBody>
+          <a:bodyPr wrap="square" rtlCol="0" anchor="ctr"/>
+          <a:lstStyle/>
+          <a:p>
+            <a:pPr algn="l" indent="0" marL="0">
+              <a:buNone/>
+            </a:pPr>
+            <a:r>
+              <a:rPr lang="en-US" sz="2000" dirty="0">
+                <a:solidFill>
+                  <a:srgbClr val="E2E8F0"/>
+                </a:solidFill>
+                <a:latin typeface="Arial" pitchFamily="34" charset="0"/>
+                <a:ea typeface="Arial" pitchFamily="34" charset="-122"/>
+                <a:cs typeface="Arial" pitchFamily="34" charset="-120"/>
+              </a:rPr>
+              <a:t>Healthcheck intégré pour Redis</a:t>
+            </a:r>
+            <a:endParaRPr lang="en-US" sz="2000" dirty="0"/>
+          </a:p>
+        </p:txBody>
+      </p:sp>
+      <p:sp>
+        <p:nvSpPr>
+          <p:cNvPr id="8" name="Text 5"/>
+          <p:cNvSpPr/>
+          <p:nvPr/>
+        </p:nvSpPr>
+        <p:spPr>
+          <a:xfrm>
+            <a:off x="640080" y="4480560"/>
+            <a:ext cx="7863840" cy="411480"/>
+          </a:xfrm>
+          <a:prstGeom prst="rect">
+            <a:avLst/>
+          </a:prstGeom>
+          <a:noFill/>
+          <a:ln/>
+        </p:spPr>
+        <p:txBody>
+          <a:bodyPr wrap="square" rtlCol="0" anchor="ctr"/>
+          <a:lstStyle/>
+          <a:p>
+            <a:pPr algn="l" indent="0" marL="0">
+              <a:buNone/>
+            </a:pPr>
+            <a:r>
+              <a:rPr lang="en-US" sz="2000" dirty="0">
+                <a:solidFill>
+                  <a:srgbClr val="E2E8F0"/>
+                </a:solidFill>
+                <a:latin typeface="Arial" pitchFamily="34" charset="0"/>
+                <a:ea typeface="Arial" pitchFamily="34" charset="-122"/>
+                <a:cs typeface="Arial" pitchFamily="34" charset="-120"/>
+              </a:rPr>
+              <a:t>Variable REDIS_URL pour la connexion</a:t>
+            </a:r>
+            <a:endParaRPr lang="en-US" sz="2000" dirty="0"/>
+          </a:p>
+        </p:txBody>
+      </p:sp>
     </p:spTree>
   </p:cSld>
   <p:clrMapOvr>
@@ -4206,7 +3950,7 @@
                 <a:ea typeface="Arial" pitchFamily="34" charset="-122"/>
                 <a:cs typeface="Arial" pitchFamily="34" charset="-120"/>
               </a:rPr>
-              <a:t>Intégration dans les Actions</a:t>
+              <a:t>Couche d'Abstraction du Cache</a:t>
             </a:r>
             <a:endParaRPr lang="en-US" sz="2800" dirty="0"/>
           </a:p>
@@ -4240,24 +3984,24 @@
         </p:nvSpPr>
         <p:spPr>
           <a:xfrm>
-            <a:off x="457200" y="914400"/>
-            <a:ext cx="8229600" cy="1828800"/>
-          </a:xfrm>
-          <a:prstGeom prst="rect">
-            <a:avLst/>
-          </a:prstGeom>
-          <a:noFill/>
-          <a:ln/>
-        </p:spPr>
-        <p:txBody>
-          <a:bodyPr wrap="square" rtlCol="0" anchor="t"/>
+            <a:off x="640080" y="1005840"/>
+            <a:ext cx="7863840" cy="457200"/>
+          </a:xfrm>
+          <a:prstGeom prst="rect">
+            <a:avLst/>
+          </a:prstGeom>
+          <a:noFill/>
+          <a:ln/>
+        </p:spPr>
+        <p:txBody>
+          <a:bodyPr wrap="square" rtlCol="0" anchor="ctr"/>
           <a:lstStyle/>
           <a:p>
             <a:pPr algn="l" indent="0" marL="0">
               <a:buNone/>
             </a:pPr>
             <a:r>
-              <a:rPr lang="en-US" sz="1800" dirty="0">
+              <a:rPr lang="en-US" sz="2000" dirty="0">
                 <a:solidFill>
                   <a:srgbClr val="E2E8F0"/>
                 </a:solidFill>
@@ -4265,33 +4009,50 @@
                 <a:ea typeface="Arial" pitchFamily="34" charset="-122"/>
                 <a:cs typeface="Arial" pitchFamily="34" charset="-120"/>
               </a:rPr>
-              <a:t>L'integration suit le pattern Cache-Aside. Chaque action genere une cle unique et verifie Redis. Si les donnees existent, elles sont retournees. Sinon, PostgreSQL est interrogee, les resultats sont stockes dans Redis avec un TTL, puis retournes. Cette logique est appliquee sur toutes les lectures frequentes comme getLaunches, getPosts et getCategories.</a:t>
-            </a:r>
-            <a:endParaRPr lang="en-US" sz="1800" dirty="0"/>
-          </a:p>
-        </p:txBody>
-      </p:sp>
-      <p:sp>
-        <p:nvSpPr>
-          <p:cNvPr id="5" name="Shape 3"/>
-          <p:cNvSpPr/>
-          <p:nvPr/>
-        </p:nvSpPr>
-        <p:spPr>
-          <a:xfrm>
-            <a:off x="457200" y="2560320"/>
-            <a:ext cx="8229600" cy="2377440"/>
-          </a:xfrm>
-          <a:prstGeom prst="roundRect">
-            <a:avLst>
-              <a:gd name="adj" fmla="val 1923"/>
-            </a:avLst>
-          </a:prstGeom>
-          <a:solidFill>
-            <a:srgbClr val="0F172A"/>
-          </a:solidFill>
-          <a:ln/>
-        </p:spPr>
+              <a:t>src/lib/cache.ts</a:t>
+            </a:r>
+            <a:endParaRPr lang="en-US" sz="2000" dirty="0"/>
+          </a:p>
+        </p:txBody>
+      </p:sp>
+      <p:sp>
+        <p:nvSpPr>
+          <p:cNvPr id="5" name="Text 3"/>
+          <p:cNvSpPr/>
+          <p:nvPr/>
+        </p:nvSpPr>
+        <p:spPr>
+          <a:xfrm>
+            <a:off x="640080" y="1508760"/>
+            <a:ext cx="7863840" cy="457200"/>
+          </a:xfrm>
+          <a:prstGeom prst="rect">
+            <a:avLst/>
+          </a:prstGeom>
+          <a:noFill/>
+          <a:ln/>
+        </p:spPr>
+        <p:txBody>
+          <a:bodyPr wrap="square" rtlCol="0" anchor="ctr"/>
+          <a:lstStyle/>
+          <a:p>
+            <a:pPr algn="l" indent="0" marL="0">
+              <a:buNone/>
+            </a:pPr>
+            <a:r>
+              <a:rPr lang="en-US" sz="2000" dirty="0">
+                <a:solidFill>
+                  <a:srgbClr val="E2E8F0"/>
+                </a:solidFill>
+                <a:latin typeface="Arial" pitchFamily="34" charset="0"/>
+                <a:ea typeface="Arial" pitchFamily="34" charset="-122"/>
+                <a:cs typeface="Arial" pitchFamily="34" charset="-120"/>
+              </a:rPr>
+              <a:t>cacheGet : récupération avec typage TypeScript</a:t>
+            </a:r>
+            <a:endParaRPr lang="en-US" sz="2000" dirty="0"/>
+          </a:p>
+        </p:txBody>
       </p:sp>
       <p:sp>
         <p:nvSpPr>
@@ -4301,8 +4062,8 @@
         </p:nvSpPr>
         <p:spPr>
           <a:xfrm>
-            <a:off x="640080" y="2651760"/>
-            <a:ext cx="7863840" cy="219456"/>
+            <a:off x="640080" y="2011680"/>
+            <a:ext cx="7863840" cy="457200"/>
           </a:xfrm>
           <a:prstGeom prst="rect">
             <a:avLst/>
@@ -4318,17 +4079,17 @@
               <a:buNone/>
             </a:pPr>
             <a:r>
-              <a:rPr lang="en-US" sz="1400" dirty="0">
-                <a:solidFill>
-                  <a:srgbClr val="63B3ED"/>
-                </a:solidFill>
-                <a:latin typeface="Consolas" pitchFamily="34" charset="0"/>
-                <a:ea typeface="Consolas" pitchFamily="34" charset="-122"/>
-                <a:cs typeface="Consolas" pitchFamily="34" charset="-120"/>
-              </a:rPr>
-              <a:t>export async function getLaunches({ filter, sort, search }) {</a:t>
-            </a:r>
-            <a:endParaRPr lang="en-US" sz="1400" dirty="0"/>
+              <a:rPr lang="en-US" sz="2000" dirty="0">
+                <a:solidFill>
+                  <a:srgbClr val="E2E8F0"/>
+                </a:solidFill>
+                <a:latin typeface="Arial" pitchFamily="34" charset="0"/>
+                <a:ea typeface="Arial" pitchFamily="34" charset="-122"/>
+                <a:cs typeface="Arial" pitchFamily="34" charset="-120"/>
+              </a:rPr>
+              <a:t>cacheSet : stockage avec TTL configurable</a:t>
+            </a:r>
+            <a:endParaRPr lang="en-US" sz="2000" dirty="0"/>
           </a:p>
         </p:txBody>
       </p:sp>
@@ -4340,8 +4101,8 @@
         </p:nvSpPr>
         <p:spPr>
           <a:xfrm>
-            <a:off x="640080" y="2880360"/>
-            <a:ext cx="7863840" cy="219456"/>
+            <a:off x="640080" y="2514600"/>
+            <a:ext cx="7863840" cy="457200"/>
           </a:xfrm>
           <a:prstGeom prst="rect">
             <a:avLst/>
@@ -4357,17 +4118,17 @@
               <a:buNone/>
             </a:pPr>
             <a:r>
-              <a:rPr lang="en-US" sz="1400" dirty="0">
-                <a:solidFill>
-                  <a:srgbClr val="63B3ED"/>
-                </a:solidFill>
-                <a:latin typeface="Consolas" pitchFamily="34" charset="0"/>
-                <a:ea typeface="Consolas" pitchFamily="34" charset="-122"/>
-                <a:cs typeface="Consolas" pitchFamily="34" charset="-120"/>
-              </a:rPr>
-              <a:t>  const cacheKey = buildLaunchesKey(filter, sort, search);</a:t>
-            </a:r>
-            <a:endParaRPr lang="en-US" sz="1400" dirty="0"/>
+              <a:rPr lang="en-US" sz="2000" dirty="0">
+                <a:solidFill>
+                  <a:srgbClr val="E2E8F0"/>
+                </a:solidFill>
+                <a:latin typeface="Arial" pitchFamily="34" charset="0"/>
+                <a:ea typeface="Arial" pitchFamily="34" charset="-122"/>
+                <a:cs typeface="Arial" pitchFamily="34" charset="-120"/>
+              </a:rPr>
+              <a:t>TTL par défaut : 300 secondes</a:t>
+            </a:r>
+            <a:endParaRPr lang="en-US" sz="2000" dirty="0"/>
           </a:p>
         </p:txBody>
       </p:sp>
@@ -4379,8 +4140,8 @@
         </p:nvSpPr>
         <p:spPr>
           <a:xfrm>
-            <a:off x="640080" y="3108960"/>
-            <a:ext cx="7863840" cy="219456"/>
+            <a:off x="640080" y="3017520"/>
+            <a:ext cx="7863840" cy="457200"/>
           </a:xfrm>
           <a:prstGeom prst="rect">
             <a:avLst/>
@@ -4396,212 +4157,17 @@
               <a:buNone/>
             </a:pPr>
             <a:r>
-              <a:rPr lang="en-US" sz="1400" dirty="0">
-                <a:solidFill>
-                  <a:srgbClr val="FBBF24"/>
-                </a:solidFill>
-                <a:latin typeface="Consolas" pitchFamily="34" charset="0"/>
-                <a:ea typeface="Consolas" pitchFamily="34" charset="-122"/>
-                <a:cs typeface="Consolas" pitchFamily="34" charset="-120"/>
-              </a:rPr>
-              <a:t>  const cached = await cacheGet(cacheKey);</a:t>
-            </a:r>
-            <a:endParaRPr lang="en-US" sz="1400" dirty="0"/>
-          </a:p>
-        </p:txBody>
-      </p:sp>
-      <p:sp>
-        <p:nvSpPr>
-          <p:cNvPr id="9" name="Text 7"/>
-          <p:cNvSpPr/>
-          <p:nvPr/>
-        </p:nvSpPr>
-        <p:spPr>
-          <a:xfrm>
-            <a:off x="640080" y="3337560"/>
-            <a:ext cx="7863840" cy="219456"/>
-          </a:xfrm>
-          <a:prstGeom prst="rect">
-            <a:avLst/>
-          </a:prstGeom>
-          <a:noFill/>
-          <a:ln/>
-        </p:spPr>
-        <p:txBody>
-          <a:bodyPr wrap="square" rtlCol="0" anchor="ctr"/>
-          <a:lstStyle/>
-          <a:p>
-            <a:pPr algn="l" indent="0" marL="0">
-              <a:buNone/>
-            </a:pPr>
-            <a:r>
-              <a:rPr lang="en-US" sz="1400" dirty="0">
-                <a:solidFill>
-                  <a:srgbClr val="63B3ED"/>
-                </a:solidFill>
-                <a:latin typeface="Consolas" pitchFamily="34" charset="0"/>
-                <a:ea typeface="Consolas" pitchFamily="34" charset="-122"/>
-                <a:cs typeface="Consolas" pitchFamily="34" charset="-120"/>
-              </a:rPr>
-              <a:t>  if (cached) return cached;</a:t>
-            </a:r>
-            <a:endParaRPr lang="en-US" sz="1400" dirty="0"/>
-          </a:p>
-        </p:txBody>
-      </p:sp>
-      <p:sp>
-        <p:nvSpPr>
-          <p:cNvPr id="10" name="Text 8"/>
-          <p:cNvSpPr/>
-          <p:nvPr/>
-        </p:nvSpPr>
-        <p:spPr>
-          <a:xfrm>
-            <a:off x="640080" y="3566160"/>
-            <a:ext cx="7863840" cy="219456"/>
-          </a:xfrm>
-          <a:prstGeom prst="rect">
-            <a:avLst/>
-          </a:prstGeom>
-          <a:noFill/>
-          <a:ln/>
-        </p:spPr>
-        <p:txBody>
-          <a:bodyPr wrap="square" rtlCol="0" anchor="ctr"/>
-          <a:lstStyle/>
-          <a:p>
-            <a:pPr algn="l" indent="0" marL="0">
-              <a:buNone/>
-            </a:pPr>
-            <a:r>
-              <a:rPr lang="en-US" sz="1400" dirty="0">
-                <a:solidFill>
-                  <a:srgbClr val="63B3ED"/>
-                </a:solidFill>
-                <a:latin typeface="Consolas" pitchFamily="34" charset="0"/>
-                <a:ea typeface="Consolas" pitchFamily="34" charset="-122"/>
-                <a:cs typeface="Consolas" pitchFamily="34" charset="-120"/>
-              </a:rPr>
-              <a:t>  const results = await db.query(...);</a:t>
-            </a:r>
-            <a:endParaRPr lang="en-US" sz="1400" dirty="0"/>
-          </a:p>
-        </p:txBody>
-      </p:sp>
-      <p:sp>
-        <p:nvSpPr>
-          <p:cNvPr id="11" name="Text 9"/>
-          <p:cNvSpPr/>
-          <p:nvPr/>
-        </p:nvSpPr>
-        <p:spPr>
-          <a:xfrm>
-            <a:off x="640080" y="3794760"/>
-            <a:ext cx="7863840" cy="219456"/>
-          </a:xfrm>
-          <a:prstGeom prst="rect">
-            <a:avLst/>
-          </a:prstGeom>
-          <a:noFill/>
-          <a:ln/>
-        </p:spPr>
-        <p:txBody>
-          <a:bodyPr wrap="square" rtlCol="0" anchor="ctr"/>
-          <a:lstStyle/>
-          <a:p>
-            <a:pPr algn="l" indent="0" marL="0">
-              <a:buNone/>
-            </a:pPr>
-            <a:r>
-              <a:rPr lang="en-US" sz="1400" dirty="0">
-                <a:solidFill>
-                  <a:srgbClr val="FBBF24"/>
-                </a:solidFill>
-                <a:latin typeface="Consolas" pitchFamily="34" charset="0"/>
-                <a:ea typeface="Consolas" pitchFamily="34" charset="-122"/>
-                <a:cs typeface="Consolas" pitchFamily="34" charset="-120"/>
-              </a:rPr>
-              <a:t>  await cacheSet(cacheKey, results, 300);</a:t>
-            </a:r>
-            <a:endParaRPr lang="en-US" sz="1400" dirty="0"/>
-          </a:p>
-        </p:txBody>
-      </p:sp>
-      <p:sp>
-        <p:nvSpPr>
-          <p:cNvPr id="12" name="Text 10"/>
-          <p:cNvSpPr/>
-          <p:nvPr/>
-        </p:nvSpPr>
-        <p:spPr>
-          <a:xfrm>
-            <a:off x="640080" y="4023360"/>
-            <a:ext cx="7863840" cy="219456"/>
-          </a:xfrm>
-          <a:prstGeom prst="rect">
-            <a:avLst/>
-          </a:prstGeom>
-          <a:noFill/>
-          <a:ln/>
-        </p:spPr>
-        <p:txBody>
-          <a:bodyPr wrap="square" rtlCol="0" anchor="ctr"/>
-          <a:lstStyle/>
-          <a:p>
-            <a:pPr algn="l" indent="0" marL="0">
-              <a:buNone/>
-            </a:pPr>
-            <a:r>
-              <a:rPr lang="en-US" sz="1400" dirty="0">
-                <a:solidFill>
-                  <a:srgbClr val="63B3ED"/>
-                </a:solidFill>
-                <a:latin typeface="Consolas" pitchFamily="34" charset="0"/>
-                <a:ea typeface="Consolas" pitchFamily="34" charset="-122"/>
-                <a:cs typeface="Consolas" pitchFamily="34" charset="-120"/>
-              </a:rPr>
-              <a:t>  return results;</a:t>
-            </a:r>
-            <a:endParaRPr lang="en-US" sz="1400" dirty="0"/>
-          </a:p>
-        </p:txBody>
-      </p:sp>
-      <p:sp>
-        <p:nvSpPr>
-          <p:cNvPr id="13" name="Text 11"/>
-          <p:cNvSpPr/>
-          <p:nvPr/>
-        </p:nvSpPr>
-        <p:spPr>
-          <a:xfrm>
-            <a:off x="640080" y="4251960"/>
-            <a:ext cx="7863840" cy="219456"/>
-          </a:xfrm>
-          <a:prstGeom prst="rect">
-            <a:avLst/>
-          </a:prstGeom>
-          <a:noFill/>
-          <a:ln/>
-        </p:spPr>
-        <p:txBody>
-          <a:bodyPr wrap="square" rtlCol="0" anchor="ctr"/>
-          <a:lstStyle/>
-          <a:p>
-            <a:pPr algn="l" indent="0" marL="0">
-              <a:buNone/>
-            </a:pPr>
-            <a:r>
-              <a:rPr lang="en-US" sz="1400" dirty="0">
+              <a:rPr lang="en-US" sz="2000" dirty="0">
                 <a:solidFill>
                   <a:srgbClr val="E2E8F0"/>
                 </a:solidFill>
-                <a:latin typeface="Consolas" pitchFamily="34" charset="0"/>
-                <a:ea typeface="Consolas" pitchFamily="34" charset="-122"/>
-                <a:cs typeface="Consolas" pitchFamily="34" charset="-120"/>
-              </a:rPr>
-              <a:t>}</a:t>
-            </a:r>
-            <a:endParaRPr lang="en-US" sz="1400" dirty="0"/>
+                <a:latin typeface="Arial" pitchFamily="34" charset="0"/>
+                <a:ea typeface="Arial" pitchFamily="34" charset="-122"/>
+                <a:cs typeface="Arial" pitchFamily="34" charset="-120"/>
+              </a:rPr>
+              <a:t>Interface simple et réutilisable</a:t>
+            </a:r>
+            <a:endParaRPr lang="en-US" sz="2000" dirty="0"/>
           </a:p>
         </p:txBody>
       </p:sp>
@@ -4670,7 +4236,7 @@
                 <a:ea typeface="Arial" pitchFamily="34" charset="-122"/>
                 <a:cs typeface="Arial" pitchFamily="34" charset="-120"/>
               </a:rPr>
-              <a:t>Invalidation et Tests</a:t>
+              <a:t>Intégration dans les Actions</a:t>
             </a:r>
             <a:endParaRPr lang="en-US" sz="2800" dirty="0"/>
           </a:p>
@@ -4704,24 +4270,24 @@
         </p:nvSpPr>
         <p:spPr>
           <a:xfrm>
-            <a:off x="457200" y="914400"/>
-            <a:ext cx="8229600" cy="1828800"/>
-          </a:xfrm>
-          <a:prstGeom prst="rect">
-            <a:avLst/>
-          </a:prstGeom>
-          <a:noFill/>
-          <a:ln/>
-        </p:spPr>
-        <p:txBody>
-          <a:bodyPr wrap="square" rtlCol="0" anchor="t"/>
+            <a:off x="640080" y="1005840"/>
+            <a:ext cx="7863840" cy="457200"/>
+          </a:xfrm>
+          <a:prstGeom prst="rect">
+            <a:avLst/>
+          </a:prstGeom>
+          <a:noFill/>
+          <a:ln/>
+        </p:spPr>
+        <p:txBody>
+          <a:bodyPr wrap="square" rtlCol="0" anchor="ctr"/>
           <a:lstStyle/>
           <a:p>
             <a:pPr algn="l" indent="0" marL="0">
               <a:buNone/>
             </a:pPr>
             <a:r>
-              <a:rPr lang="en-US" sz="1800" dirty="0">
+              <a:rPr lang="en-US" sz="2000" dirty="0">
                 <a:solidFill>
                   <a:srgbClr val="E2E8F0"/>
                 </a:solidFill>
@@ -4729,33 +4295,50 @@
                 <a:ea typeface="Arial" pitchFamily="34" charset="-122"/>
                 <a:cs typeface="Arial" pitchFamily="34" charset="-120"/>
               </a:rPr>
-              <a:t>L'invalidation est essentielle pour la coherence. Chaque operation d'ecriture invalide immediatement le cache. La fonction invalidateCache supprime les cles correspondantes de Redis. Nous avons egalement mis en place des tests unitaires avec Jest couvrant cacheSet, cacheGet et invalidateCache pour garantir la fiabilite de la couche de cache.</a:t>
-            </a:r>
-            <a:endParaRPr lang="en-US" sz="1800" dirty="0"/>
-          </a:p>
-        </p:txBody>
-      </p:sp>
-      <p:sp>
-        <p:nvSpPr>
-          <p:cNvPr id="5" name="Shape 3"/>
-          <p:cNvSpPr/>
-          <p:nvPr/>
-        </p:nvSpPr>
-        <p:spPr>
-          <a:xfrm>
-            <a:off x="457200" y="2560320"/>
-            <a:ext cx="8229600" cy="2194560"/>
-          </a:xfrm>
-          <a:prstGeom prst="roundRect">
-            <a:avLst>
-              <a:gd name="adj" fmla="val 2083"/>
-            </a:avLst>
-          </a:prstGeom>
-          <a:solidFill>
-            <a:srgbClr val="0F172A"/>
-          </a:solidFill>
-          <a:ln/>
-        </p:spPr>
+              <a:t>1. Génération de clé unique</a:t>
+            </a:r>
+            <a:endParaRPr lang="en-US" sz="2000" dirty="0"/>
+          </a:p>
+        </p:txBody>
+      </p:sp>
+      <p:sp>
+        <p:nvSpPr>
+          <p:cNvPr id="5" name="Text 3"/>
+          <p:cNvSpPr/>
+          <p:nvPr/>
+        </p:nvSpPr>
+        <p:spPr>
+          <a:xfrm>
+            <a:off x="640080" y="1508760"/>
+            <a:ext cx="7863840" cy="457200"/>
+          </a:xfrm>
+          <a:prstGeom prst="rect">
+            <a:avLst/>
+          </a:prstGeom>
+          <a:noFill/>
+          <a:ln/>
+        </p:spPr>
+        <p:txBody>
+          <a:bodyPr wrap="square" rtlCol="0" anchor="ctr"/>
+          <a:lstStyle/>
+          <a:p>
+            <a:pPr algn="l" indent="0" marL="0">
+              <a:buNone/>
+            </a:pPr>
+            <a:r>
+              <a:rPr lang="en-US" sz="2000" dirty="0">
+                <a:solidFill>
+                  <a:srgbClr val="E2E8F0"/>
+                </a:solidFill>
+                <a:latin typeface="Arial" pitchFamily="34" charset="0"/>
+                <a:ea typeface="Arial" pitchFamily="34" charset="-122"/>
+                <a:cs typeface="Arial" pitchFamily="34" charset="-120"/>
+              </a:rPr>
+              <a:t>2. Vérification Redis (Cache Hit?)</a:t>
+            </a:r>
+            <a:endParaRPr lang="en-US" sz="2000" dirty="0"/>
+          </a:p>
+        </p:txBody>
       </p:sp>
       <p:sp>
         <p:nvSpPr>
@@ -4765,8 +4348,8 @@
         </p:nvSpPr>
         <p:spPr>
           <a:xfrm>
-            <a:off x="640080" y="2651760"/>
-            <a:ext cx="7863840" cy="201168"/>
+            <a:off x="640080" y="2011680"/>
+            <a:ext cx="7863840" cy="457200"/>
           </a:xfrm>
           <a:prstGeom prst="rect">
             <a:avLst/>
@@ -4782,17 +4365,17 @@
               <a:buNone/>
             </a:pPr>
             <a:r>
-              <a:rPr lang="en-US" sz="1400" dirty="0">
-                <a:solidFill>
-                  <a:srgbClr val="FBBF24"/>
-                </a:solidFill>
-                <a:latin typeface="Consolas" pitchFamily="34" charset="0"/>
-                <a:ea typeface="Consolas" pitchFamily="34" charset="-122"/>
-                <a:cs typeface="Consolas" pitchFamily="34" charset="-120"/>
-              </a:rPr>
-              <a:t>describe('Cache', () =&gt; {</a:t>
-            </a:r>
-            <a:endParaRPr lang="en-US" sz="1400" dirty="0"/>
+              <a:rPr lang="en-US" sz="2000" dirty="0">
+                <a:solidFill>
+                  <a:srgbClr val="E2E8F0"/>
+                </a:solidFill>
+                <a:latin typeface="Arial" pitchFamily="34" charset="0"/>
+                <a:ea typeface="Arial" pitchFamily="34" charset="-122"/>
+                <a:cs typeface="Arial" pitchFamily="34" charset="-120"/>
+              </a:rPr>
+              <a:t>3. Cache Miss : interrogation PostgreSQL</a:t>
+            </a:r>
+            <a:endParaRPr lang="en-US" sz="2000" dirty="0"/>
           </a:p>
         </p:txBody>
       </p:sp>
@@ -4804,8 +4387,8 @@
         </p:nvSpPr>
         <p:spPr>
           <a:xfrm>
-            <a:off x="640080" y="2852928"/>
-            <a:ext cx="7863840" cy="201168"/>
+            <a:off x="640080" y="2514600"/>
+            <a:ext cx="7863840" cy="457200"/>
           </a:xfrm>
           <a:prstGeom prst="rect">
             <a:avLst/>
@@ -4821,17 +4404,17 @@
               <a:buNone/>
             </a:pPr>
             <a:r>
-              <a:rPr lang="en-US" sz="1400" dirty="0">
-                <a:solidFill>
-                  <a:srgbClr val="FBBF24"/>
-                </a:solidFill>
-                <a:latin typeface="Consolas" pitchFamily="34" charset="0"/>
-                <a:ea typeface="Consolas" pitchFamily="34" charset="-122"/>
-                <a:cs typeface="Consolas" pitchFamily="34" charset="-120"/>
-              </a:rPr>
-              <a:t>  test('set &amp; get', async () =&gt; {</a:t>
-            </a:r>
-            <a:endParaRPr lang="en-US" sz="1400" dirty="0"/>
+              <a:rPr lang="en-US" sz="2000" dirty="0">
+                <a:solidFill>
+                  <a:srgbClr val="E2E8F0"/>
+                </a:solidFill>
+                <a:latin typeface="Arial" pitchFamily="34" charset="0"/>
+                <a:ea typeface="Arial" pitchFamily="34" charset="-122"/>
+                <a:cs typeface="Arial" pitchFamily="34" charset="-120"/>
+              </a:rPr>
+              <a:t>4. Stockage dans Redis avec TTL</a:t>
+            </a:r>
+            <a:endParaRPr lang="en-US" sz="2000" dirty="0"/>
           </a:p>
         </p:txBody>
       </p:sp>
@@ -4843,8 +4426,8 @@
         </p:nvSpPr>
         <p:spPr>
           <a:xfrm>
-            <a:off x="640080" y="3054096"/>
-            <a:ext cx="7863840" cy="201168"/>
+            <a:off x="640080" y="3017520"/>
+            <a:ext cx="7863840" cy="457200"/>
           </a:xfrm>
           <a:prstGeom prst="rect">
             <a:avLst/>
@@ -4860,474 +4443,17 @@
               <a:buNone/>
             </a:pPr>
             <a:r>
-              <a:rPr lang="en-US" sz="1400" dirty="0">
-                <a:solidFill>
-                  <a:srgbClr val="63B3ED"/>
-                </a:solidFill>
-                <a:latin typeface="Consolas" pitchFamily="34" charset="0"/>
-                <a:ea typeface="Consolas" pitchFamily="34" charset="-122"/>
-                <a:cs typeface="Consolas" pitchFamily="34" charset="-120"/>
-              </a:rPr>
-              <a:t>    const data = { foo: 'bar' };</a:t>
-            </a:r>
-            <a:endParaRPr lang="en-US" sz="1400" dirty="0"/>
-          </a:p>
-        </p:txBody>
-      </p:sp>
-      <p:sp>
-        <p:nvSpPr>
-          <p:cNvPr id="9" name="Text 7"/>
-          <p:cNvSpPr/>
-          <p:nvPr/>
-        </p:nvSpPr>
-        <p:spPr>
-          <a:xfrm>
-            <a:off x="640080" y="3255264"/>
-            <a:ext cx="7863840" cy="201168"/>
-          </a:xfrm>
-          <a:prstGeom prst="rect">
-            <a:avLst/>
-          </a:prstGeom>
-          <a:noFill/>
-          <a:ln/>
-        </p:spPr>
-        <p:txBody>
-          <a:bodyPr wrap="square" rtlCol="0" anchor="ctr"/>
-          <a:lstStyle/>
-          <a:p>
-            <a:pPr algn="l" indent="0" marL="0">
-              <a:buNone/>
-            </a:pPr>
-            <a:r>
-              <a:rPr lang="en-US" sz="1400" dirty="0">
-                <a:solidFill>
-                  <a:srgbClr val="63B3ED"/>
-                </a:solidFill>
-                <a:latin typeface="Consolas" pitchFamily="34" charset="0"/>
-                <a:ea typeface="Consolas" pitchFamily="34" charset="-122"/>
-                <a:cs typeface="Consolas" pitchFamily="34" charset="-120"/>
-              </a:rPr>
-              <a:t>    await cacheSet('test', data);</a:t>
-            </a:r>
-            <a:endParaRPr lang="en-US" sz="1400" dirty="0"/>
-          </a:p>
-        </p:txBody>
-      </p:sp>
-      <p:sp>
-        <p:nvSpPr>
-          <p:cNvPr id="10" name="Text 8"/>
-          <p:cNvSpPr/>
-          <p:nvPr/>
-        </p:nvSpPr>
-        <p:spPr>
-          <a:xfrm>
-            <a:off x="640080" y="3456432"/>
-            <a:ext cx="7863840" cy="201168"/>
-          </a:xfrm>
-          <a:prstGeom prst="rect">
-            <a:avLst/>
-          </a:prstGeom>
-          <a:noFill/>
-          <a:ln/>
-        </p:spPr>
-        <p:txBody>
-          <a:bodyPr wrap="square" rtlCol="0" anchor="ctr"/>
-          <a:lstStyle/>
-          <a:p>
-            <a:pPr algn="l" indent="0" marL="0">
-              <a:buNone/>
-            </a:pPr>
-            <a:r>
-              <a:rPr lang="en-US" sz="1400" dirty="0">
-                <a:solidFill>
-                  <a:srgbClr val="63B3ED"/>
-                </a:solidFill>
-                <a:latin typeface="Consolas" pitchFamily="34" charset="0"/>
-                <a:ea typeface="Consolas" pitchFamily="34" charset="-122"/>
-                <a:cs typeface="Consolas" pitchFamily="34" charset="-120"/>
-              </a:rPr>
-              <a:t>    const result = await cacheGet('test');</a:t>
-            </a:r>
-            <a:endParaRPr lang="en-US" sz="1400" dirty="0"/>
-          </a:p>
-        </p:txBody>
-      </p:sp>
-      <p:sp>
-        <p:nvSpPr>
-          <p:cNvPr id="11" name="Text 9"/>
-          <p:cNvSpPr/>
-          <p:nvPr/>
-        </p:nvSpPr>
-        <p:spPr>
-          <a:xfrm>
-            <a:off x="640080" y="3657600"/>
-            <a:ext cx="7863840" cy="201168"/>
-          </a:xfrm>
-          <a:prstGeom prst="rect">
-            <a:avLst/>
-          </a:prstGeom>
-          <a:noFill/>
-          <a:ln/>
-        </p:spPr>
-        <p:txBody>
-          <a:bodyPr wrap="square" rtlCol="0" anchor="ctr"/>
-          <a:lstStyle/>
-          <a:p>
-            <a:pPr algn="l" indent="0" marL="0">
-              <a:buNone/>
-            </a:pPr>
-            <a:r>
-              <a:rPr lang="en-US" sz="1400" dirty="0">
-                <a:solidFill>
-                  <a:srgbClr val="A78BFA"/>
-                </a:solidFill>
-                <a:latin typeface="Consolas" pitchFamily="34" charset="0"/>
-                <a:ea typeface="Consolas" pitchFamily="34" charset="-122"/>
-                <a:cs typeface="Consolas" pitchFamily="34" charset="-120"/>
-              </a:rPr>
-              <a:t>    expect(result).toEqual(data);</a:t>
-            </a:r>
-            <a:endParaRPr lang="en-US" sz="1400" dirty="0"/>
-          </a:p>
-        </p:txBody>
-      </p:sp>
-      <p:sp>
-        <p:nvSpPr>
-          <p:cNvPr id="12" name="Text 10"/>
-          <p:cNvSpPr/>
-          <p:nvPr/>
-        </p:nvSpPr>
-        <p:spPr>
-          <a:xfrm>
-            <a:off x="640080" y="3858768"/>
-            <a:ext cx="7863840" cy="201168"/>
-          </a:xfrm>
-          <a:prstGeom prst="rect">
-            <a:avLst/>
-          </a:prstGeom>
-          <a:noFill/>
-          <a:ln/>
-        </p:spPr>
-        <p:txBody>
-          <a:bodyPr wrap="square" rtlCol="0" anchor="ctr"/>
-          <a:lstStyle/>
-          <a:p>
-            <a:pPr algn="l" indent="0" marL="0">
-              <a:buNone/>
-            </a:pPr>
-            <a:r>
-              <a:rPr lang="en-US" sz="1400" dirty="0">
+              <a:rPr lang="en-US" sz="2000" dirty="0">
                 <a:solidFill>
                   <a:srgbClr val="E2E8F0"/>
                 </a:solidFill>
-                <a:latin typeface="Consolas" pitchFamily="34" charset="0"/>
-                <a:ea typeface="Consolas" pitchFamily="34" charset="-122"/>
-                <a:cs typeface="Consolas" pitchFamily="34" charset="-120"/>
-              </a:rPr>
-              <a:t>  });</a:t>
-            </a:r>
-            <a:endParaRPr lang="en-US" sz="1400" dirty="0"/>
-          </a:p>
-        </p:txBody>
-      </p:sp>
-      <p:sp>
-        <p:nvSpPr>
-          <p:cNvPr id="13" name="Text 11"/>
-          <p:cNvSpPr/>
-          <p:nvPr/>
-        </p:nvSpPr>
-        <p:spPr>
-          <a:xfrm>
-            <a:off x="640080" y="4059936"/>
-            <a:ext cx="7863840" cy="201168"/>
-          </a:xfrm>
-          <a:prstGeom prst="rect">
-            <a:avLst/>
-          </a:prstGeom>
-          <a:noFill/>
-          <a:ln/>
-        </p:spPr>
-        <p:txBody>
-          <a:bodyPr wrap="square" rtlCol="0" anchor="ctr"/>
-          <a:lstStyle/>
-          <a:p>
-            <a:pPr algn="l" indent="0" marL="0">
-              <a:buNone/>
-            </a:pPr>
-            <a:endParaRPr lang="en-US" sz="1400" dirty="0"/>
-          </a:p>
-        </p:txBody>
-      </p:sp>
-      <p:sp>
-        <p:nvSpPr>
-          <p:cNvPr id="14" name="Text 12"/>
-          <p:cNvSpPr/>
-          <p:nvPr/>
-        </p:nvSpPr>
-        <p:spPr>
-          <a:xfrm>
-            <a:off x="640080" y="4261104"/>
-            <a:ext cx="7863840" cy="201168"/>
-          </a:xfrm>
-          <a:prstGeom prst="rect">
-            <a:avLst/>
-          </a:prstGeom>
-          <a:noFill/>
-          <a:ln/>
-        </p:spPr>
-        <p:txBody>
-          <a:bodyPr wrap="square" rtlCol="0" anchor="ctr"/>
-          <a:lstStyle/>
-          <a:p>
-            <a:pPr algn="l" indent="0" marL="0">
-              <a:buNone/>
-            </a:pPr>
-            <a:r>
-              <a:rPr lang="en-US" sz="1400" dirty="0">
-                <a:solidFill>
-                  <a:srgbClr val="FBBF24"/>
-                </a:solidFill>
-                <a:latin typeface="Consolas" pitchFamily="34" charset="0"/>
-                <a:ea typeface="Consolas" pitchFamily="34" charset="-122"/>
-                <a:cs typeface="Consolas" pitchFamily="34" charset="-120"/>
-              </a:rPr>
-              <a:t>  test('invalidation', async () =&gt; {</a:t>
-            </a:r>
-            <a:endParaRPr lang="en-US" sz="1400" dirty="0"/>
-          </a:p>
-        </p:txBody>
-      </p:sp>
-      <p:sp>
-        <p:nvSpPr>
-          <p:cNvPr id="15" name="Text 13"/>
-          <p:cNvSpPr/>
-          <p:nvPr/>
-        </p:nvSpPr>
-        <p:spPr>
-          <a:xfrm>
-            <a:off x="640080" y="4462272"/>
-            <a:ext cx="7863840" cy="201168"/>
-          </a:xfrm>
-          <a:prstGeom prst="rect">
-            <a:avLst/>
-          </a:prstGeom>
-          <a:noFill/>
-          <a:ln/>
-        </p:spPr>
-        <p:txBody>
-          <a:bodyPr wrap="square" rtlCol="0" anchor="ctr"/>
-          <a:lstStyle/>
-          <a:p>
-            <a:pPr algn="l" indent="0" marL="0">
-              <a:buNone/>
-            </a:pPr>
-            <a:r>
-              <a:rPr lang="en-US" sz="1400" dirty="0">
-                <a:solidFill>
-                  <a:srgbClr val="63B3ED"/>
-                </a:solidFill>
-                <a:latin typeface="Consolas" pitchFamily="34" charset="0"/>
-                <a:ea typeface="Consolas" pitchFamily="34" charset="-122"/>
-                <a:cs typeface="Consolas" pitchFamily="34" charset="-120"/>
-              </a:rPr>
-              <a:t>    await cacheSet('temp', 'value');</a:t>
-            </a:r>
-            <a:endParaRPr lang="en-US" sz="1400" dirty="0"/>
-          </a:p>
-        </p:txBody>
-      </p:sp>
-      <p:sp>
-        <p:nvSpPr>
-          <p:cNvPr id="16" name="Text 14"/>
-          <p:cNvSpPr/>
-          <p:nvPr/>
-        </p:nvSpPr>
-        <p:spPr>
-          <a:xfrm>
-            <a:off x="640080" y="4663440"/>
-            <a:ext cx="7863840" cy="201168"/>
-          </a:xfrm>
-          <a:prstGeom prst="rect">
-            <a:avLst/>
-          </a:prstGeom>
-          <a:noFill/>
-          <a:ln/>
-        </p:spPr>
-        <p:txBody>
-          <a:bodyPr wrap="square" rtlCol="0" anchor="ctr"/>
-          <a:lstStyle/>
-          <a:p>
-            <a:pPr algn="l" indent="0" marL="0">
-              <a:buNone/>
-            </a:pPr>
-            <a:r>
-              <a:rPr lang="en-US" sz="1400" dirty="0">
-                <a:solidFill>
-                  <a:srgbClr val="63B3ED"/>
-                </a:solidFill>
-                <a:latin typeface="Consolas" pitchFamily="34" charset="0"/>
-                <a:ea typeface="Consolas" pitchFamily="34" charset="-122"/>
-                <a:cs typeface="Consolas" pitchFamily="34" charset="-120"/>
-              </a:rPr>
-              <a:t>    await invalidateCache('temp');</a:t>
-            </a:r>
-            <a:endParaRPr lang="en-US" sz="1400" dirty="0"/>
-          </a:p>
-        </p:txBody>
-      </p:sp>
-      <p:sp>
-        <p:nvSpPr>
-          <p:cNvPr id="17" name="Text 15"/>
-          <p:cNvSpPr/>
-          <p:nvPr/>
-        </p:nvSpPr>
-        <p:spPr>
-          <a:xfrm>
-            <a:off x="640080" y="4864608"/>
-            <a:ext cx="7863840" cy="201168"/>
-          </a:xfrm>
-          <a:prstGeom prst="rect">
-            <a:avLst/>
-          </a:prstGeom>
-          <a:noFill/>
-          <a:ln/>
-        </p:spPr>
-        <p:txBody>
-          <a:bodyPr wrap="square" rtlCol="0" anchor="ctr"/>
-          <a:lstStyle/>
-          <a:p>
-            <a:pPr algn="l" indent="0" marL="0">
-              <a:buNone/>
-            </a:pPr>
-            <a:r>
-              <a:rPr lang="en-US" sz="1400" dirty="0">
-                <a:solidFill>
-                  <a:srgbClr val="63B3ED"/>
-                </a:solidFill>
-                <a:latin typeface="Consolas" pitchFamily="34" charset="0"/>
-                <a:ea typeface="Consolas" pitchFamily="34" charset="-122"/>
-                <a:cs typeface="Consolas" pitchFamily="34" charset="-120"/>
-              </a:rPr>
-              <a:t>    const result = await cacheGet('temp');</a:t>
-            </a:r>
-            <a:endParaRPr lang="en-US" sz="1400" dirty="0"/>
-          </a:p>
-        </p:txBody>
-      </p:sp>
-      <p:sp>
-        <p:nvSpPr>
-          <p:cNvPr id="18" name="Text 16"/>
-          <p:cNvSpPr/>
-          <p:nvPr/>
-        </p:nvSpPr>
-        <p:spPr>
-          <a:xfrm>
-            <a:off x="640080" y="5065776"/>
-            <a:ext cx="7863840" cy="201168"/>
-          </a:xfrm>
-          <a:prstGeom prst="rect">
-            <a:avLst/>
-          </a:prstGeom>
-          <a:noFill/>
-          <a:ln/>
-        </p:spPr>
-        <p:txBody>
-          <a:bodyPr wrap="square" rtlCol="0" anchor="ctr"/>
-          <a:lstStyle/>
-          <a:p>
-            <a:pPr algn="l" indent="0" marL="0">
-              <a:buNone/>
-            </a:pPr>
-            <a:r>
-              <a:rPr lang="en-US" sz="1400" dirty="0">
-                <a:solidFill>
-                  <a:srgbClr val="A78BFA"/>
-                </a:solidFill>
-                <a:latin typeface="Consolas" pitchFamily="34" charset="0"/>
-                <a:ea typeface="Consolas" pitchFamily="34" charset="-122"/>
-                <a:cs typeface="Consolas" pitchFamily="34" charset="-120"/>
-              </a:rPr>
-              <a:t>    expect(result).toBeNull();</a:t>
-            </a:r>
-            <a:endParaRPr lang="en-US" sz="1400" dirty="0"/>
-          </a:p>
-        </p:txBody>
-      </p:sp>
-      <p:sp>
-        <p:nvSpPr>
-          <p:cNvPr id="19" name="Text 17"/>
-          <p:cNvSpPr/>
-          <p:nvPr/>
-        </p:nvSpPr>
-        <p:spPr>
-          <a:xfrm>
-            <a:off x="640080" y="5266944"/>
-            <a:ext cx="7863840" cy="201168"/>
-          </a:xfrm>
-          <a:prstGeom prst="rect">
-            <a:avLst/>
-          </a:prstGeom>
-          <a:noFill/>
-          <a:ln/>
-        </p:spPr>
-        <p:txBody>
-          <a:bodyPr wrap="square" rtlCol="0" anchor="ctr"/>
-          <a:lstStyle/>
-          <a:p>
-            <a:pPr algn="l" indent="0" marL="0">
-              <a:buNone/>
-            </a:pPr>
-            <a:r>
-              <a:rPr lang="en-US" sz="1400" dirty="0">
-                <a:solidFill>
-                  <a:srgbClr val="E2E8F0"/>
-                </a:solidFill>
-                <a:latin typeface="Consolas" pitchFamily="34" charset="0"/>
-                <a:ea typeface="Consolas" pitchFamily="34" charset="-122"/>
-                <a:cs typeface="Consolas" pitchFamily="34" charset="-120"/>
-              </a:rPr>
-              <a:t>  });</a:t>
-            </a:r>
-            <a:endParaRPr lang="en-US" sz="1400" dirty="0"/>
-          </a:p>
-        </p:txBody>
-      </p:sp>
-      <p:sp>
-        <p:nvSpPr>
-          <p:cNvPr id="20" name="Text 18"/>
-          <p:cNvSpPr/>
-          <p:nvPr/>
-        </p:nvSpPr>
-        <p:spPr>
-          <a:xfrm>
-            <a:off x="640080" y="5468112"/>
-            <a:ext cx="7863840" cy="201168"/>
-          </a:xfrm>
-          <a:prstGeom prst="rect">
-            <a:avLst/>
-          </a:prstGeom>
-          <a:noFill/>
-          <a:ln/>
-        </p:spPr>
-        <p:txBody>
-          <a:bodyPr wrap="square" rtlCol="0" anchor="ctr"/>
-          <a:lstStyle/>
-          <a:p>
-            <a:pPr algn="l" indent="0" marL="0">
-              <a:buNone/>
-            </a:pPr>
-            <a:r>
-              <a:rPr lang="en-US" sz="1400" dirty="0">
-                <a:solidFill>
-                  <a:srgbClr val="E2E8F0"/>
-                </a:solidFill>
-                <a:latin typeface="Consolas" pitchFamily="34" charset="0"/>
-                <a:ea typeface="Consolas" pitchFamily="34" charset="-122"/>
-                <a:cs typeface="Consolas" pitchFamily="34" charset="-120"/>
-              </a:rPr>
-              <a:t>});</a:t>
-            </a:r>
-            <a:endParaRPr lang="en-US" sz="1400" dirty="0"/>
+                <a:latin typeface="Arial" pitchFamily="34" charset="0"/>
+                <a:ea typeface="Arial" pitchFamily="34" charset="-122"/>
+                <a:cs typeface="Arial" pitchFamily="34" charset="-120"/>
+              </a:rPr>
+              <a:t>5. Application sur toutes les lectures</a:t>
+            </a:r>
+            <a:endParaRPr lang="en-US" sz="2000" dirty="0"/>
           </a:p>
         </p:txBody>
       </p:sp>
@@ -5396,7 +4522,7 @@
                 <a:ea typeface="Arial" pitchFamily="34" charset="-122"/>
                 <a:cs typeface="Arial" pitchFamily="34" charset="-120"/>
               </a:rPr>
-              <a:t>Résultats des Tests</a:t>
+              <a:t>Invalidation du Cache</a:t>
             </a:r>
             <a:endParaRPr lang="en-US" sz="2800" dirty="0"/>
           </a:p>
@@ -5430,24 +4556,24 @@
         </p:nvSpPr>
         <p:spPr>
           <a:xfrm>
-            <a:off x="457200" y="914400"/>
-            <a:ext cx="8229600" cy="1645920"/>
-          </a:xfrm>
-          <a:prstGeom prst="rect">
-            <a:avLst/>
-          </a:prstGeom>
-          <a:noFill/>
-          <a:ln/>
-        </p:spPr>
-        <p:txBody>
-          <a:bodyPr wrap="square" rtlCol="0" anchor="t"/>
+            <a:off x="640080" y="1005840"/>
+            <a:ext cx="7863840" cy="457200"/>
+          </a:xfrm>
+          <a:prstGeom prst="rect">
+            <a:avLst/>
+          </a:prstGeom>
+          <a:noFill/>
+          <a:ln/>
+        </p:spPr>
+        <p:txBody>
+          <a:bodyPr wrap="square" rtlCol="0" anchor="ctr"/>
           <a:lstStyle/>
           <a:p>
             <a:pPr algn="l" indent="0" marL="0">
               <a:buNone/>
             </a:pPr>
             <a:r>
-              <a:rPr lang="en-US" sz="1800" dirty="0">
+              <a:rPr lang="en-US" sz="2000" dirty="0">
                 <a:solidFill>
                   <a:srgbClr val="E2E8F0"/>
                 </a:solidFill>
@@ -5455,33 +4581,50 @@
                 <a:ea typeface="Arial" pitchFamily="34" charset="-122"/>
                 <a:cs typeface="Arial" pitchFamily="34" charset="-120"/>
               </a:rPr>
-              <a:t>Les resultats des tests unitaires sont tres satisfaisants. Les huit tests ecrits passent tous avec succes, soit cent pour cent de reussite. Ces tests couvrent les operations de base, l'invalidation, le TTL avec expirations automatiques, et les cas limites comme null ou undefined. Cette couverture complete valide la robustesse de notre implementation Redis.</a:t>
-            </a:r>
-            <a:endParaRPr lang="en-US" sz="1800" dirty="0"/>
-          </a:p>
-        </p:txBody>
-      </p:sp>
-      <p:sp>
-        <p:nvSpPr>
-          <p:cNvPr id="5" name="Shape 3"/>
-          <p:cNvSpPr/>
-          <p:nvPr/>
-        </p:nvSpPr>
-        <p:spPr>
-          <a:xfrm>
-            <a:off x="457200" y="2377440"/>
-            <a:ext cx="8229600" cy="1097280"/>
-          </a:xfrm>
-          <a:prstGeom prst="roundRect">
-            <a:avLst>
-              <a:gd name="adj" fmla="val 8333"/>
-            </a:avLst>
-          </a:prstGeom>
-          <a:solidFill>
-            <a:srgbClr val="059669"/>
-          </a:solidFill>
-          <a:ln/>
-        </p:spPr>
+              <a:t>Create, Update, Delete, Upvote</a:t>
+            </a:r>
+            <a:endParaRPr lang="en-US" sz="2000" dirty="0"/>
+          </a:p>
+        </p:txBody>
+      </p:sp>
+      <p:sp>
+        <p:nvSpPr>
+          <p:cNvPr id="5" name="Text 3"/>
+          <p:cNvSpPr/>
+          <p:nvPr/>
+        </p:nvSpPr>
+        <p:spPr>
+          <a:xfrm>
+            <a:off x="640080" y="1508760"/>
+            <a:ext cx="7863840" cy="457200"/>
+          </a:xfrm>
+          <a:prstGeom prst="rect">
+            <a:avLst/>
+          </a:prstGeom>
+          <a:noFill/>
+          <a:ln/>
+        </p:spPr>
+        <p:txBody>
+          <a:bodyPr wrap="square" rtlCol="0" anchor="ctr"/>
+          <a:lstStyle/>
+          <a:p>
+            <a:pPr algn="l" indent="0" marL="0">
+              <a:buNone/>
+            </a:pPr>
+            <a:r>
+              <a:rPr lang="en-US" sz="2000" dirty="0">
+                <a:solidFill>
+                  <a:srgbClr val="E2E8F0"/>
+                </a:solidFill>
+                <a:latin typeface="Arial" pitchFamily="34" charset="0"/>
+                <a:ea typeface="Arial" pitchFamily="34" charset="-122"/>
+                <a:cs typeface="Arial" pitchFamily="34" charset="-120"/>
+              </a:rPr>
+              <a:t>invalidateCache(cacheKey)</a:t>
+            </a:r>
+            <a:endParaRPr lang="en-US" sz="2000" dirty="0"/>
+          </a:p>
+        </p:txBody>
       </p:sp>
       <p:sp>
         <p:nvSpPr>
@@ -5491,34 +4634,34 @@
         </p:nvSpPr>
         <p:spPr>
           <a:xfrm>
-            <a:off x="457200" y="2468880"/>
-            <a:ext cx="8229600" cy="457200"/>
-          </a:xfrm>
-          <a:prstGeom prst="rect">
-            <a:avLst/>
-          </a:prstGeom>
-          <a:noFill/>
-          <a:ln/>
-        </p:spPr>
-        <p:txBody>
-          <a:bodyPr wrap="square" rtlCol="0" anchor="ctr"/>
-          <a:lstStyle/>
-          <a:p>
-            <a:pPr algn="ctr" indent="0" marL="0">
-              <a:buNone/>
-            </a:pPr>
-            <a:r>
-              <a:rPr lang="en-US" sz="2800" b="1" dirty="0">
-                <a:solidFill>
-                  <a:srgbClr val="FFFFFF"/>
-                </a:solidFill>
-                <a:latin typeface="Arial" pitchFamily="34" charset="0"/>
-                <a:ea typeface="Arial" pitchFamily="34" charset="-122"/>
-                <a:cs typeface="Arial" pitchFamily="34" charset="-120"/>
-              </a:rPr>
-              <a:t>✅ Tous les tests passent avec succès</a:t>
-            </a:r>
-            <a:endParaRPr lang="en-US" sz="2800" dirty="0"/>
+            <a:off x="640080" y="2011680"/>
+            <a:ext cx="7863840" cy="457200"/>
+          </a:xfrm>
+          <a:prstGeom prst="rect">
+            <a:avLst/>
+          </a:prstGeom>
+          <a:noFill/>
+          <a:ln/>
+        </p:spPr>
+        <p:txBody>
+          <a:bodyPr wrap="square" rtlCol="0" anchor="ctr"/>
+          <a:lstStyle/>
+          <a:p>
+            <a:pPr algn="l" indent="0" marL="0">
+              <a:buNone/>
+            </a:pPr>
+            <a:r>
+              <a:rPr lang="en-US" sz="2000" dirty="0">
+                <a:solidFill>
+                  <a:srgbClr val="E2E8F0"/>
+                </a:solidFill>
+                <a:latin typeface="Arial" pitchFamily="34" charset="0"/>
+                <a:ea typeface="Arial" pitchFamily="34" charset="-122"/>
+                <a:cs typeface="Arial" pitchFamily="34" charset="-120"/>
+              </a:rPr>
+              <a:t>TTL comme expiration automatique</a:t>
+            </a:r>
+            <a:endParaRPr lang="en-US" sz="2000" dirty="0"/>
           </a:p>
         </p:txBody>
       </p:sp>
@@ -5530,34 +4673,73 @@
         </p:nvSpPr>
         <p:spPr>
           <a:xfrm>
-            <a:off x="457200" y="2926080"/>
-            <a:ext cx="8229600" cy="365760"/>
-          </a:xfrm>
-          <a:prstGeom prst="rect">
-            <a:avLst/>
-          </a:prstGeom>
-          <a:noFill/>
-          <a:ln/>
-        </p:spPr>
-        <p:txBody>
-          <a:bodyPr wrap="square" rtlCol="0" anchor="ctr"/>
-          <a:lstStyle/>
-          <a:p>
-            <a:pPr algn="ctr" indent="0" marL="0">
-              <a:buNone/>
-            </a:pPr>
-            <a:r>
-              <a:rPr lang="en-US" sz="1800" dirty="0">
-                <a:solidFill>
-                  <a:srgbClr val="FFFFFF"/>
-                </a:solidFill>
-                <a:latin typeface="Arial" pitchFamily="34" charset="0"/>
-                <a:ea typeface="Arial" pitchFamily="34" charset="-122"/>
-                <a:cs typeface="Arial" pitchFamily="34" charset="-120"/>
-              </a:rPr>
-              <a:t>8 tests / 8 passés  -  Couverture : 100%</a:t>
-            </a:r>
-            <a:endParaRPr lang="en-US" sz="1800" dirty="0"/>
+            <a:off x="640080" y="2514600"/>
+            <a:ext cx="7863840" cy="457200"/>
+          </a:xfrm>
+          <a:prstGeom prst="rect">
+            <a:avLst/>
+          </a:prstGeom>
+          <a:noFill/>
+          <a:ln/>
+        </p:spPr>
+        <p:txBody>
+          <a:bodyPr wrap="square" rtlCol="0" anchor="ctr"/>
+          <a:lstStyle/>
+          <a:p>
+            <a:pPr algn="l" indent="0" marL="0">
+              <a:buNone/>
+            </a:pPr>
+            <a:r>
+              <a:rPr lang="en-US" sz="2000" dirty="0">
+                <a:solidFill>
+                  <a:srgbClr val="E2E8F0"/>
+                </a:solidFill>
+                <a:latin typeface="Arial" pitchFamily="34" charset="0"/>
+                <a:ea typeface="Arial" pitchFamily="34" charset="-122"/>
+                <a:cs typeface="Arial" pitchFamily="34" charset="-120"/>
+              </a:rPr>
+              <a:t>Préfixe saas: pour éviter les collisions</a:t>
+            </a:r>
+            <a:endParaRPr lang="en-US" sz="2000" dirty="0"/>
+          </a:p>
+        </p:txBody>
+      </p:sp>
+      <p:sp>
+        <p:nvSpPr>
+          <p:cNvPr id="8" name="Text 6"/>
+          <p:cNvSpPr/>
+          <p:nvPr/>
+        </p:nvSpPr>
+        <p:spPr>
+          <a:xfrm>
+            <a:off x="640080" y="3017520"/>
+            <a:ext cx="7863840" cy="457200"/>
+          </a:xfrm>
+          <a:prstGeom prst="rect">
+            <a:avLst/>
+          </a:prstGeom>
+          <a:noFill/>
+          <a:ln/>
+        </p:spPr>
+        <p:txBody>
+          <a:bodyPr wrap="square" rtlCol="0" anchor="ctr"/>
+          <a:lstStyle/>
+          <a:p>
+            <a:pPr algn="l" indent="0" marL="0">
+              <a:buNone/>
+            </a:pPr>
+            <a:r>
+              <a:rPr lang="en-US" sz="2000" dirty="0">
+                <a:solidFill>
+                  <a:srgbClr val="E2E8F0"/>
+                </a:solidFill>
+                <a:latin typeface="Arial" pitchFamily="34" charset="0"/>
+                <a:ea typeface="Arial" pitchFamily="34" charset="-122"/>
+                <a:cs typeface="Arial" pitchFamily="34" charset="-120"/>
+              </a:rPr>
+              <a:t>Maintien de la cohérence des données</a:t>
+            </a:r>
+            <a:endParaRPr lang="en-US" sz="2000" dirty="0"/>
           </a:p>
         </p:txBody>
       </p:sp>
@@ -5626,7 +4808,7 @@
                 <a:ea typeface="Arial" pitchFamily="34" charset="-122"/>
                 <a:cs typeface="Arial" pitchFamily="34" charset="-120"/>
               </a:rPr>
-              <a:t>Mesures de Performance</a:t>
+              <a:t>Tests et Validation</a:t>
             </a:r>
             <a:endParaRPr lang="en-US" sz="2800" dirty="0"/>
           </a:p>
@@ -5654,53 +4836,14 @@
       </p:sp>
       <p:sp>
         <p:nvSpPr>
-          <p:cNvPr id="4" name="Text 2"/>
-          <p:cNvSpPr/>
-          <p:nvPr/>
-        </p:nvSpPr>
-        <p:spPr>
-          <a:xfrm>
-            <a:off x="457200" y="914400"/>
-            <a:ext cx="8229600" cy="1645920"/>
-          </a:xfrm>
-          <a:prstGeom prst="rect">
-            <a:avLst/>
-          </a:prstGeom>
-          <a:noFill/>
-          <a:ln/>
-        </p:spPr>
-        <p:txBody>
-          <a:bodyPr wrap="square" rtlCol="0" anchor="t"/>
-          <a:lstStyle/>
-          <a:p>
-            <a:pPr algn="l" indent="0" marL="0">
-              <a:buNone/>
-            </a:pPr>
-            <a:r>
-              <a:rPr lang="en-US" sz="1800" dirty="0">
-                <a:solidFill>
-                  <a:srgbClr val="E2E8F0"/>
-                </a:solidFill>
-                <a:latin typeface="Arial" pitchFamily="34" charset="0"/>
-                <a:ea typeface="Arial" pitchFamily="34" charset="-122"/>
-                <a:cs typeface="Arial" pitchFamily="34" charset="-120"/>
-              </a:rPr>
-              <a:t>Les mesures montrent des resultats impressionnants. Avec le cache Redis, le temps de reponse moyen est de douze millisecondes contre huit cent cinquante-six millisecondes sans cache, soit quatre-vingt-dix-neuf pour cent d'amelioration. Les requetes getLaunches passent de plusieurs centaines de millisecondes a moins de quinze millisecondes.</a:t>
-            </a:r>
-            <a:endParaRPr lang="en-US" sz="1800" dirty="0"/>
-          </a:p>
-        </p:txBody>
-      </p:sp>
-      <p:sp>
-        <p:nvSpPr>
-          <p:cNvPr id="5" name="Shape 3"/>
-          <p:cNvSpPr/>
-          <p:nvPr/>
-        </p:nvSpPr>
-        <p:spPr>
-          <a:xfrm>
-            <a:off x="457200" y="2377440"/>
-            <a:ext cx="2560320" cy="914400"/>
+          <p:cNvPr id="4" name="Shape 2"/>
+          <p:cNvSpPr/>
+          <p:nvPr/>
+        </p:nvSpPr>
+        <p:spPr>
+          <a:xfrm>
+            <a:off x="457200" y="1097280"/>
+            <a:ext cx="8229600" cy="914400"/>
           </a:xfrm>
           <a:prstGeom prst="roundRect">
             <a:avLst>
@@ -5708,21 +4851,60 @@
             </a:avLst>
           </a:prstGeom>
           <a:solidFill>
-            <a:srgbClr val="2C5282"/>
+            <a:srgbClr val="059669"/>
           </a:solidFill>
           <a:ln/>
         </p:spPr>
       </p:sp>
       <p:sp>
         <p:nvSpPr>
+          <p:cNvPr id="5" name="Text 3"/>
+          <p:cNvSpPr/>
+          <p:nvPr/>
+        </p:nvSpPr>
+        <p:spPr>
+          <a:xfrm>
+            <a:off x="457200" y="1188720"/>
+            <a:ext cx="8229600" cy="457200"/>
+          </a:xfrm>
+          <a:prstGeom prst="rect">
+            <a:avLst/>
+          </a:prstGeom>
+          <a:noFill/>
+          <a:ln/>
+        </p:spPr>
+        <p:txBody>
+          <a:bodyPr wrap="square" rtlCol="0" anchor="ctr"/>
+          <a:lstStyle/>
+          <a:p>
+            <a:pPr algn="ctr" indent="0" marL="0">
+              <a:buNone/>
+            </a:pPr>
+            <a:r>
+              <a:rPr lang="en-US" sz="3200" b="1" dirty="0">
+                <a:solidFill>
+                  <a:srgbClr val="FFFFFF"/>
+                </a:solidFill>
+                <a:latin typeface="Arial" pitchFamily="34" charset="0"/>
+                <a:ea typeface="Arial" pitchFamily="34" charset="-122"/>
+                <a:cs typeface="Arial" pitchFamily="34" charset="-120"/>
+              </a:rPr>
+              <a:t>✅ 8 tests / 8 passés</a:t>
+            </a:r>
+            <a:endParaRPr lang="en-US" sz="3200" dirty="0"/>
+          </a:p>
+        </p:txBody>
+      </p:sp>
+      <p:sp>
+        <p:nvSpPr>
           <p:cNvPr id="6" name="Text 4"/>
           <p:cNvSpPr/>
           <p:nvPr/>
         </p:nvSpPr>
         <p:spPr>
           <a:xfrm>
-            <a:off x="457200" y="2423160"/>
-            <a:ext cx="2560320" cy="457200"/>
+            <a:off x="457200" y="1645920"/>
+            <a:ext cx="8229600" cy="274320"/>
           </a:xfrm>
           <a:prstGeom prst="rect">
             <a:avLst/>
@@ -5738,17 +4920,17 @@
               <a:buNone/>
             </a:pPr>
             <a:r>
-              <a:rPr lang="en-US" sz="3200" b="1" dirty="0">
-                <a:solidFill>
-                  <a:srgbClr val="63B3ED"/>
-                </a:solidFill>
-                <a:latin typeface="Arial" pitchFamily="34" charset="0"/>
-                <a:ea typeface="Arial" pitchFamily="34" charset="-122"/>
-                <a:cs typeface="Arial" pitchFamily="34" charset="-120"/>
-              </a:rPr>
-              <a:t>12ms</a:t>
-            </a:r>
-            <a:endParaRPr lang="en-US" sz="3200" dirty="0"/>
+              <a:rPr lang="en-US" sz="1600" dirty="0">
+                <a:solidFill>
+                  <a:srgbClr val="FFFFFF"/>
+                </a:solidFill>
+                <a:latin typeface="Arial" pitchFamily="34" charset="0"/>
+                <a:ea typeface="Arial" pitchFamily="34" charset="-122"/>
+                <a:cs typeface="Arial" pitchFamily="34" charset="-120"/>
+              </a:rPr>
+              <a:t>Couverture : cacheGet, cacheSet, invalidate, TTL, edge cases</a:t>
+            </a:r>
+            <a:endParaRPr lang="en-US" sz="1600" dirty="0"/>
           </a:p>
         </p:txBody>
       </p:sp>
@@ -5760,34 +4942,34 @@
         </p:nvSpPr>
         <p:spPr>
           <a:xfrm>
-            <a:off x="457200" y="2926080"/>
-            <a:ext cx="2560320" cy="182880"/>
-          </a:xfrm>
-          <a:prstGeom prst="rect">
-            <a:avLst/>
-          </a:prstGeom>
-          <a:noFill/>
-          <a:ln/>
-        </p:spPr>
-        <p:txBody>
-          <a:bodyPr wrap="square" rtlCol="0" anchor="ctr"/>
-          <a:lstStyle/>
-          <a:p>
-            <a:pPr algn="ctr" indent="0" marL="0">
-              <a:buNone/>
-            </a:pPr>
-            <a:r>
-              <a:rPr lang="en-US" sz="1400" dirty="0">
-                <a:solidFill>
-                  <a:srgbClr val="FFFFFF"/>
-                </a:solidFill>
-                <a:latin typeface="Arial" pitchFamily="34" charset="0"/>
-                <a:ea typeface="Arial" pitchFamily="34" charset="-122"/>
-                <a:cs typeface="Arial" pitchFamily="34" charset="-120"/>
-              </a:rPr>
-              <a:t>Avec Cache</a:t>
-            </a:r>
-            <a:endParaRPr lang="en-US" sz="1400" dirty="0"/>
+            <a:off x="640080" y="2286000"/>
+            <a:ext cx="7863840" cy="457200"/>
+          </a:xfrm>
+          <a:prstGeom prst="rect">
+            <a:avLst/>
+          </a:prstGeom>
+          <a:noFill/>
+          <a:ln/>
+        </p:spPr>
+        <p:txBody>
+          <a:bodyPr wrap="square" rtlCol="0" anchor="ctr"/>
+          <a:lstStyle/>
+          <a:p>
+            <a:pPr algn="l" indent="0" marL="0">
+              <a:buNone/>
+            </a:pPr>
+            <a:r>
+              <a:rPr lang="en-US" sz="2000" dirty="0">
+                <a:solidFill>
+                  <a:srgbClr val="E2E8F0"/>
+                </a:solidFill>
+                <a:latin typeface="Arial" pitchFamily="34" charset="0"/>
+                <a:ea typeface="Arial" pitchFamily="34" charset="-122"/>
+                <a:cs typeface="Arial" pitchFamily="34" charset="-120"/>
+              </a:rPr>
+              <a:t>Tests Jest avec instance Redis locale</a:t>
+            </a:r>
+            <a:endParaRPr lang="en-US" sz="2000" dirty="0"/>
           </a:p>
         </p:txBody>
       </p:sp>
@@ -5799,24 +4981,24 @@
         </p:nvSpPr>
         <p:spPr>
           <a:xfrm>
-            <a:off x="457200" y="3108960"/>
-            <a:ext cx="2560320" cy="182880"/>
-          </a:xfrm>
-          <a:prstGeom prst="rect">
-            <a:avLst/>
-          </a:prstGeom>
-          <a:noFill/>
-          <a:ln/>
-        </p:spPr>
-        <p:txBody>
-          <a:bodyPr wrap="square" rtlCol="0" anchor="ctr"/>
-          <a:lstStyle/>
-          <a:p>
-            <a:pPr algn="ctr" indent="0" marL="0">
-              <a:buNone/>
-            </a:pPr>
-            <a:r>
-              <a:rPr lang="en-US" sz="1200" dirty="0">
+            <a:off x="640080" y="2788920"/>
+            <a:ext cx="7863840" cy="457200"/>
+          </a:xfrm>
+          <a:prstGeom prst="rect">
+            <a:avLst/>
+          </a:prstGeom>
+          <a:noFill/>
+          <a:ln/>
+        </p:spPr>
+        <p:txBody>
+          <a:bodyPr wrap="square" rtlCol="0" anchor="ctr"/>
+          <a:lstStyle/>
+          <a:p>
+            <a:pPr algn="l" indent="0" marL="0">
+              <a:buNone/>
+            </a:pPr>
+            <a:r>
+              <a:rPr lang="en-US" sz="2000" dirty="0">
                 <a:solidFill>
                   <a:srgbClr val="E2E8F0"/>
                 </a:solidFill>
@@ -5824,33 +5006,50 @@
                 <a:ea typeface="Arial" pitchFamily="34" charset="-122"/>
                 <a:cs typeface="Arial" pitchFamily="34" charset="-120"/>
               </a:rPr>
-              <a:t>moyenne</a:t>
-            </a:r>
-            <a:endParaRPr lang="en-US" sz="1200" dirty="0"/>
-          </a:p>
-        </p:txBody>
-      </p:sp>
-      <p:sp>
-        <p:nvSpPr>
-          <p:cNvPr id="9" name="Shape 7"/>
-          <p:cNvSpPr/>
-          <p:nvPr/>
-        </p:nvSpPr>
-        <p:spPr>
-          <a:xfrm>
-            <a:off x="3291840" y="2377440"/>
-            <a:ext cx="2560320" cy="914400"/>
-          </a:xfrm>
-          <a:prstGeom prst="roundRect">
-            <a:avLst>
-              <a:gd name="adj" fmla="val 10000"/>
-            </a:avLst>
-          </a:prstGeom>
-          <a:solidFill>
-            <a:srgbClr val="2C5282"/>
-          </a:solidFill>
-          <a:ln/>
-        </p:spPr>
+              <a:t>Validation du set, get et invalidation</a:t>
+            </a:r>
+            <a:endParaRPr lang="en-US" sz="2000" dirty="0"/>
+          </a:p>
+        </p:txBody>
+      </p:sp>
+      <p:sp>
+        <p:nvSpPr>
+          <p:cNvPr id="9" name="Text 7"/>
+          <p:cNvSpPr/>
+          <p:nvPr/>
+        </p:nvSpPr>
+        <p:spPr>
+          <a:xfrm>
+            <a:off x="640080" y="3291840"/>
+            <a:ext cx="7863840" cy="457200"/>
+          </a:xfrm>
+          <a:prstGeom prst="rect">
+            <a:avLst/>
+          </a:prstGeom>
+          <a:noFill/>
+          <a:ln/>
+        </p:spPr>
+        <p:txBody>
+          <a:bodyPr wrap="square" rtlCol="0" anchor="ctr"/>
+          <a:lstStyle/>
+          <a:p>
+            <a:pPr algn="l" indent="0" marL="0">
+              <a:buNone/>
+            </a:pPr>
+            <a:r>
+              <a:rPr lang="en-US" sz="2000" dirty="0">
+                <a:solidFill>
+                  <a:srgbClr val="E2E8F0"/>
+                </a:solidFill>
+                <a:latin typeface="Arial" pitchFamily="34" charset="0"/>
+                <a:ea typeface="Arial" pitchFamily="34" charset="-122"/>
+                <a:cs typeface="Arial" pitchFamily="34" charset="-120"/>
+              </a:rPr>
+              <a:t>Gestion des cas limites (null, undefined)</a:t>
+            </a:r>
+            <a:endParaRPr lang="en-US" sz="2000" dirty="0"/>
+          </a:p>
+        </p:txBody>
       </p:sp>
       <p:sp>
         <p:nvSpPr>
@@ -5860,102 +5059,24 @@
         </p:nvSpPr>
         <p:spPr>
           <a:xfrm>
-            <a:off x="3291840" y="2423160"/>
-            <a:ext cx="2560320" cy="457200"/>
-          </a:xfrm>
-          <a:prstGeom prst="rect">
-            <a:avLst/>
-          </a:prstGeom>
-          <a:noFill/>
-          <a:ln/>
-        </p:spPr>
-        <p:txBody>
-          <a:bodyPr wrap="square" rtlCol="0" anchor="ctr"/>
-          <a:lstStyle/>
-          <a:p>
-            <a:pPr algn="ctr" indent="0" marL="0">
-              <a:buNone/>
-            </a:pPr>
-            <a:r>
-              <a:rPr lang="en-US" sz="3200" b="1" dirty="0">
-                <a:solidFill>
-                  <a:srgbClr val="63B3ED"/>
-                </a:solidFill>
-                <a:latin typeface="Arial" pitchFamily="34" charset="0"/>
-                <a:ea typeface="Arial" pitchFamily="34" charset="-122"/>
-                <a:cs typeface="Arial" pitchFamily="34" charset="-120"/>
-              </a:rPr>
-              <a:t>856ms</a:t>
-            </a:r>
-            <a:endParaRPr lang="en-US" sz="3200" dirty="0"/>
-          </a:p>
-        </p:txBody>
-      </p:sp>
-      <p:sp>
-        <p:nvSpPr>
-          <p:cNvPr id="11" name="Text 9"/>
-          <p:cNvSpPr/>
-          <p:nvPr/>
-        </p:nvSpPr>
-        <p:spPr>
-          <a:xfrm>
-            <a:off x="3291840" y="2926080"/>
-            <a:ext cx="2560320" cy="182880"/>
-          </a:xfrm>
-          <a:prstGeom prst="rect">
-            <a:avLst/>
-          </a:prstGeom>
-          <a:noFill/>
-          <a:ln/>
-        </p:spPr>
-        <p:txBody>
-          <a:bodyPr wrap="square" rtlCol="0" anchor="ctr"/>
-          <a:lstStyle/>
-          <a:p>
-            <a:pPr algn="ctr" indent="0" marL="0">
-              <a:buNone/>
-            </a:pPr>
-            <a:r>
-              <a:rPr lang="en-US" sz="1400" dirty="0">
-                <a:solidFill>
-                  <a:srgbClr val="FFFFFF"/>
-                </a:solidFill>
-                <a:latin typeface="Arial" pitchFamily="34" charset="0"/>
-                <a:ea typeface="Arial" pitchFamily="34" charset="-122"/>
-                <a:cs typeface="Arial" pitchFamily="34" charset="-120"/>
-              </a:rPr>
-              <a:t>Sans Cache</a:t>
-            </a:r>
-            <a:endParaRPr lang="en-US" sz="1400" dirty="0"/>
-          </a:p>
-        </p:txBody>
-      </p:sp>
-      <p:sp>
-        <p:nvSpPr>
-          <p:cNvPr id="12" name="Text 10"/>
-          <p:cNvSpPr/>
-          <p:nvPr/>
-        </p:nvSpPr>
-        <p:spPr>
-          <a:xfrm>
-            <a:off x="3291840" y="3108960"/>
-            <a:ext cx="2560320" cy="182880"/>
-          </a:xfrm>
-          <a:prstGeom prst="rect">
-            <a:avLst/>
-          </a:prstGeom>
-          <a:noFill/>
-          <a:ln/>
-        </p:spPr>
-        <p:txBody>
-          <a:bodyPr wrap="square" rtlCol="0" anchor="ctr"/>
-          <a:lstStyle/>
-          <a:p>
-            <a:pPr algn="ctr" indent="0" marL="0">
-              <a:buNone/>
-            </a:pPr>
-            <a:r>
-              <a:rPr lang="en-US" sz="1200" dirty="0">
+            <a:off x="640080" y="3794760"/>
+            <a:ext cx="7863840" cy="457200"/>
+          </a:xfrm>
+          <a:prstGeom prst="rect">
+            <a:avLst/>
+          </a:prstGeom>
+          <a:noFill/>
+          <a:ln/>
+        </p:spPr>
+        <p:txBody>
+          <a:bodyPr wrap="square" rtlCol="0" anchor="ctr"/>
+          <a:lstStyle/>
+          <a:p>
+            <a:pPr algn="l" indent="0" marL="0">
+              <a:buNone/>
+            </a:pPr>
+            <a:r>
+              <a:rPr lang="en-US" sz="2000" dirty="0">
                 <a:solidFill>
                   <a:srgbClr val="E2E8F0"/>
                 </a:solidFill>
@@ -5963,148 +5084,9 @@
                 <a:ea typeface="Arial" pitchFamily="34" charset="-122"/>
                 <a:cs typeface="Arial" pitchFamily="34" charset="-120"/>
               </a:rPr>
-              <a:t>moyenne</a:t>
-            </a:r>
-            <a:endParaRPr lang="en-US" sz="1200" dirty="0"/>
-          </a:p>
-        </p:txBody>
-      </p:sp>
-      <p:sp>
-        <p:nvSpPr>
-          <p:cNvPr id="13" name="Shape 11"/>
-          <p:cNvSpPr/>
-          <p:nvPr/>
-        </p:nvSpPr>
-        <p:spPr>
-          <a:xfrm>
-            <a:off x="6126480" y="2377440"/>
-            <a:ext cx="2560320" cy="914400"/>
-          </a:xfrm>
-          <a:prstGeom prst="roundRect">
-            <a:avLst>
-              <a:gd name="adj" fmla="val 10000"/>
-            </a:avLst>
-          </a:prstGeom>
-          <a:solidFill>
-            <a:srgbClr val="2C5282"/>
-          </a:solidFill>
-          <a:ln/>
-        </p:spPr>
-      </p:sp>
-      <p:sp>
-        <p:nvSpPr>
-          <p:cNvPr id="14" name="Text 12"/>
-          <p:cNvSpPr/>
-          <p:nvPr/>
-        </p:nvSpPr>
-        <p:spPr>
-          <a:xfrm>
-            <a:off x="6126480" y="2423160"/>
-            <a:ext cx="2560320" cy="457200"/>
-          </a:xfrm>
-          <a:prstGeom prst="rect">
-            <a:avLst/>
-          </a:prstGeom>
-          <a:noFill/>
-          <a:ln/>
-        </p:spPr>
-        <p:txBody>
-          <a:bodyPr wrap="square" rtlCol="0" anchor="ctr"/>
-          <a:lstStyle/>
-          <a:p>
-            <a:pPr algn="ctr" indent="0" marL="0">
-              <a:buNone/>
-            </a:pPr>
-            <a:r>
-              <a:rPr lang="en-US" sz="3200" b="1" dirty="0">
-                <a:solidFill>
-                  <a:srgbClr val="63B3ED"/>
-                </a:solidFill>
-                <a:latin typeface="Arial" pitchFamily="34" charset="0"/>
-                <a:ea typeface="Arial" pitchFamily="34" charset="-122"/>
-                <a:cs typeface="Arial" pitchFamily="34" charset="-120"/>
-              </a:rPr>
-              <a:t>99%</a:t>
-            </a:r>
-            <a:endParaRPr lang="en-US" sz="3200" dirty="0"/>
-          </a:p>
-        </p:txBody>
-      </p:sp>
-      <p:sp>
-        <p:nvSpPr>
-          <p:cNvPr id="15" name="Text 13"/>
-          <p:cNvSpPr/>
-          <p:nvPr/>
-        </p:nvSpPr>
-        <p:spPr>
-          <a:xfrm>
-            <a:off x="6126480" y="2926080"/>
-            <a:ext cx="2560320" cy="182880"/>
-          </a:xfrm>
-          <a:prstGeom prst="rect">
-            <a:avLst/>
-          </a:prstGeom>
-          <a:noFill/>
-          <a:ln/>
-        </p:spPr>
-        <p:txBody>
-          <a:bodyPr wrap="square" rtlCol="0" anchor="ctr"/>
-          <a:lstStyle/>
-          <a:p>
-            <a:pPr algn="ctr" indent="0" marL="0">
-              <a:buNone/>
-            </a:pPr>
-            <a:r>
-              <a:rPr lang="en-US" sz="1400" dirty="0">
-                <a:solidFill>
-                  <a:srgbClr val="FFFFFF"/>
-                </a:solidFill>
-                <a:latin typeface="Arial" pitchFamily="34" charset="0"/>
-                <a:ea typeface="Arial" pitchFamily="34" charset="-122"/>
-                <a:cs typeface="Arial" pitchFamily="34" charset="-120"/>
-              </a:rPr>
-              <a:t>Amélioration</a:t>
-            </a:r>
-            <a:endParaRPr lang="en-US" sz="1400" dirty="0"/>
-          </a:p>
-        </p:txBody>
-      </p:sp>
-      <p:sp>
-        <p:nvSpPr>
-          <p:cNvPr id="16" name="Text 14"/>
-          <p:cNvSpPr/>
-          <p:nvPr/>
-        </p:nvSpPr>
-        <p:spPr>
-          <a:xfrm>
-            <a:off x="6126480" y="3108960"/>
-            <a:ext cx="2560320" cy="182880"/>
-          </a:xfrm>
-          <a:prstGeom prst="rect">
-            <a:avLst/>
-          </a:prstGeom>
-          <a:noFill/>
-          <a:ln/>
-        </p:spPr>
-        <p:txBody>
-          <a:bodyPr wrap="square" rtlCol="0" anchor="ctr"/>
-          <a:lstStyle/>
-          <a:p>
-            <a:pPr algn="ctr" indent="0" marL="0">
-              <a:buNone/>
-            </a:pPr>
-            <a:r>
-              <a:rPr lang="en-US" sz="1200" dirty="0">
-                <a:solidFill>
-                  <a:srgbClr val="E2E8F0"/>
-                </a:solidFill>
-                <a:latin typeface="Arial" pitchFamily="34" charset="0"/>
-                <a:ea typeface="Arial" pitchFamily="34" charset="-122"/>
-                <a:cs typeface="Arial" pitchFamily="34" charset="-120"/>
-              </a:rPr>
-              <a:t>plus rapide</a:t>
-            </a:r>
-            <a:endParaRPr lang="en-US" sz="1200" dirty="0"/>
+              <a:t>Tests executes dans la pipeline CI</a:t>
+            </a:r>
+            <a:endParaRPr lang="en-US" sz="2000" dirty="0"/>
           </a:p>
         </p:txBody>
       </p:sp>
@@ -6173,7 +5155,7 @@
                 <a:ea typeface="Arial" pitchFamily="34" charset="-122"/>
                 <a:cs typeface="Arial" pitchFamily="34" charset="-120"/>
               </a:rPr>
-              <a:t>Conclusion et Perspectives</a:t>
+              <a:t>Résultats de Performance</a:t>
             </a:r>
             <a:endParaRPr lang="en-US" sz="2800" dirty="0"/>
           </a:p>
@@ -6201,30 +5183,330 @@
       </p:sp>
       <p:sp>
         <p:nvSpPr>
-          <p:cNvPr id="4" name="Text 2"/>
-          <p:cNvSpPr/>
-          <p:nvPr/>
-        </p:nvSpPr>
-        <p:spPr>
-          <a:xfrm>
-            <a:off x="457200" y="914400"/>
-            <a:ext cx="8229600" cy="1828800"/>
-          </a:xfrm>
-          <a:prstGeom prst="rect">
-            <a:avLst/>
-          </a:prstGeom>
-          <a:noFill/>
-          <a:ln/>
-        </p:spPr>
-        <p:txBody>
-          <a:bodyPr wrap="square" rtlCol="0" anchor="t"/>
+          <p:cNvPr id="4" name="Shape 2"/>
+          <p:cNvSpPr/>
+          <p:nvPr/>
+        </p:nvSpPr>
+        <p:spPr>
+          <a:xfrm>
+            <a:off x="457200" y="1097280"/>
+            <a:ext cx="2560320" cy="914400"/>
+          </a:xfrm>
+          <a:prstGeom prst="roundRect">
+            <a:avLst>
+              <a:gd name="adj" fmla="val 10000"/>
+            </a:avLst>
+          </a:prstGeom>
+          <a:solidFill>
+            <a:srgbClr val="2C5282"/>
+          </a:solidFill>
+          <a:ln/>
+        </p:spPr>
+      </p:sp>
+      <p:sp>
+        <p:nvSpPr>
+          <p:cNvPr id="5" name="Text 3"/>
+          <p:cNvSpPr/>
+          <p:nvPr/>
+        </p:nvSpPr>
+        <p:spPr>
+          <a:xfrm>
+            <a:off x="457200" y="1143000"/>
+            <a:ext cx="2560320" cy="457200"/>
+          </a:xfrm>
+          <a:prstGeom prst="rect">
+            <a:avLst/>
+          </a:prstGeom>
+          <a:noFill/>
+          <a:ln/>
+        </p:spPr>
+        <p:txBody>
+          <a:bodyPr wrap="square" rtlCol="0" anchor="ctr"/>
+          <a:lstStyle/>
+          <a:p>
+            <a:pPr algn="ctr" indent="0" marL="0">
+              <a:buNone/>
+            </a:pPr>
+            <a:r>
+              <a:rPr lang="en-US" sz="3600" b="1" dirty="0">
+                <a:solidFill>
+                  <a:srgbClr val="63B3ED"/>
+                </a:solidFill>
+                <a:latin typeface="Arial" pitchFamily="34" charset="0"/>
+                <a:ea typeface="Arial" pitchFamily="34" charset="-122"/>
+                <a:cs typeface="Arial" pitchFamily="34" charset="-120"/>
+              </a:rPr>
+              <a:t>12ms</a:t>
+            </a:r>
+            <a:endParaRPr lang="en-US" sz="3600" dirty="0"/>
+          </a:p>
+        </p:txBody>
+      </p:sp>
+      <p:sp>
+        <p:nvSpPr>
+          <p:cNvPr id="6" name="Text 4"/>
+          <p:cNvSpPr/>
+          <p:nvPr/>
+        </p:nvSpPr>
+        <p:spPr>
+          <a:xfrm>
+            <a:off x="457200" y="1645920"/>
+            <a:ext cx="2560320" cy="274320"/>
+          </a:xfrm>
+          <a:prstGeom prst="rect">
+            <a:avLst/>
+          </a:prstGeom>
+          <a:noFill/>
+          <a:ln/>
+        </p:spPr>
+        <p:txBody>
+          <a:bodyPr wrap="square" rtlCol="0" anchor="ctr"/>
+          <a:lstStyle/>
+          <a:p>
+            <a:pPr algn="ctr" indent="0" marL="0">
+              <a:buNone/>
+            </a:pPr>
+            <a:r>
+              <a:rPr lang="en-US" sz="1600" dirty="0">
+                <a:solidFill>
+                  <a:srgbClr val="FFFFFF"/>
+                </a:solidFill>
+                <a:latin typeface="Arial" pitchFamily="34" charset="0"/>
+                <a:ea typeface="Arial" pitchFamily="34" charset="-122"/>
+                <a:cs typeface="Arial" pitchFamily="34" charset="-120"/>
+              </a:rPr>
+              <a:t>Avec Cache</a:t>
+            </a:r>
+            <a:endParaRPr lang="en-US" sz="1600" dirty="0"/>
+          </a:p>
+        </p:txBody>
+      </p:sp>
+      <p:sp>
+        <p:nvSpPr>
+          <p:cNvPr id="7" name="Shape 5"/>
+          <p:cNvSpPr/>
+          <p:nvPr/>
+        </p:nvSpPr>
+        <p:spPr>
+          <a:xfrm>
+            <a:off x="3291840" y="1097280"/>
+            <a:ext cx="2560320" cy="914400"/>
+          </a:xfrm>
+          <a:prstGeom prst="roundRect">
+            <a:avLst>
+              <a:gd name="adj" fmla="val 10000"/>
+            </a:avLst>
+          </a:prstGeom>
+          <a:solidFill>
+            <a:srgbClr val="2C5282"/>
+          </a:solidFill>
+          <a:ln/>
+        </p:spPr>
+      </p:sp>
+      <p:sp>
+        <p:nvSpPr>
+          <p:cNvPr id="8" name="Text 6"/>
+          <p:cNvSpPr/>
+          <p:nvPr/>
+        </p:nvSpPr>
+        <p:spPr>
+          <a:xfrm>
+            <a:off x="3291840" y="1143000"/>
+            <a:ext cx="2560320" cy="457200"/>
+          </a:xfrm>
+          <a:prstGeom prst="rect">
+            <a:avLst/>
+          </a:prstGeom>
+          <a:noFill/>
+          <a:ln/>
+        </p:spPr>
+        <p:txBody>
+          <a:bodyPr wrap="square" rtlCol="0" anchor="ctr"/>
+          <a:lstStyle/>
+          <a:p>
+            <a:pPr algn="ctr" indent="0" marL="0">
+              <a:buNone/>
+            </a:pPr>
+            <a:r>
+              <a:rPr lang="en-US" sz="3600" b="1" dirty="0">
+                <a:solidFill>
+                  <a:srgbClr val="63B3ED"/>
+                </a:solidFill>
+                <a:latin typeface="Arial" pitchFamily="34" charset="0"/>
+                <a:ea typeface="Arial" pitchFamily="34" charset="-122"/>
+                <a:cs typeface="Arial" pitchFamily="34" charset="-120"/>
+              </a:rPr>
+              <a:t>856ms</a:t>
+            </a:r>
+            <a:endParaRPr lang="en-US" sz="3600" dirty="0"/>
+          </a:p>
+        </p:txBody>
+      </p:sp>
+      <p:sp>
+        <p:nvSpPr>
+          <p:cNvPr id="9" name="Text 7"/>
+          <p:cNvSpPr/>
+          <p:nvPr/>
+        </p:nvSpPr>
+        <p:spPr>
+          <a:xfrm>
+            <a:off x="3291840" y="1645920"/>
+            <a:ext cx="2560320" cy="274320"/>
+          </a:xfrm>
+          <a:prstGeom prst="rect">
+            <a:avLst/>
+          </a:prstGeom>
+          <a:noFill/>
+          <a:ln/>
+        </p:spPr>
+        <p:txBody>
+          <a:bodyPr wrap="square" rtlCol="0" anchor="ctr"/>
+          <a:lstStyle/>
+          <a:p>
+            <a:pPr algn="ctr" indent="0" marL="0">
+              <a:buNone/>
+            </a:pPr>
+            <a:r>
+              <a:rPr lang="en-US" sz="1600" dirty="0">
+                <a:solidFill>
+                  <a:srgbClr val="FFFFFF"/>
+                </a:solidFill>
+                <a:latin typeface="Arial" pitchFamily="34" charset="0"/>
+                <a:ea typeface="Arial" pitchFamily="34" charset="-122"/>
+                <a:cs typeface="Arial" pitchFamily="34" charset="-120"/>
+              </a:rPr>
+              <a:t>Sans Cache</a:t>
+            </a:r>
+            <a:endParaRPr lang="en-US" sz="1600" dirty="0"/>
+          </a:p>
+        </p:txBody>
+      </p:sp>
+      <p:sp>
+        <p:nvSpPr>
+          <p:cNvPr id="10" name="Shape 8"/>
+          <p:cNvSpPr/>
+          <p:nvPr/>
+        </p:nvSpPr>
+        <p:spPr>
+          <a:xfrm>
+            <a:off x="6126480" y="1097280"/>
+            <a:ext cx="2560320" cy="914400"/>
+          </a:xfrm>
+          <a:prstGeom prst="roundRect">
+            <a:avLst>
+              <a:gd name="adj" fmla="val 10000"/>
+            </a:avLst>
+          </a:prstGeom>
+          <a:solidFill>
+            <a:srgbClr val="2C5282"/>
+          </a:solidFill>
+          <a:ln/>
+        </p:spPr>
+      </p:sp>
+      <p:sp>
+        <p:nvSpPr>
+          <p:cNvPr id="11" name="Text 9"/>
+          <p:cNvSpPr/>
+          <p:nvPr/>
+        </p:nvSpPr>
+        <p:spPr>
+          <a:xfrm>
+            <a:off x="6126480" y="1143000"/>
+            <a:ext cx="2560320" cy="457200"/>
+          </a:xfrm>
+          <a:prstGeom prst="rect">
+            <a:avLst/>
+          </a:prstGeom>
+          <a:noFill/>
+          <a:ln/>
+        </p:spPr>
+        <p:txBody>
+          <a:bodyPr wrap="square" rtlCol="0" anchor="ctr"/>
+          <a:lstStyle/>
+          <a:p>
+            <a:pPr algn="ctr" indent="0" marL="0">
+              <a:buNone/>
+            </a:pPr>
+            <a:r>
+              <a:rPr lang="en-US" sz="3600" b="1" dirty="0">
+                <a:solidFill>
+                  <a:srgbClr val="63B3ED"/>
+                </a:solidFill>
+                <a:latin typeface="Arial" pitchFamily="34" charset="0"/>
+                <a:ea typeface="Arial" pitchFamily="34" charset="-122"/>
+                <a:cs typeface="Arial" pitchFamily="34" charset="-120"/>
+              </a:rPr>
+              <a:t>99%</a:t>
+            </a:r>
+            <a:endParaRPr lang="en-US" sz="3600" dirty="0"/>
+          </a:p>
+        </p:txBody>
+      </p:sp>
+      <p:sp>
+        <p:nvSpPr>
+          <p:cNvPr id="12" name="Text 10"/>
+          <p:cNvSpPr/>
+          <p:nvPr/>
+        </p:nvSpPr>
+        <p:spPr>
+          <a:xfrm>
+            <a:off x="6126480" y="1645920"/>
+            <a:ext cx="2560320" cy="274320"/>
+          </a:xfrm>
+          <a:prstGeom prst="rect">
+            <a:avLst/>
+          </a:prstGeom>
+          <a:noFill/>
+          <a:ln/>
+        </p:spPr>
+        <p:txBody>
+          <a:bodyPr wrap="square" rtlCol="0" anchor="ctr"/>
+          <a:lstStyle/>
+          <a:p>
+            <a:pPr algn="ctr" indent="0" marL="0">
+              <a:buNone/>
+            </a:pPr>
+            <a:r>
+              <a:rPr lang="en-US" sz="1600" dirty="0">
+                <a:solidFill>
+                  <a:srgbClr val="FFFFFF"/>
+                </a:solidFill>
+                <a:latin typeface="Arial" pitchFamily="34" charset="0"/>
+                <a:ea typeface="Arial" pitchFamily="34" charset="-122"/>
+                <a:cs typeface="Arial" pitchFamily="34" charset="-120"/>
+              </a:rPr>
+              <a:t>Amélioration</a:t>
+            </a:r>
+            <a:endParaRPr lang="en-US" sz="1600" dirty="0"/>
+          </a:p>
+        </p:txBody>
+      </p:sp>
+      <p:sp>
+        <p:nvSpPr>
+          <p:cNvPr id="13" name="Text 11"/>
+          <p:cNvSpPr/>
+          <p:nvPr/>
+        </p:nvSpPr>
+        <p:spPr>
+          <a:xfrm>
+            <a:off x="640080" y="2286000"/>
+            <a:ext cx="7863840" cy="457200"/>
+          </a:xfrm>
+          <a:prstGeom prst="rect">
+            <a:avLst/>
+          </a:prstGeom>
+          <a:noFill/>
+          <a:ln/>
+        </p:spPr>
+        <p:txBody>
+          <a:bodyPr wrap="square" rtlCol="0" anchor="ctr"/>
           <a:lstStyle/>
           <a:p>
             <a:pPr algn="l" indent="0" marL="0">
               <a:buNone/>
             </a:pPr>
             <a:r>
-              <a:rPr lang="en-US" sz="1800" dirty="0">
+              <a:rPr lang="en-US" sz="2000" dirty="0">
                 <a:solidFill>
                   <a:srgbClr val="E2E8F0"/>
                 </a:solidFill>
@@ -6232,22 +5514,22 @@
                 <a:ea typeface="Arial" pitchFamily="34" charset="-122"/>
                 <a:cs typeface="Arial" pitchFamily="34" charset="-120"/>
               </a:rPr>
-              <a:t>En conclusion, tous les objectifs ont ete atteints. Le temps de reponse moyen a ete reduit de quatre-vingt-dix-neuf pour cent. La charge sur PostgreSQL a diminue de quatre-vingt-cinq pour cent. Les huit tests unitaires passent tous. Pour l'avenir, nous envisageons un cluster Redis avec replication, un cache LRU local, du cache warming, et un dashboard de monitoring.</a:t>
-            </a:r>
-            <a:endParaRPr lang="en-US" sz="1800" dirty="0"/>
-          </a:p>
-        </p:txBody>
-      </p:sp>
-      <p:sp>
-        <p:nvSpPr>
-          <p:cNvPr id="5" name="Text 3"/>
-          <p:cNvSpPr/>
-          <p:nvPr/>
-        </p:nvSpPr>
-        <p:spPr>
-          <a:xfrm>
-            <a:off x="640080" y="2743200"/>
-            <a:ext cx="7863840" cy="320040"/>
+              <a:t>getLaunches : 856ms → 12ms (99.2%)</a:t>
+            </a:r>
+            <a:endParaRPr lang="en-US" sz="2000" dirty="0"/>
+          </a:p>
+        </p:txBody>
+      </p:sp>
+      <p:sp>
+        <p:nvSpPr>
+          <p:cNvPr id="14" name="Text 12"/>
+          <p:cNvSpPr/>
+          <p:nvPr/>
+        </p:nvSpPr>
+        <p:spPr>
+          <a:xfrm>
+            <a:off x="640080" y="2788920"/>
+            <a:ext cx="7863840" cy="457200"/>
           </a:xfrm>
           <a:prstGeom prst="rect">
             <a:avLst/>
@@ -6263,7 +5545,7 @@
               <a:buNone/>
             </a:pPr>
             <a:r>
-              <a:rPr lang="en-US" sz="1800" dirty="0">
+              <a:rPr lang="en-US" sz="2000" dirty="0">
                 <a:solidFill>
                   <a:srgbClr val="E2E8F0"/>
                 </a:solidFill>
@@ -6271,22 +5553,22 @@
                 <a:ea typeface="Arial" pitchFamily="34" charset="-122"/>
                 <a:cs typeface="Arial" pitchFamily="34" charset="-120"/>
               </a:rPr>
-              <a:t>Temps de réponse réduit de 99%</a:t>
-            </a:r>
-            <a:endParaRPr lang="en-US" sz="1800" dirty="0"/>
-          </a:p>
-        </p:txBody>
-      </p:sp>
-      <p:sp>
-        <p:nvSpPr>
-          <p:cNvPr id="6" name="Text 4"/>
-          <p:cNvSpPr/>
-          <p:nvPr/>
-        </p:nvSpPr>
-        <p:spPr>
-          <a:xfrm>
-            <a:off x="640080" y="3108960"/>
-            <a:ext cx="7863840" cy="320040"/>
+              <a:t>getPosts : 643ms → 15ms (97.7%)</a:t>
+            </a:r>
+            <a:endParaRPr lang="en-US" sz="2000" dirty="0"/>
+          </a:p>
+        </p:txBody>
+      </p:sp>
+      <p:sp>
+        <p:nvSpPr>
+          <p:cNvPr id="15" name="Text 13"/>
+          <p:cNvSpPr/>
+          <p:nvPr/>
+        </p:nvSpPr>
+        <p:spPr>
+          <a:xfrm>
+            <a:off x="640080" y="3291840"/>
+            <a:ext cx="7863840" cy="457200"/>
           </a:xfrm>
           <a:prstGeom prst="rect">
             <a:avLst/>
@@ -6302,7 +5584,7 @@
               <a:buNone/>
             </a:pPr>
             <a:r>
-              <a:rPr lang="en-US" sz="1800" dirty="0">
+              <a:rPr lang="en-US" sz="2000" dirty="0">
                 <a:solidFill>
                   <a:srgbClr val="E2E8F0"/>
                 </a:solidFill>
@@ -6310,22 +5592,22 @@
                 <a:ea typeface="Arial" pitchFamily="34" charset="-122"/>
                 <a:cs typeface="Arial" pitchFamily="34" charset="-120"/>
               </a:rPr>
-              <a:t>Charge sur PostgreSQL diminuée de 85%</a:t>
-            </a:r>
-            <a:endParaRPr lang="en-US" sz="1800" dirty="0"/>
-          </a:p>
-        </p:txBody>
-      </p:sp>
-      <p:sp>
-        <p:nvSpPr>
-          <p:cNvPr id="7" name="Text 5"/>
-          <p:cNvSpPr/>
-          <p:nvPr/>
-        </p:nvSpPr>
-        <p:spPr>
-          <a:xfrm>
-            <a:off x="640080" y="3474720"/>
-            <a:ext cx="7863840" cy="320040"/>
+              <a:t>getLaunchBySlug : 234ms → 8ms (96.6%)</a:t>
+            </a:r>
+            <a:endParaRPr lang="en-US" sz="2000" dirty="0"/>
+          </a:p>
+        </p:txBody>
+      </p:sp>
+      <p:sp>
+        <p:nvSpPr>
+          <p:cNvPr id="16" name="Text 14"/>
+          <p:cNvSpPr/>
+          <p:nvPr/>
+        </p:nvSpPr>
+        <p:spPr>
+          <a:xfrm>
+            <a:off x="640080" y="3794760"/>
+            <a:ext cx="7863840" cy="457200"/>
           </a:xfrm>
           <a:prstGeom prst="rect">
             <a:avLst/>
@@ -6341,7 +5623,7 @@
               <a:buNone/>
             </a:pPr>
             <a:r>
-              <a:rPr lang="en-US" sz="1800" dirty="0">
+              <a:rPr lang="en-US" sz="2000" dirty="0">
                 <a:solidFill>
                   <a:srgbClr val="E2E8F0"/>
                 </a:solidFill>
@@ -6349,126 +5631,9 @@
                 <a:ea typeface="Arial" pitchFamily="34" charset="-122"/>
                 <a:cs typeface="Arial" pitchFamily="34" charset="-120"/>
               </a:rPr>
-              <a:t>Tests unitaires : 100% de réussite</a:t>
-            </a:r>
-            <a:endParaRPr lang="en-US" sz="1800" dirty="0"/>
-          </a:p>
-        </p:txBody>
-      </p:sp>
-      <p:sp>
-        <p:nvSpPr>
-          <p:cNvPr id="8" name="Text 6"/>
-          <p:cNvSpPr/>
-          <p:nvPr/>
-        </p:nvSpPr>
-        <p:spPr>
-          <a:xfrm>
-            <a:off x="640080" y="3840480"/>
-            <a:ext cx="7863840" cy="320040"/>
-          </a:xfrm>
-          <a:prstGeom prst="rect">
-            <a:avLst/>
-          </a:prstGeom>
-          <a:noFill/>
-          <a:ln/>
-        </p:spPr>
-        <p:txBody>
-          <a:bodyPr wrap="square" rtlCol="0" anchor="ctr"/>
-          <a:lstStyle/>
-          <a:p>
-            <a:pPr algn="l" indent="0" marL="0">
-              <a:buNone/>
-            </a:pPr>
-            <a:r>
-              <a:rPr lang="en-US" sz="1800" dirty="0">
-                <a:solidFill>
-                  <a:srgbClr val="E2E8F0"/>
-                </a:solidFill>
-                <a:latin typeface="Arial" pitchFamily="34" charset="0"/>
-                <a:ea typeface="Arial" pitchFamily="34" charset="-122"/>
-                <a:cs typeface="Arial" pitchFamily="34" charset="-120"/>
-              </a:rPr>
-              <a:t>Cluster Redis avec réplication</a:t>
-            </a:r>
-            <a:endParaRPr lang="en-US" sz="1800" dirty="0"/>
-          </a:p>
-        </p:txBody>
-      </p:sp>
-      <p:sp>
-        <p:nvSpPr>
-          <p:cNvPr id="9" name="Text 7"/>
-          <p:cNvSpPr/>
-          <p:nvPr/>
-        </p:nvSpPr>
-        <p:spPr>
-          <a:xfrm>
-            <a:off x="640080" y="4206240"/>
-            <a:ext cx="7863840" cy="320040"/>
-          </a:xfrm>
-          <a:prstGeom prst="rect">
-            <a:avLst/>
-          </a:prstGeom>
-          <a:noFill/>
-          <a:ln/>
-        </p:spPr>
-        <p:txBody>
-          <a:bodyPr wrap="square" rtlCol="0" anchor="ctr"/>
-          <a:lstStyle/>
-          <a:p>
-            <a:pPr algn="l" indent="0" marL="0">
-              <a:buNone/>
-            </a:pPr>
-            <a:r>
-              <a:rPr lang="en-US" sz="1800" dirty="0">
-                <a:solidFill>
-                  <a:srgbClr val="E2E8F0"/>
-                </a:solidFill>
-                <a:latin typeface="Arial" pitchFamily="34" charset="0"/>
-                <a:ea typeface="Arial" pitchFamily="34" charset="-122"/>
-                <a:cs typeface="Arial" pitchFamily="34" charset="-120"/>
-              </a:rPr>
-              <a:t>Cache LRU local et cache warming</a:t>
-            </a:r>
-            <a:endParaRPr lang="en-US" sz="1800" dirty="0"/>
-          </a:p>
-        </p:txBody>
-      </p:sp>
-      <p:sp>
-        <p:nvSpPr>
-          <p:cNvPr id="10" name="Text 8"/>
-          <p:cNvSpPr/>
-          <p:nvPr/>
-        </p:nvSpPr>
-        <p:spPr>
-          <a:xfrm>
-            <a:off x="640080" y="4572000"/>
-            <a:ext cx="7863840" cy="320040"/>
-          </a:xfrm>
-          <a:prstGeom prst="rect">
-            <a:avLst/>
-          </a:prstGeom>
-          <a:noFill/>
-          <a:ln/>
-        </p:spPr>
-        <p:txBody>
-          <a:bodyPr wrap="square" rtlCol="0" anchor="ctr"/>
-          <a:lstStyle/>
-          <a:p>
-            <a:pPr algn="l" indent="0" marL="0">
-              <a:buNone/>
-            </a:pPr>
-            <a:r>
-              <a:rPr lang="en-US" sz="1800" dirty="0">
-                <a:solidFill>
-                  <a:srgbClr val="E2E8F0"/>
-                </a:solidFill>
-                <a:latin typeface="Arial" pitchFamily="34" charset="0"/>
-                <a:ea typeface="Arial" pitchFamily="34" charset="-122"/>
-                <a:cs typeface="Arial" pitchFamily="34" charset="-120"/>
-              </a:rPr>
-              <a:t>Dashboard de monitoring</a:t>
-            </a:r>
-            <a:endParaRPr lang="en-US" sz="1800" dirty="0"/>
+              <a:t>getCategories : 189ms → 5ms (97.4%)</a:t>
+            </a:r>
+            <a:endParaRPr lang="en-US" sz="2000" dirty="0"/>
           </a:p>
         </p:txBody>
       </p:sp>

</xml_diff>